<commit_message>
docs: reframe classifier as retrospective prototype; evidence-of-absence-safe language
Codex round 5, all findings fixed:
- High: 24h classifier framed everywhere as a retrospective ranking
  prototype among eventually-funded loans (negative class = funded but
  not within 24h; expired/withdrawn listings absent) with the explicit
  path to a real early-warning pilot; never 'pilot the risk flag'
- Moderate: 'defensible standard' / 'appropriate few-cluster bar' /
  'trustworthy nulls' replaced with no-robust-evidence language; Slide 3
  retitled 'How we stress-tested our findings'
- Low: HC3 backup no longer claims a universal strictness ordering
- pptx generator promoted to committed script (scripts/build_slides_draft.py)
  and deck regenerated; affected PDFs re-rendered; 114 tests pass

Co-Authored-By: Claude Fable 5 <noreply@anthropic.com>
</commit_message>
<xml_diff>
--- a/docs/presentation/slides_draft.pptx
+++ b/docs/presentation/slides_draft.pptx
@@ -931,7 +931,7 @@
           <a:lstStyle/>
           <a:p>
             <a:r>
-              <a:t>Now the question we came to answer — and the honest answer is that nothing about the narrative survives our own scrutiny. Urgency language looked like a clean, universal win: significant at p&lt;0.001. Cluster by country, and it collapses to p≈0.44. Gone. Family framing — here our own first version got it wrong: we tested whether regions differ from Africa, which is not the same as whether family framing helps WITHIN a region. Corrected, two pooled categories — Palestine+Yemen, and Honduras+Nicaragua — do show faster funding in every fit we ran. But each rests on exactly two countries, and against the appropriate few-cluster bar — a t distribution with one degree of freedom, where the critical value is 12.7, not 1.96 — neither is significant: p between 0.06 and 0.21. So we report it as a hypothesis worth testing, not a finding. Sentiment tone: more positive language associates with SLOWER funding, but its significance flips between our two specifications — we call it open. We'd rather show you three trustworthy nulls than one exciting result we can't defend.</a:t>
+              <a:t>Now the question we came to answer — and the honest answer is that nothing about the narrative survives our own scrutiny. Urgency language looked like a clean, universal win: significant at p&lt;0.001. Cluster by country, and it collapses to p≈0.44. Gone. Family framing — here our own first version got it wrong: we tested whether regions differ from Africa, which is not the same as whether family framing helps WITHIN a region. Corrected, two pooled categories — Palestine+Yemen, and Honduras+Nicaragua — do show faster funding in every fit we ran. But each rests on exactly two countries, and against a deliberately harsh few-cluster screen — a t distribution with one degree of freedom, where the critical value is 12.7, not 1.96 — neither is significant: p between 0.06 and 0.21. So we report it as a hypothesis worth testing, not a finding. Sentiment tone: more positive language associates with SLOWER funding, but its significance flips between our two specifications — we call it open. We'd rather report no robust evidence than one exciting result we can't defend.</a:t>
             </a:r>
           </a:p>
         </p:txBody>
@@ -1071,7 +1071,7 @@
           <a:lstStyle/>
           <a:p>
             <a:r>
-              <a:t>So what should Kiva actually do? Three things. First — don't ship writing tips. A platform-wide 'add urgency' nudge would be built on a result that doesn't survive testing. The family-framing pattern deserves a country-stratified A/B test in exactly those four markets: that's how a hypothesis becomes a decision, and it's cheap to run. Second — the structural gaps are where the real levers are: review how the consistently slower sectors and regions are surfaced, bundled, and supported, because those gaps are ten times the size of any wording effect. Third — speed itself is predictable: our classifier ranks same-day funding at AUC 0.90 on strictly future data, without any framing features. That's strong enough to pilot an early-warning flag for loans likely to stall — pilot, with calibration, capacity and fairness checks, not a blind rollout.</a:t>
+              <a:t>So what should Kiva actually do? Three things. First — don't ship writing tips. A platform-wide 'add urgency' nudge would be built on a result that doesn't survive testing. The family-framing pattern deserves a country-stratified A/B test in exactly those four markets: that's how a hypothesis becomes a decision, and it's cheap to run. Second — the structural gaps are where the real levers are: review how the consistently slower sectors and regions are surfaced, bundled, and supported, because those gaps are ten times the size of any wording effect. Third — speed is predictable in retrospect: among loans that eventually funded, our classifier ranks same-day funding at AUC 0.90 on strictly future data, without any framing features. One honest boundary: expired or withdrawn listings never enter this data, so that is a ranking prototype among eventual funders — not yet an early-warning system. To build one, Kiva should pull all posted listings including expired and withdrawn outcomes, define the operational target, and retrain and validate on that population — before any pilot.</a:t>
             </a:r>
           </a:p>
         </p:txBody>
@@ -4739,7 +4739,7 @@
         <p:spPr>
           <a:xfrm>
             <a:off x="685800" y="1783080"/>
-            <a:ext cx="10881360" cy="4617720"/>
+            <a:ext cx="11064240" cy="4526280"/>
           </a:xfrm>
           <a:prstGeom prst="rect">
             <a:avLst/>
@@ -5020,7 +5020,7 @@
               </a:defRPr>
             </a:pPr>
             <a:r>
-              <a:t>How we made sure findings are real</a:t>
+              <a:t>How we stress-tested our findings</a:t>
             </a:r>
           </a:p>
         </p:txBody>
@@ -5078,7 +5078,7 @@
         <p:spPr>
           <a:xfrm>
             <a:off x="685800" y="1783080"/>
-            <a:ext cx="7498079" cy="4617720"/>
+            <a:ext cx="7498079" cy="4526280"/>
           </a:xfrm>
           <a:prstGeom prst="rect">
             <a:avLst/>
@@ -5143,7 +5143,7 @@
                 </a:solidFill>
                 <a:latin typeface="Avenir Next"/>
               </a:rPr>
-              <a:t>Framing claims: every ‘significant’ result re-tested with country-clustered standard errors, then a harsher few-cluster reference where a result rests on a handful of countries.</a:t>
+              <a:t>Framing claims: every 'significant' result re-tested with country-clustered standard errors, then a harsher few-cluster reference where a result rests on a handful of countries.</a:t>
             </a:r>
           </a:p>
           <a:p>
@@ -5212,8 +5212,8 @@
         </p:nvSpPr>
         <p:spPr>
           <a:xfrm>
-            <a:off x="8458200" y="1783080"/>
-            <a:ext cx="3108960" cy="4206240"/>
+            <a:off x="8412480" y="1783080"/>
+            <a:ext cx="3200400" cy="4206240"/>
           </a:xfrm>
           <a:prstGeom prst="roundRect">
             <a:avLst/>
@@ -5519,7 +5519,7 @@
         <p:spPr>
           <a:xfrm>
             <a:off x="685800" y="1783080"/>
-            <a:ext cx="10972800" cy="914400"/>
+            <a:ext cx="11064240" cy="914400"/>
           </a:xfrm>
           <a:prstGeom prst="rect">
             <a:avLst/>
@@ -5541,7 +5541,7 @@
               </a:defRPr>
             </a:pPr>
             <a:r>
-              <a:t>46%  →  30%  →  30%  </a:t>
+              <a:t>46% → 30% → 30%  </a:t>
             </a:r>
             <a:r>
               <a:rPr sz="1600" b="0">
@@ -5564,7 +5564,7 @@
         <p:spPr>
           <a:xfrm>
             <a:off x="685800" y="2834639"/>
-            <a:ext cx="7498079" cy="3566160"/>
+            <a:ext cx="7498079" cy="3474720"/>
           </a:xfrm>
           <a:prstGeom prst="rect">
             <a:avLst/>
@@ -5670,8 +5670,8 @@
         </p:nvSpPr>
         <p:spPr>
           <a:xfrm>
-            <a:off x="8458200" y="2834639"/>
-            <a:ext cx="3108960" cy="3154680"/>
+            <a:off x="8412480" y="2834639"/>
+            <a:ext cx="3200400" cy="3154680"/>
           </a:xfrm>
           <a:prstGeom prst="roundRect">
             <a:avLst/>
@@ -5977,7 +5977,7 @@
         <p:spPr>
           <a:xfrm>
             <a:off x="685800" y="1783080"/>
-            <a:ext cx="10972800" cy="914400"/>
+            <a:ext cx="11064240" cy="914400"/>
           </a:xfrm>
           <a:prstGeom prst="rect">
             <a:avLst/>
@@ -6022,7 +6022,7 @@
         <p:spPr>
           <a:xfrm>
             <a:off x="685800" y="2834639"/>
-            <a:ext cx="7498079" cy="3566160"/>
+            <a:ext cx="7498079" cy="3474720"/>
           </a:xfrm>
           <a:prstGeom prst="rect">
             <a:avLst/>
@@ -6059,7 +6059,7 @@
                 </a:solidFill>
                 <a:latin typeface="Avenir Next"/>
               </a:rPr>
-              <a:t>Loan amount + repayment terms: linked to funding speed ~10× more strongly than any single narrative choice.</a:t>
+              <a:t>Loan amount + repayment terms: linked to funding speed ~10x more strongly than any single narrative choice.</a:t>
             </a:r>
           </a:p>
           <a:p>
@@ -6128,8 +6128,8 @@
         </p:nvSpPr>
         <p:spPr>
           <a:xfrm>
-            <a:off x="8458200" y="2834639"/>
-            <a:ext cx="3108960" cy="3154680"/>
+            <a:off x="8412480" y="2834639"/>
+            <a:ext cx="3200400" cy="3154680"/>
           </a:xfrm>
           <a:prstGeom prst="roundRect">
             <a:avLst/>
@@ -6435,7 +6435,7 @@
         <p:spPr>
           <a:xfrm>
             <a:off x="685800" y="1783080"/>
-            <a:ext cx="10972800" cy="914400"/>
+            <a:ext cx="11064240" cy="914400"/>
           </a:xfrm>
           <a:prstGeom prst="rect">
             <a:avLst/>
@@ -6457,7 +6457,7 @@
               </a:defRPr>
             </a:pPr>
             <a:r>
-              <a:t>Zero  </a:t>
+              <a:t>No narrative result  </a:t>
             </a:r>
             <a:r>
               <a:rPr sz="1600" b="0">
@@ -6466,7 +6466,7 @@
                 </a:solidFill>
                 <a:latin typeface="Avenir Next"/>
               </a:rPr>
-              <a:t>narrative-framing results survive a defensible standard</a:t>
+              <a:t>is robust enough to support a recommendation</a:t>
             </a:r>
           </a:p>
         </p:txBody>
@@ -6480,7 +6480,7 @@
         <p:spPr>
           <a:xfrm>
             <a:off x="685800" y="2834639"/>
-            <a:ext cx="7498079" cy="3566160"/>
+            <a:ext cx="7498079" cy="3474720"/>
           </a:xfrm>
           <a:prstGeom prst="rect">
             <a:avLst/>
@@ -6545,7 +6545,7 @@
                 </a:solidFill>
                 <a:latin typeface="Avenir Next"/>
               </a:rPr>
-              <a:t>Family: corrected test → Middle East (Palestine+Yemen) &amp; Central America (Honduras+Nicaragua) same direction in every fit — but 2 countries each; few-cluster t(1) bar is 12.7, not 1.96: p≈0.06–0.21. A hypothesis, not a finding.</a:t>
+              <a:t>Family: corrected test → Middle East (Palestine+Yemen) &amp; Central America (Honduras+Nicaragua) same direction in every fit — but 2 countries each; few-cluster t(1) screen bar is 12.7, not 1.96: p≈0.06–0.21. A hypothesis, not a finding.</a:t>
             </a:r>
           </a:p>
           <a:p>
@@ -6573,7 +6573,7 @@
                 </a:solidFill>
                 <a:latin typeface="Avenir Next"/>
               </a:rPr>
-              <a:t>Sentiment: positive tone ↔ slower funding, but significance flips between specifications — genuinely open.</a:t>
+              <a:t>Sentiment: positive tone &lt;-&gt; slower funding, but significance flips between specifications — genuinely open.</a:t>
             </a:r>
           </a:p>
           <a:p>
@@ -6614,8 +6614,8 @@
         </p:nvSpPr>
         <p:spPr>
           <a:xfrm>
-            <a:off x="8458200" y="2834639"/>
-            <a:ext cx="3108960" cy="3154680"/>
+            <a:off x="8412480" y="2834639"/>
+            <a:ext cx="3200400" cy="3154680"/>
           </a:xfrm>
           <a:prstGeom prst="roundRect">
             <a:avLst/>
@@ -6921,7 +6921,7 @@
         <p:spPr>
           <a:xfrm>
             <a:off x="685800" y="1783080"/>
-            <a:ext cx="10972800" cy="914400"/>
+            <a:ext cx="11064240" cy="914400"/>
           </a:xfrm>
           <a:prstGeom prst="rect">
             <a:avLst/>
@@ -6952,7 +6952,7 @@
                 </a:solidFill>
                 <a:latin typeface="Avenir Next"/>
               </a:rPr>
-              <a:t>across story topics — a &gt;9× swing</a:t>
+              <a:t>across story topics — a &gt;9x swing</a:t>
             </a:r>
           </a:p>
         </p:txBody>
@@ -6966,7 +6966,7 @@
         <p:spPr>
           <a:xfrm>
             <a:off x="685800" y="2834639"/>
-            <a:ext cx="7498079" cy="3566160"/>
+            <a:ext cx="7498079" cy="3474720"/>
           </a:xfrm>
           <a:prstGeom prst="rect">
             <a:avLst/>
@@ -7044,8 +7044,8 @@
         </p:nvSpPr>
         <p:spPr>
           <a:xfrm>
-            <a:off x="8458200" y="2834639"/>
-            <a:ext cx="3108960" cy="3154680"/>
+            <a:off x="8412480" y="2834639"/>
+            <a:ext cx="3200400" cy="3154680"/>
           </a:xfrm>
           <a:prstGeom prst="roundRect">
             <a:avLst/>
@@ -7351,7 +7351,7 @@
         <p:spPr>
           <a:xfrm>
             <a:off x="685800" y="1783080"/>
-            <a:ext cx="10881360" cy="4617720"/>
+            <a:ext cx="11064240" cy="4526280"/>
           </a:xfrm>
           <a:prstGeom prst="rect">
             <a:avLst/>
@@ -7388,7 +7388,7 @@
                 </a:solidFill>
                 <a:latin typeface="Avenir Next"/>
               </a:rPr>
-              <a:t>DON'T ship writing tips — a platform-wide ‘add urgency’ nudge would be built on a result that doesn't survive testing.</a:t>
+              <a:t>DON'T ship writing tips — a platform-wide 'add urgency' nudge would be built on a result that doesn't survive testing.</a:t>
             </a:r>
           </a:p>
           <a:p>
@@ -7444,7 +7444,7 @@
                 </a:solidFill>
                 <a:latin typeface="Avenir Next"/>
               </a:rPr>
-              <a:t>DO review the structural gaps (sector / region / gender) — they are ~10× the size of any wording effect.</a:t>
+              <a:t>DO review the structural gaps (sector / region / gender) — they are ~10x the size of any wording effect.</a:t>
             </a:r>
           </a:p>
           <a:p>
@@ -7472,7 +7472,7 @@
                 </a:solidFill>
                 <a:latin typeface="Avenir Next"/>
               </a:rPr>
-              <a:t>PILOT a same-day-funding risk flag: holdout ROC AUC ≈ 0.90 on strictly future data — with calibration, capacity and fairness checks first.</a:t>
+              <a:t>PROTOTYPE, then re-validate: the 24h classifier ranks well among eventually-funded loans (AUC ≈ 0.90, strictly future data) — but expired/withdrawn listings aren't in the data, so an early-warning flag first needs all posted listings, a defined target, and retraining on that population.</a:t>
             </a:r>
           </a:p>
         </p:txBody>
@@ -7718,7 +7718,7 @@
         <p:spPr>
           <a:xfrm>
             <a:off x="685800" y="1783080"/>
-            <a:ext cx="10881360" cy="4617720"/>
+            <a:ext cx="11064240" cy="4526280"/>
           </a:xfrm>
           <a:prstGeom prst="rect">
             <a:avLst/>
@@ -7783,7 +7783,7 @@
                 </a:solidFill>
                 <a:latin typeface="Avenir Next"/>
               </a:rPr>
-              <a:t>Measures how fast a FUNDED loan funds — not whether a loan gets funded at all.</a:t>
+              <a:t>Measures how fast a FUNDED loan funds — not whether a loan gets funded at all (expired/withdrawn listings never enter the data).</a:t>
             </a:r>
           </a:p>
           <a:p>

</xml_diff>

<commit_message>
docs: fill the deck's five chart placeholders with real exhibits
Charts extracted from the Kaggle-executed notebooks (committed under
docs/presentation/charts/ so the build is reproducible): holdout
predicted-vs-actual (S3), 24h-share-by-period panel (S4, cropped),
funding speed by sector (S5), topic speeds (S7); S6 gets the verified
SS7.2 few-cluster table typeset as an exhibit. Generator lays exhibits
in a right column with captions; geometric QA (bounds + text overlap)
passes clean.

Co-Authored-By: Claude Fable 5 <noreply@anthropic.com>
</commit_message>
<xml_diff>
--- a/docs/presentation/slides_draft.pptx
+++ b/docs/presentation/slides_draft.pptx
@@ -5078,7 +5078,7 @@
         <p:spPr>
           <a:xfrm>
             <a:off x="685800" y="1783080"/>
-            <a:ext cx="7498079" cy="4526280"/>
+            <a:ext cx="6720840" cy="4526280"/>
           </a:xfrm>
           <a:prstGeom prst="rect">
             <a:avLst/>
@@ -5204,75 +5204,61 @@
           </a:p>
         </p:txBody>
       </p:sp>
-      <p:sp>
-        <p:nvSpPr>
-          <p:cNvPr id="7" name="Rounded Rectangle 6"/>
-          <p:cNvSpPr/>
+      <p:pic>
+        <p:nvPicPr>
+          <p:cNvPr id="7" name="Picture 6" descr="mod_21.png"/>
+          <p:cNvPicPr>
+            <a:picLocks noChangeAspect="1"/>
+          </p:cNvPicPr>
           <p:nvPr/>
-        </p:nvSpPr>
-        <p:spPr>
-          <a:xfrm>
-            <a:off x="8412480" y="1783080"/>
-            <a:ext cx="3200400" cy="4206240"/>
-          </a:xfrm>
-          <a:prstGeom prst="roundRect">
+        </p:nvPicPr>
+        <p:blipFill>
+          <a:blip r:embed="rId2"/>
+          <a:stretch>
+            <a:fillRect/>
+          </a:stretch>
+        </p:blipFill>
+        <p:spPr>
+          <a:xfrm>
+            <a:off x="7498079" y="1783080"/>
+            <a:ext cx="4069080" cy="4074986"/>
+          </a:xfrm>
+          <a:prstGeom prst="rect">
             <a:avLst/>
           </a:prstGeom>
-          <a:solidFill>
-            <a:srgbClr val="F1EBDF"/>
-          </a:solidFill>
-          <a:ln w="9525">
-            <a:solidFill>
-              <a:srgbClr val="DCD3C0"/>
-            </a:solidFill>
-          </a:ln>
-          <a:effectLst/>
-        </p:spPr>
-        <p:style>
-          <a:lnRef idx="1">
-            <a:schemeClr val="accent1"/>
-          </a:lnRef>
-          <a:fillRef idx="3">
-            <a:schemeClr val="accent1"/>
-          </a:fillRef>
-          <a:effectRef idx="2">
-            <a:schemeClr val="accent1"/>
-          </a:effectRef>
-          <a:fontRef idx="minor">
-            <a:schemeClr val="lt1"/>
-          </a:fontRef>
-        </p:style>
-        <p:txBody>
-          <a:bodyPr rtlCol="0" anchor="ctr" wrap="square"/>
-          <a:lstStyle/>
-          <a:p>
-            <a:pPr algn="ctr">
-              <a:defRPr sz="1300" b="1" i="0">
-                <a:solidFill>
-                  <a:srgbClr val="1F4E5F"/>
+        </p:spPr>
+      </p:pic>
+      <p:sp>
+        <p:nvSpPr>
+          <p:cNvPr id="8" name="TextBox 7"/>
+          <p:cNvSpPr txBox="1"/>
+          <p:nvPr/>
+        </p:nvSpPr>
+        <p:spPr>
+          <a:xfrm>
+            <a:off x="7498079" y="6172200"/>
+            <a:ext cx="4206240" cy="274320"/>
+          </a:xfrm>
+          <a:prstGeom prst="rect">
+            <a:avLst/>
+          </a:prstGeom>
+          <a:noFill/>
+        </p:spPr>
+        <p:txBody>
+          <a:bodyPr wrap="square">
+            <a:spAutoFit/>
+          </a:bodyPr>
+          <a:lstStyle/>
+          <a:p>
+            <a:pPr>
+              <a:defRPr sz="850" b="0" i="0">
+                <a:solidFill>
+                  <a:srgbClr val="6E6A5E"/>
                 </a:solidFill>
                 <a:latin typeface="Courier New"/>
               </a:defRPr>
             </a:pPr>
             <a:r>
-              <a:t>CHART GOES HERE</a:t>
-            </a:r>
-          </a:p>
-          <a:p>
-            <a:br/>
-            <a:pPr algn="ctr">
-              <a:defRPr sz="1100" b="0" i="0">
-                <a:solidFill>
-                  <a:srgbClr val="6E6A5E"/>
-                </a:solidFill>
-                <a:latin typeface="Avenir Next"/>
-              </a:defRPr>
-            </a:pPr>
-            <a:r>
-              <a:t>screenshot from:</a:t>
-            </a:r>
-            <a:br/>
-            <a:r>
               <a:t>modeling notebook §4 data split · §7.1 cluster-robust check</a:t>
             </a:r>
           </a:p>
@@ -5280,7 +5266,7 @@
       </p:sp>
       <p:sp>
         <p:nvSpPr>
-          <p:cNvPr id="8" name="TextBox 7"/>
+          <p:cNvPr id="9" name="TextBox 8"/>
           <p:cNvSpPr txBox="1"/>
           <p:nvPr/>
         </p:nvSpPr>
@@ -5564,7 +5550,7 @@
         <p:spPr>
           <a:xfrm>
             <a:off x="685800" y="2834639"/>
-            <a:ext cx="7498079" cy="3474720"/>
+            <a:ext cx="6720840" cy="3474720"/>
           </a:xfrm>
           <a:prstGeom prst="rect">
             <a:avLst/>
@@ -5662,75 +5648,61 @@
           </a:p>
         </p:txBody>
       </p:sp>
-      <p:sp>
-        <p:nvSpPr>
-          <p:cNvPr id="8" name="Rounded Rectangle 7"/>
-          <p:cNvSpPr/>
+      <p:pic>
+        <p:nvPicPr>
+          <p:cNvPr id="8" name="Picture 7" descr="eda_17_right.png"/>
+          <p:cNvPicPr>
+            <a:picLocks noChangeAspect="1"/>
+          </p:cNvPicPr>
           <p:nvPr/>
-        </p:nvSpPr>
-        <p:spPr>
-          <a:xfrm>
-            <a:off x="8412480" y="2834639"/>
-            <a:ext cx="3200400" cy="3154680"/>
-          </a:xfrm>
-          <a:prstGeom prst="roundRect">
+        </p:nvPicPr>
+        <p:blipFill>
+          <a:blip r:embed="rId2"/>
+          <a:stretch>
+            <a:fillRect/>
+          </a:stretch>
+        </p:blipFill>
+        <p:spPr>
+          <a:xfrm>
+            <a:off x="7498079" y="2834639"/>
+            <a:ext cx="4069080" cy="2961556"/>
+          </a:xfrm>
+          <a:prstGeom prst="rect">
             <a:avLst/>
           </a:prstGeom>
-          <a:solidFill>
-            <a:srgbClr val="F1EBDF"/>
-          </a:solidFill>
-          <a:ln w="9525">
-            <a:solidFill>
-              <a:srgbClr val="DCD3C0"/>
-            </a:solidFill>
-          </a:ln>
-          <a:effectLst/>
-        </p:spPr>
-        <p:style>
-          <a:lnRef idx="1">
-            <a:schemeClr val="accent1"/>
-          </a:lnRef>
-          <a:fillRef idx="3">
-            <a:schemeClr val="accent1"/>
-          </a:fillRef>
-          <a:effectRef idx="2">
-            <a:schemeClr val="accent1"/>
-          </a:effectRef>
-          <a:fontRef idx="minor">
-            <a:schemeClr val="lt1"/>
-          </a:fontRef>
-        </p:style>
-        <p:txBody>
-          <a:bodyPr rtlCol="0" anchor="ctr" wrap="square"/>
-          <a:lstStyle/>
-          <a:p>
-            <a:pPr algn="ctr">
-              <a:defRPr sz="1300" b="1" i="0">
-                <a:solidFill>
-                  <a:srgbClr val="1F4E5F"/>
+        </p:spPr>
+      </p:pic>
+      <p:sp>
+        <p:nvSpPr>
+          <p:cNvPr id="9" name="TextBox 8"/>
+          <p:cNvSpPr txBox="1"/>
+          <p:nvPr/>
+        </p:nvSpPr>
+        <p:spPr>
+          <a:xfrm>
+            <a:off x="7498079" y="6172200"/>
+            <a:ext cx="4206240" cy="274320"/>
+          </a:xfrm>
+          <a:prstGeom prst="rect">
+            <a:avLst/>
+          </a:prstGeom>
+          <a:noFill/>
+        </p:spPr>
+        <p:txBody>
+          <a:bodyPr wrap="square">
+            <a:spAutoFit/>
+          </a:bodyPr>
+          <a:lstStyle/>
+          <a:p>
+            <a:pPr>
+              <a:defRPr sz="850" b="0" i="0">
+                <a:solidFill>
+                  <a:srgbClr val="6E6A5E"/>
                 </a:solidFill>
                 <a:latin typeface="Courier New"/>
               </a:defRPr>
             </a:pPr>
             <a:r>
-              <a:t>CHART GOES HERE</a:t>
-            </a:r>
-          </a:p>
-          <a:p>
-            <a:br/>
-            <a:pPr algn="ctr">
-              <a:defRPr sz="1100" b="0" i="0">
-                <a:solidFill>
-                  <a:srgbClr val="6E6A5E"/>
-                </a:solidFill>
-                <a:latin typeface="Avenir Next"/>
-              </a:defRPr>
-            </a:pPr>
-            <a:r>
-              <a:t>screenshot from:</a:t>
-            </a:r>
-            <a:br/>
-            <a:r>
               <a:t>EDA notebook §4 categorical trends (period chart)</a:t>
             </a:r>
           </a:p>
@@ -5738,7 +5710,7 @@
       </p:sp>
       <p:sp>
         <p:nvSpPr>
-          <p:cNvPr id="9" name="TextBox 8"/>
+          <p:cNvPr id="10" name="TextBox 9"/>
           <p:cNvSpPr txBox="1"/>
           <p:nvPr/>
         </p:nvSpPr>
@@ -6022,7 +5994,7 @@
         <p:spPr>
           <a:xfrm>
             <a:off x="685800" y="2834639"/>
-            <a:ext cx="7498079" cy="3474720"/>
+            <a:ext cx="6720840" cy="3474720"/>
           </a:xfrm>
           <a:prstGeom prst="rect">
             <a:avLst/>
@@ -6120,75 +6092,61 @@
           </a:p>
         </p:txBody>
       </p:sp>
-      <p:sp>
-        <p:nvSpPr>
-          <p:cNvPr id="8" name="Rounded Rectangle 7"/>
-          <p:cNvSpPr/>
+      <p:pic>
+        <p:nvPicPr>
+          <p:cNvPr id="8" name="Picture 7" descr="eda_22.png"/>
+          <p:cNvPicPr>
+            <a:picLocks noChangeAspect="1"/>
+          </p:cNvPicPr>
           <p:nvPr/>
-        </p:nvSpPr>
-        <p:spPr>
-          <a:xfrm>
-            <a:off x="8412480" y="2834639"/>
-            <a:ext cx="3200400" cy="3154680"/>
-          </a:xfrm>
-          <a:prstGeom prst="roundRect">
+        </p:nvPicPr>
+        <p:blipFill>
+          <a:blip r:embed="rId2"/>
+          <a:stretch>
+            <a:fillRect/>
+          </a:stretch>
+        </p:blipFill>
+        <p:spPr>
+          <a:xfrm>
+            <a:off x="7672562" y="2834639"/>
+            <a:ext cx="3720114" cy="3291840"/>
+          </a:xfrm>
+          <a:prstGeom prst="rect">
             <a:avLst/>
           </a:prstGeom>
-          <a:solidFill>
-            <a:srgbClr val="F1EBDF"/>
-          </a:solidFill>
-          <a:ln w="9525">
-            <a:solidFill>
-              <a:srgbClr val="DCD3C0"/>
-            </a:solidFill>
-          </a:ln>
-          <a:effectLst/>
-        </p:spPr>
-        <p:style>
-          <a:lnRef idx="1">
-            <a:schemeClr val="accent1"/>
-          </a:lnRef>
-          <a:fillRef idx="3">
-            <a:schemeClr val="accent1"/>
-          </a:fillRef>
-          <a:effectRef idx="2">
-            <a:schemeClr val="accent1"/>
-          </a:effectRef>
-          <a:fontRef idx="minor">
-            <a:schemeClr val="lt1"/>
-          </a:fontRef>
-        </p:style>
-        <p:txBody>
-          <a:bodyPr rtlCol="0" anchor="ctr" wrap="square"/>
-          <a:lstStyle/>
-          <a:p>
-            <a:pPr algn="ctr">
-              <a:defRPr sz="1300" b="1" i="0">
-                <a:solidFill>
-                  <a:srgbClr val="1F4E5F"/>
+        </p:spPr>
+      </p:pic>
+      <p:sp>
+        <p:nvSpPr>
+          <p:cNvPr id="9" name="TextBox 8"/>
+          <p:cNvSpPr txBox="1"/>
+          <p:nvPr/>
+        </p:nvSpPr>
+        <p:spPr>
+          <a:xfrm>
+            <a:off x="7498079" y="6172200"/>
+            <a:ext cx="4206240" cy="274320"/>
+          </a:xfrm>
+          <a:prstGeom prst="rect">
+            <a:avLst/>
+          </a:prstGeom>
+          <a:noFill/>
+        </p:spPr>
+        <p:txBody>
+          <a:bodyPr wrap="square">
+            <a:spAutoFit/>
+          </a:bodyPr>
+          <a:lstStyle/>
+          <a:p>
+            <a:pPr>
+              <a:defRPr sz="850" b="0" i="0">
+                <a:solidFill>
+                  <a:srgbClr val="6E6A5E"/>
                 </a:solidFill>
                 <a:latin typeface="Courier New"/>
               </a:defRPr>
             </a:pPr>
             <a:r>
-              <a:t>CHART GOES HERE</a:t>
-            </a:r>
-          </a:p>
-          <a:p>
-            <a:br/>
-            <a:pPr algn="ctr">
-              <a:defRPr sz="1100" b="0" i="0">
-                <a:solidFill>
-                  <a:srgbClr val="6E6A5E"/>
-                </a:solidFill>
-                <a:latin typeface="Avenir Next"/>
-              </a:defRPr>
-            </a:pPr>
-            <a:r>
-              <a:t>screenshot from:</a:t>
-            </a:r>
-            <a:br/>
-            <a:r>
               <a:t>EDA notebook §5 categorical features · §9 feature correlations</a:t>
             </a:r>
           </a:p>
@@ -6196,7 +6154,7 @@
       </p:sp>
       <p:sp>
         <p:nvSpPr>
-          <p:cNvPr id="9" name="TextBox 8"/>
+          <p:cNvPr id="10" name="TextBox 9"/>
           <p:cNvSpPr txBox="1"/>
           <p:nvPr/>
         </p:nvSpPr>
@@ -6480,7 +6438,7 @@
         <p:spPr>
           <a:xfrm>
             <a:off x="685800" y="2834639"/>
-            <a:ext cx="7498079" cy="3474720"/>
+            <a:ext cx="6720840" cy="3474720"/>
           </a:xfrm>
           <a:prstGeom prst="rect">
             <a:avLst/>
@@ -6606,75 +6564,61 @@
           </a:p>
         </p:txBody>
       </p:sp>
-      <p:sp>
-        <p:nvSpPr>
-          <p:cNvPr id="8" name="Rounded Rectangle 7"/>
-          <p:cNvSpPr/>
+      <p:pic>
+        <p:nvPicPr>
+          <p:cNvPr id="8" name="Picture 7" descr="few_cluster_table.png"/>
+          <p:cNvPicPr>
+            <a:picLocks noChangeAspect="1"/>
+          </p:cNvPicPr>
           <p:nvPr/>
-        </p:nvSpPr>
-        <p:spPr>
-          <a:xfrm>
-            <a:off x="8412480" y="2834639"/>
-            <a:ext cx="3200400" cy="3154680"/>
-          </a:xfrm>
-          <a:prstGeom prst="roundRect">
+        </p:nvPicPr>
+        <p:blipFill>
+          <a:blip r:embed="rId2"/>
+          <a:stretch>
+            <a:fillRect/>
+          </a:stretch>
+        </p:blipFill>
+        <p:spPr>
+          <a:xfrm>
+            <a:off x="7498079" y="2834639"/>
+            <a:ext cx="4069080" cy="2854330"/>
+          </a:xfrm>
+          <a:prstGeom prst="rect">
             <a:avLst/>
           </a:prstGeom>
-          <a:solidFill>
-            <a:srgbClr val="F1EBDF"/>
-          </a:solidFill>
-          <a:ln w="9525">
-            <a:solidFill>
-              <a:srgbClr val="DCD3C0"/>
-            </a:solidFill>
-          </a:ln>
-          <a:effectLst/>
-        </p:spPr>
-        <p:style>
-          <a:lnRef idx="1">
-            <a:schemeClr val="accent1"/>
-          </a:lnRef>
-          <a:fillRef idx="3">
-            <a:schemeClr val="accent1"/>
-          </a:fillRef>
-          <a:effectRef idx="2">
-            <a:schemeClr val="accent1"/>
-          </a:effectRef>
-          <a:fontRef idx="minor">
-            <a:schemeClr val="lt1"/>
-          </a:fontRef>
-        </p:style>
-        <p:txBody>
-          <a:bodyPr rtlCol="0" anchor="ctr" wrap="square"/>
-          <a:lstStyle/>
-          <a:p>
-            <a:pPr algn="ctr">
-              <a:defRPr sz="1300" b="1" i="0">
-                <a:solidFill>
-                  <a:srgbClr val="1F4E5F"/>
+        </p:spPr>
+      </p:pic>
+      <p:sp>
+        <p:nvSpPr>
+          <p:cNvPr id="9" name="TextBox 8"/>
+          <p:cNvSpPr txBox="1"/>
+          <p:nvPr/>
+        </p:nvSpPr>
+        <p:spPr>
+          <a:xfrm>
+            <a:off x="7498079" y="6172200"/>
+            <a:ext cx="4206240" cy="274320"/>
+          </a:xfrm>
+          <a:prstGeom prst="rect">
+            <a:avLst/>
+          </a:prstGeom>
+          <a:noFill/>
+        </p:spPr>
+        <p:txBody>
+          <a:bodyPr wrap="square">
+            <a:spAutoFit/>
+          </a:bodyPr>
+          <a:lstStyle/>
+          <a:p>
+            <a:pPr>
+              <a:defRPr sz="850" b="0" i="0">
+                <a:solidFill>
+                  <a:srgbClr val="6E6A5E"/>
                 </a:solidFill>
                 <a:latin typeface="Courier New"/>
               </a:defRPr>
             </a:pPr>
             <a:r>
-              <a:t>CHART GOES HERE</a:t>
-            </a:r>
-          </a:p>
-          <a:p>
-            <a:br/>
-            <a:pPr algn="ctr">
-              <a:defRPr sz="1100" b="0" i="0">
-                <a:solidFill>
-                  <a:srgbClr val="6E6A5E"/>
-                </a:solidFill>
-                <a:latin typeface="Avenir Next"/>
-              </a:defRPr>
-            </a:pPr>
-            <a:r>
-              <a:t>screenshot from:</a:t>
-            </a:r>
-            <a:br/>
-            <a:r>
               <a:t>modeling notebook §7.2 within-region slopes · §7.1 check</a:t>
             </a:r>
           </a:p>
@@ -6682,7 +6626,7 @@
       </p:sp>
       <p:sp>
         <p:nvSpPr>
-          <p:cNvPr id="9" name="TextBox 8"/>
+          <p:cNvPr id="10" name="TextBox 9"/>
           <p:cNvSpPr txBox="1"/>
           <p:nvPr/>
         </p:nvSpPr>
@@ -6966,7 +6910,7 @@
         <p:spPr>
           <a:xfrm>
             <a:off x="685800" y="2834639"/>
-            <a:ext cx="7498079" cy="3474720"/>
+            <a:ext cx="6720840" cy="3474720"/>
           </a:xfrm>
           <a:prstGeom prst="rect">
             <a:avLst/>
@@ -7036,75 +6980,61 @@
           </a:p>
         </p:txBody>
       </p:sp>
-      <p:sp>
-        <p:nvSpPr>
-          <p:cNvPr id="8" name="Rounded Rectangle 7"/>
-          <p:cNvSpPr/>
+      <p:pic>
+        <p:nvPicPr>
+          <p:cNvPr id="8" name="Picture 7" descr="eda_32.png"/>
+          <p:cNvPicPr>
+            <a:picLocks noChangeAspect="1"/>
+          </p:cNvPicPr>
           <p:nvPr/>
-        </p:nvSpPr>
-        <p:spPr>
-          <a:xfrm>
-            <a:off x="8412480" y="2834639"/>
-            <a:ext cx="3200400" cy="3154680"/>
-          </a:xfrm>
-          <a:prstGeom prst="roundRect">
+        </p:nvPicPr>
+        <p:blipFill>
+          <a:blip r:embed="rId2"/>
+          <a:stretch>
+            <a:fillRect/>
+          </a:stretch>
+        </p:blipFill>
+        <p:spPr>
+          <a:xfrm>
+            <a:off x="7498079" y="2834639"/>
+            <a:ext cx="4069080" cy="2427316"/>
+          </a:xfrm>
+          <a:prstGeom prst="rect">
             <a:avLst/>
           </a:prstGeom>
-          <a:solidFill>
-            <a:srgbClr val="F1EBDF"/>
-          </a:solidFill>
-          <a:ln w="9525">
-            <a:solidFill>
-              <a:srgbClr val="DCD3C0"/>
-            </a:solidFill>
-          </a:ln>
-          <a:effectLst/>
-        </p:spPr>
-        <p:style>
-          <a:lnRef idx="1">
-            <a:schemeClr val="accent1"/>
-          </a:lnRef>
-          <a:fillRef idx="3">
-            <a:schemeClr val="accent1"/>
-          </a:fillRef>
-          <a:effectRef idx="2">
-            <a:schemeClr val="accent1"/>
-          </a:effectRef>
-          <a:fontRef idx="minor">
-            <a:schemeClr val="lt1"/>
-          </a:fontRef>
-        </p:style>
-        <p:txBody>
-          <a:bodyPr rtlCol="0" anchor="ctr" wrap="square"/>
-          <a:lstStyle/>
-          <a:p>
-            <a:pPr algn="ctr">
-              <a:defRPr sz="1300" b="1" i="0">
-                <a:solidFill>
-                  <a:srgbClr val="1F4E5F"/>
+        </p:spPr>
+      </p:pic>
+      <p:sp>
+        <p:nvSpPr>
+          <p:cNvPr id="9" name="TextBox 8"/>
+          <p:cNvSpPr txBox="1"/>
+          <p:nvPr/>
+        </p:nvSpPr>
+        <p:spPr>
+          <a:xfrm>
+            <a:off x="7498079" y="6172200"/>
+            <a:ext cx="4206240" cy="274320"/>
+          </a:xfrm>
+          <a:prstGeom prst="rect">
+            <a:avLst/>
+          </a:prstGeom>
+          <a:noFill/>
+        </p:spPr>
+        <p:txBody>
+          <a:bodyPr wrap="square">
+            <a:spAutoFit/>
+          </a:bodyPr>
+          <a:lstStyle/>
+          <a:p>
+            <a:pPr>
+              <a:defRPr sz="850" b="0" i="0">
+                <a:solidFill>
+                  <a:srgbClr val="6E6A5E"/>
                 </a:solidFill>
                 <a:latin typeface="Courier New"/>
               </a:defRPr>
             </a:pPr>
             <a:r>
-              <a:t>CHART GOES HERE</a:t>
-            </a:r>
-          </a:p>
-          <a:p>
-            <a:br/>
-            <a:pPr algn="ctr">
-              <a:defRPr sz="1100" b="0" i="0">
-                <a:solidFill>
-                  <a:srgbClr val="6E6A5E"/>
-                </a:solidFill>
-                <a:latin typeface="Avenir Next"/>
-              </a:defRPr>
-            </a:pPr>
-            <a:r>
-              <a:t>screenshot from:</a:t>
-            </a:r>
-            <a:br/>
-            <a:r>
               <a:t>EDA notebook §8 topic modeling</a:t>
             </a:r>
           </a:p>
@@ -7112,7 +7042,7 @@
       </p:sp>
       <p:sp>
         <p:nvSpPr>
-          <p:cNvPr id="9" name="TextBox 8"/>
+          <p:cNvPr id="10" name="TextBox 9"/>
           <p:cNvSpPr txBox="1"/>
           <p:nvPr/>
         </p:nvSpPr>

</xml_diff>

<commit_message>
docs: add Q&A appendix to the deck (divider + 4 backup slides)
A1 two-country problem in full, A2 SHAP caveats, A3 structure
dose-response, A4 classifier operating detail with population boundary -
clearly marked 'not part of the 10-minute presentation'; chips A1-A4.
Geometric QA clean.

Co-Authored-By: Claude Fable 5 <noreply@anthropic.com>
</commit_message>
<xml_diff>
--- a/docs/presentation/slides_draft.pptx
+++ b/docs/presentation/slides_draft.pptx
@@ -15,6 +15,11 @@
     <p:sldId id="263" r:id="rId15"/>
     <p:sldId id="264" r:id="rId16"/>
     <p:sldId id="265" r:id="rId17"/>
+    <p:sldId id="266" r:id="rId18"/>
+    <p:sldId id="267" r:id="rId19"/>
+    <p:sldId id="268" r:id="rId20"/>
+    <p:sldId id="269" r:id="rId21"/>
+    <p:sldId id="270" r:id="rId22"/>
   </p:sldIdLst>
   <p:sldSz cx="12191695" cy="6858000" type="screen4x3"/>
   <p:notesSz cx="6858000" cy="9144000"/>
@@ -582,6 +587,356 @@
           <a:p>
             <a:r>
               <a:t>In this data, the story barely registers — the structure carries the signal. And testing hard enough to KNOW that is worth more to a platform than a good-sounding tip. Thank you — we're happy to take questions.</a:t>
+            </a:r>
+          </a:p>
+        </p:txBody>
+      </p:sp>
+      <p:sp>
+        <p:nvSpPr>
+          <p:cNvPr id="4" name="Slide Number Placeholder 3"/>
+          <p:cNvSpPr>
+            <a:spLocks noGrp="1"/>
+          </p:cNvSpPr>
+          <p:nvPr>
+            <p:ph type="sldNum" idx="5" sz="quarter"/>
+          </p:nvPr>
+        </p:nvSpPr>
+        <p:spPr/>
+      </p:sp>
+    </p:spTree>
+  </p:cSld>
+  <p:clrMapOvr>
+    <a:masterClrMapping/>
+  </p:clrMapOvr>
+</p:notes>
+</file>
+
+<file path=ppt/notesSlides/notesSlide11.xml><?xml version="1.0" encoding="utf-8"?>
+<p:notes xmlns:a="http://schemas.openxmlformats.org/drawingml/2006/main" xmlns:p="http://schemas.openxmlformats.org/presentationml/2006/main" xmlns:r="http://schemas.openxmlformats.org/officeDocument/2006/relationships">
+  <p:cSld>
+    <p:spTree>
+      <p:nvGrpSpPr>
+        <p:cNvPr id="1" name=""/>
+        <p:cNvGrpSpPr/>
+        <p:nvPr/>
+      </p:nvGrpSpPr>
+      <p:grpSpPr>
+        <a:xfrm>
+          <a:off x="0" y="0"/>
+          <a:ext cx="0" cy="0"/>
+          <a:chOff x="0" y="0"/>
+          <a:chExt cx="0" cy="0"/>
+        </a:xfrm>
+      </p:grpSpPr>
+      <p:sp>
+        <p:nvSpPr>
+          <p:cNvPr id="2" name="Slide Image Placeholder 1"/>
+          <p:cNvSpPr>
+            <a:spLocks noGrp="1"/>
+          </p:cNvSpPr>
+          <p:nvPr>
+            <p:ph type="sldImg" idx="2"/>
+          </p:nvPr>
+        </p:nvSpPr>
+        <p:spPr/>
+      </p:sp>
+      <p:sp>
+        <p:nvSpPr>
+          <p:cNvPr id="3" name="Notes Placeholder 2"/>
+          <p:cNvSpPr>
+            <a:spLocks noGrp="1"/>
+          </p:cNvSpPr>
+          <p:nvPr>
+            <p:ph type="body" idx="3" sz="quarter"/>
+          </p:nvPr>
+        </p:nvSpPr>
+        <p:spPr/>
+        <p:txBody>
+          <a:bodyPr/>
+          <a:lstStyle/>
+          <a:p>
+            <a:r>
+              <a:t>Divider only. Everything after this slide exists to be pulled up during Q&amp;A if a question calls for it.</a:t>
+            </a:r>
+          </a:p>
+        </p:txBody>
+      </p:sp>
+      <p:sp>
+        <p:nvSpPr>
+          <p:cNvPr id="4" name="Slide Number Placeholder 3"/>
+          <p:cNvSpPr>
+            <a:spLocks noGrp="1"/>
+          </p:cNvSpPr>
+          <p:nvPr>
+            <p:ph type="sldNum" idx="5" sz="quarter"/>
+          </p:nvPr>
+        </p:nvSpPr>
+        <p:spPr/>
+      </p:sp>
+    </p:spTree>
+  </p:cSld>
+  <p:clrMapOvr>
+    <a:masterClrMapping/>
+  </p:clrMapOvr>
+</p:notes>
+</file>
+
+<file path=ppt/notesSlides/notesSlide12.xml><?xml version="1.0" encoding="utf-8"?>
+<p:notes xmlns:a="http://schemas.openxmlformats.org/drawingml/2006/main" xmlns:p="http://schemas.openxmlformats.org/presentationml/2006/main" xmlns:r="http://schemas.openxmlformats.org/officeDocument/2006/relationships">
+  <p:cSld>
+    <p:spTree>
+      <p:nvGrpSpPr>
+        <p:cNvPr id="1" name=""/>
+        <p:cNvGrpSpPr/>
+        <p:nvPr/>
+      </p:nvGrpSpPr>
+      <p:grpSpPr>
+        <a:xfrm>
+          <a:off x="0" y="0"/>
+          <a:ext cx="0" cy="0"/>
+          <a:chOff x="0" y="0"/>
+          <a:chExt cx="0" cy="0"/>
+        </a:xfrm>
+      </p:grpSpPr>
+      <p:sp>
+        <p:nvSpPr>
+          <p:cNvPr id="2" name="Slide Image Placeholder 1"/>
+          <p:cNvSpPr>
+            <a:spLocks noGrp="1"/>
+          </p:cNvSpPr>
+          <p:nvPr>
+            <p:ph type="sldImg" idx="2"/>
+          </p:nvPr>
+        </p:nvSpPr>
+        <p:spPr/>
+      </p:sp>
+      <p:sp>
+        <p:nvSpPr>
+          <p:cNvPr id="3" name="Notes Placeholder 2"/>
+          <p:cNvSpPr>
+            <a:spLocks noGrp="1"/>
+          </p:cNvSpPr>
+          <p:nvPr>
+            <p:ph type="body" idx="3" sz="quarter"/>
+          </p:nvPr>
+        </p:nvSpPr>
+        <p:spPr/>
+        <p:txBody>
+          <a:bodyPr/>
+          <a:lstStyle/>
+          <a:p>
+            <a:r>
+              <a:t>Backup for Slide 6 probes: exact pooled definitions, all p-values, the single-country boundary, and the honest status of the screen.</a:t>
+            </a:r>
+          </a:p>
+        </p:txBody>
+      </p:sp>
+      <p:sp>
+        <p:nvSpPr>
+          <p:cNvPr id="4" name="Slide Number Placeholder 3"/>
+          <p:cNvSpPr>
+            <a:spLocks noGrp="1"/>
+          </p:cNvSpPr>
+          <p:nvPr>
+            <p:ph type="sldNum" idx="5" sz="quarter"/>
+          </p:nvPr>
+        </p:nvSpPr>
+        <p:spPr/>
+      </p:sp>
+    </p:spTree>
+  </p:cSld>
+  <p:clrMapOvr>
+    <a:masterClrMapping/>
+  </p:clrMapOvr>
+</p:notes>
+</file>
+
+<file path=ppt/notesSlides/notesSlide13.xml><?xml version="1.0" encoding="utf-8"?>
+<p:notes xmlns:a="http://schemas.openxmlformats.org/drawingml/2006/main" xmlns:p="http://schemas.openxmlformats.org/presentationml/2006/main" xmlns:r="http://schemas.openxmlformats.org/officeDocument/2006/relationships">
+  <p:cSld>
+    <p:spTree>
+      <p:nvGrpSpPr>
+        <p:cNvPr id="1" name=""/>
+        <p:cNvGrpSpPr/>
+        <p:nvPr/>
+      </p:nvGrpSpPr>
+      <p:grpSpPr>
+        <a:xfrm>
+          <a:off x="0" y="0"/>
+          <a:ext cx="0" cy="0"/>
+          <a:chOff x="0" y="0"/>
+          <a:chExt cx="0" cy="0"/>
+        </a:xfrm>
+      </p:grpSpPr>
+      <p:sp>
+        <p:nvSpPr>
+          <p:cNvPr id="2" name="Slide Image Placeholder 1"/>
+          <p:cNvSpPr>
+            <a:spLocks noGrp="1"/>
+          </p:cNvSpPr>
+          <p:nvPr>
+            <p:ph type="sldImg" idx="2"/>
+          </p:nvPr>
+        </p:nvSpPr>
+        <p:spPr/>
+      </p:sp>
+      <p:sp>
+        <p:nvSpPr>
+          <p:cNvPr id="3" name="Notes Placeholder 2"/>
+          <p:cNvSpPr>
+            <a:spLocks noGrp="1"/>
+          </p:cNvSpPr>
+          <p:nvPr>
+            <p:ph type="body" idx="3" sz="quarter"/>
+          </p:nvPr>
+        </p:nvSpPr>
+        <p:spPr/>
+        <p:txBody>
+          <a:bodyPr/>
+          <a:lstStyle/>
+          <a:p>
+            <a:r>
+              <a:t>Backup for SHAP questions: what the ranking shows, and exactly what it cannot corroborate.</a:t>
+            </a:r>
+          </a:p>
+        </p:txBody>
+      </p:sp>
+      <p:sp>
+        <p:nvSpPr>
+          <p:cNvPr id="4" name="Slide Number Placeholder 3"/>
+          <p:cNvSpPr>
+            <a:spLocks noGrp="1"/>
+          </p:cNvSpPr>
+          <p:nvPr>
+            <p:ph type="sldNum" idx="5" sz="quarter"/>
+          </p:nvPr>
+        </p:nvSpPr>
+        <p:spPr/>
+      </p:sp>
+    </p:spTree>
+  </p:cSld>
+  <p:clrMapOvr>
+    <a:masterClrMapping/>
+  </p:clrMapOvr>
+</p:notes>
+</file>
+
+<file path=ppt/notesSlides/notesSlide14.xml><?xml version="1.0" encoding="utf-8"?>
+<p:notes xmlns:a="http://schemas.openxmlformats.org/drawingml/2006/main" xmlns:p="http://schemas.openxmlformats.org/presentationml/2006/main" xmlns:r="http://schemas.openxmlformats.org/officeDocument/2006/relationships">
+  <p:cSld>
+    <p:spTree>
+      <p:nvGrpSpPr>
+        <p:cNvPr id="1" name=""/>
+        <p:cNvGrpSpPr/>
+        <p:nvPr/>
+      </p:nvGrpSpPr>
+      <p:grpSpPr>
+        <a:xfrm>
+          <a:off x="0" y="0"/>
+          <a:ext cx="0" cy="0"/>
+          <a:chOff x="0" y="0"/>
+          <a:chExt cx="0" cy="0"/>
+        </a:xfrm>
+      </p:grpSpPr>
+      <p:sp>
+        <p:nvSpPr>
+          <p:cNvPr id="2" name="Slide Image Placeholder 1"/>
+          <p:cNvSpPr>
+            <a:spLocks noGrp="1"/>
+          </p:cNvSpPr>
+          <p:nvPr>
+            <p:ph type="sldImg" idx="2"/>
+          </p:nvPr>
+        </p:nvSpPr>
+        <p:spPr/>
+      </p:sp>
+      <p:sp>
+        <p:nvSpPr>
+          <p:cNvPr id="3" name="Notes Placeholder 2"/>
+          <p:cNvSpPr>
+            <a:spLocks noGrp="1"/>
+          </p:cNvSpPr>
+          <p:nvPr>
+            <p:ph type="body" idx="3" sz="quarter"/>
+          </p:nvPr>
+        </p:nvSpPr>
+        <p:spPr/>
+        <p:txBody>
+          <a:bodyPr/>
+          <a:lstStyle/>
+          <a:p>
+            <a:r>
+              <a:t>Backup for Slide 5 probes: the amount gradient and the gender gap's robustness status.</a:t>
+            </a:r>
+          </a:p>
+        </p:txBody>
+      </p:sp>
+      <p:sp>
+        <p:nvSpPr>
+          <p:cNvPr id="4" name="Slide Number Placeholder 3"/>
+          <p:cNvSpPr>
+            <a:spLocks noGrp="1"/>
+          </p:cNvSpPr>
+          <p:nvPr>
+            <p:ph type="sldNum" idx="5" sz="quarter"/>
+          </p:nvPr>
+        </p:nvSpPr>
+        <p:spPr/>
+      </p:sp>
+    </p:spTree>
+  </p:cSld>
+  <p:clrMapOvr>
+    <a:masterClrMapping/>
+  </p:clrMapOvr>
+</p:notes>
+</file>
+
+<file path=ppt/notesSlides/notesSlide15.xml><?xml version="1.0" encoding="utf-8"?>
+<p:notes xmlns:a="http://schemas.openxmlformats.org/drawingml/2006/main" xmlns:p="http://schemas.openxmlformats.org/presentationml/2006/main" xmlns:r="http://schemas.openxmlformats.org/officeDocument/2006/relationships">
+  <p:cSld>
+    <p:spTree>
+      <p:nvGrpSpPr>
+        <p:cNvPr id="1" name=""/>
+        <p:cNvGrpSpPr/>
+        <p:nvPr/>
+      </p:nvGrpSpPr>
+      <p:grpSpPr>
+        <a:xfrm>
+          <a:off x="0" y="0"/>
+          <a:ext cx="0" cy="0"/>
+          <a:chOff x="0" y="0"/>
+          <a:chExt cx="0" cy="0"/>
+        </a:xfrm>
+      </p:grpSpPr>
+      <p:sp>
+        <p:nvSpPr>
+          <p:cNvPr id="2" name="Slide Image Placeholder 1"/>
+          <p:cNvSpPr>
+            <a:spLocks noGrp="1"/>
+          </p:cNvSpPr>
+          <p:nvPr>
+            <p:ph type="sldImg" idx="2"/>
+          </p:nvPr>
+        </p:nvSpPr>
+        <p:spPr/>
+      </p:sp>
+      <p:sp>
+        <p:nvSpPr>
+          <p:cNvPr id="3" name="Notes Placeholder 2"/>
+          <p:cNvSpPr>
+            <a:spLocks noGrp="1"/>
+          </p:cNvSpPr>
+          <p:nvPr>
+            <p:ph type="body" idx="3" sz="quarter"/>
+          </p:nvPr>
+        </p:nvSpPr>
+        <p:spPr/>
+        <p:txBody>
+          <a:bodyPr/>
+          <a:lstStyle/>
+          <a:p>
+            <a:r>
+              <a:t>Backup for classifier questions: exact metrics, class balance, and the population boundary stated before anyone asks.</a:t>
             </a:r>
           </a:p>
         </p:txBody>
@@ -4530,6 +4885,1740 @@
             </a:pPr>
             <a:r>
               <a:t>Team Cultural Blend · UNSW Marketing Analytics Hackathon 2026</a:t>
+            </a:r>
+          </a:p>
+        </p:txBody>
+      </p:sp>
+    </p:spTree>
+  </p:cSld>
+  <p:clrMapOvr>
+    <a:masterClrMapping/>
+  </p:clrMapOvr>
+</p:sld>
+</file>
+
+<file path=ppt/slides/slide11.xml><?xml version="1.0" encoding="utf-8"?>
+<p:sld xmlns:a="http://schemas.openxmlformats.org/drawingml/2006/main" xmlns:p="http://schemas.openxmlformats.org/presentationml/2006/main" xmlns:r="http://schemas.openxmlformats.org/officeDocument/2006/relationships">
+  <p:cSld>
+    <p:bg>
+      <p:bgPr>
+        <a:solidFill>
+          <a:srgbClr val="1F4E5F"/>
+        </a:solidFill>
+        <a:effectLst/>
+      </p:bgPr>
+    </p:bg>
+    <p:spTree>
+      <p:nvGrpSpPr>
+        <p:cNvPr id="1" name=""/>
+        <p:cNvGrpSpPr/>
+        <p:nvPr/>
+      </p:nvGrpSpPr>
+      <p:grpSpPr/>
+      <p:sp>
+        <p:nvSpPr>
+          <p:cNvPr id="2" name="Rectangle 1"/>
+          <p:cNvSpPr/>
+          <p:nvPr/>
+        </p:nvSpPr>
+        <p:spPr>
+          <a:xfrm>
+            <a:off x="822960" y="2743200"/>
+            <a:ext cx="1463040" cy="50800"/>
+          </a:xfrm>
+          <a:prstGeom prst="rect">
+            <a:avLst/>
+          </a:prstGeom>
+          <a:solidFill>
+            <a:srgbClr val="C97B3D"/>
+          </a:solidFill>
+          <a:ln>
+            <a:noFill/>
+          </a:ln>
+          <a:effectLst/>
+        </p:spPr>
+        <p:style>
+          <a:lnRef idx="1">
+            <a:schemeClr val="accent1"/>
+          </a:lnRef>
+          <a:fillRef idx="3">
+            <a:schemeClr val="accent1"/>
+          </a:fillRef>
+          <a:effectRef idx="2">
+            <a:schemeClr val="accent1"/>
+          </a:effectRef>
+          <a:fontRef idx="minor">
+            <a:schemeClr val="lt1"/>
+          </a:fontRef>
+        </p:style>
+        <p:txBody>
+          <a:bodyPr rtlCol="0" anchor="ctr"/>
+          <a:lstStyle/>
+          <a:p>
+            <a:pPr algn="ctr"/>
+          </a:p>
+        </p:txBody>
+      </p:sp>
+      <p:sp>
+        <p:nvSpPr>
+          <p:cNvPr id="3" name="TextBox 2"/>
+          <p:cNvSpPr txBox="1"/>
+          <p:nvPr/>
+        </p:nvSpPr>
+        <p:spPr>
+          <a:xfrm>
+            <a:off x="822960" y="2971800"/>
+            <a:ext cx="10515600" cy="1097280"/>
+          </a:xfrm>
+          <a:prstGeom prst="rect">
+            <a:avLst/>
+          </a:prstGeom>
+          <a:noFill/>
+        </p:spPr>
+        <p:txBody>
+          <a:bodyPr wrap="square">
+            <a:spAutoFit/>
+          </a:bodyPr>
+          <a:lstStyle/>
+          <a:p>
+            <a:pPr>
+              <a:defRPr sz="5400" b="1" i="0">
+                <a:solidFill>
+                  <a:srgbClr val="FAF7F0"/>
+                </a:solidFill>
+                <a:latin typeface="Georgia"/>
+              </a:defRPr>
+            </a:pPr>
+            <a:r>
+              <a:t>Appendix</a:t>
+            </a:r>
+          </a:p>
+        </p:txBody>
+      </p:sp>
+      <p:sp>
+        <p:nvSpPr>
+          <p:cNvPr id="4" name="TextBox 3"/>
+          <p:cNvSpPr txBox="1"/>
+          <p:nvPr/>
+        </p:nvSpPr>
+        <p:spPr>
+          <a:xfrm>
+            <a:off x="822960" y="4114800"/>
+            <a:ext cx="10515600" cy="548640"/>
+          </a:xfrm>
+          <a:prstGeom prst="rect">
+            <a:avLst/>
+          </a:prstGeom>
+          <a:noFill/>
+        </p:spPr>
+        <p:txBody>
+          <a:bodyPr wrap="square">
+            <a:spAutoFit/>
+          </a:bodyPr>
+          <a:lstStyle/>
+          <a:p>
+            <a:pPr>
+              <a:defRPr sz="1800" b="0" i="1">
+                <a:solidFill>
+                  <a:srgbClr val="B8CED6"/>
+                </a:solidFill>
+                <a:latin typeface="Avenir Next"/>
+              </a:defRPr>
+            </a:pPr>
+            <a:r>
+              <a:t>Q&amp;A backup — not part of the 10-minute presentation.</a:t>
+            </a:r>
+          </a:p>
+        </p:txBody>
+      </p:sp>
+    </p:spTree>
+  </p:cSld>
+  <p:clrMapOvr>
+    <a:masterClrMapping/>
+  </p:clrMapOvr>
+</p:sld>
+</file>
+
+<file path=ppt/slides/slide12.xml><?xml version="1.0" encoding="utf-8"?>
+<p:sld xmlns:a="http://schemas.openxmlformats.org/drawingml/2006/main" xmlns:p="http://schemas.openxmlformats.org/presentationml/2006/main" xmlns:r="http://schemas.openxmlformats.org/officeDocument/2006/relationships">
+  <p:cSld>
+    <p:bg>
+      <p:bgPr>
+        <a:solidFill>
+          <a:srgbClr val="FAF7F0"/>
+        </a:solidFill>
+        <a:effectLst/>
+      </p:bgPr>
+    </p:bg>
+    <p:spTree>
+      <p:nvGrpSpPr>
+        <p:cNvPr id="1" name=""/>
+        <p:cNvGrpSpPr/>
+        <p:nvPr/>
+      </p:nvGrpSpPr>
+      <p:grpSpPr/>
+      <p:sp>
+        <p:nvSpPr>
+          <p:cNvPr id="2" name="TextBox 1"/>
+          <p:cNvSpPr txBox="1"/>
+          <p:nvPr/>
+        </p:nvSpPr>
+        <p:spPr>
+          <a:xfrm>
+            <a:off x="685800" y="384048"/>
+            <a:ext cx="8229600" cy="320040"/>
+          </a:xfrm>
+          <a:prstGeom prst="rect">
+            <a:avLst/>
+          </a:prstGeom>
+          <a:noFill/>
+        </p:spPr>
+        <p:txBody>
+          <a:bodyPr wrap="square">
+            <a:spAutoFit/>
+          </a:bodyPr>
+          <a:lstStyle/>
+          <a:p>
+            <a:pPr>
+              <a:defRPr sz="1150" b="0" i="0">
+                <a:solidFill>
+                  <a:srgbClr val="C97B3D"/>
+                </a:solidFill>
+                <a:latin typeface="Courier New"/>
+              </a:defRPr>
+            </a:pPr>
+            <a:r>
+              <a:t>APPENDIX · A1</a:t>
+            </a:r>
+          </a:p>
+        </p:txBody>
+      </p:sp>
+      <p:sp>
+        <p:nvSpPr>
+          <p:cNvPr id="3" name="Rounded Rectangle 2"/>
+          <p:cNvSpPr/>
+          <p:nvPr/>
+        </p:nvSpPr>
+        <p:spPr>
+          <a:xfrm>
+            <a:off x="11109960" y="365760"/>
+            <a:ext cx="658368" cy="347472"/>
+          </a:xfrm>
+          <a:prstGeom prst="roundRect">
+            <a:avLst/>
+          </a:prstGeom>
+          <a:solidFill>
+            <a:srgbClr val="1F4E5F"/>
+          </a:solidFill>
+          <a:ln>
+            <a:noFill/>
+          </a:ln>
+          <a:effectLst/>
+        </p:spPr>
+        <p:style>
+          <a:lnRef idx="1">
+            <a:schemeClr val="accent1"/>
+          </a:lnRef>
+          <a:fillRef idx="3">
+            <a:schemeClr val="accent1"/>
+          </a:fillRef>
+          <a:effectRef idx="2">
+            <a:schemeClr val="accent1"/>
+          </a:effectRef>
+          <a:fontRef idx="minor">
+            <a:schemeClr val="lt1"/>
+          </a:fontRef>
+        </p:style>
+        <p:txBody>
+          <a:bodyPr rtlCol="0" anchor="ctr" tIns="0" bIns="0"/>
+          <a:lstStyle/>
+          <a:p>
+            <a:pPr algn="ctr">
+              <a:defRPr sz="1200" b="0" i="0">
+                <a:solidFill>
+                  <a:srgbClr val="FAF7F0"/>
+                </a:solidFill>
+                <a:latin typeface="Courier New"/>
+              </a:defRPr>
+            </a:pPr>
+            <a:r>
+              <a:t>A1</a:t>
+            </a:r>
+          </a:p>
+        </p:txBody>
+      </p:sp>
+      <p:sp>
+        <p:nvSpPr>
+          <p:cNvPr id="4" name="TextBox 3"/>
+          <p:cNvSpPr txBox="1"/>
+          <p:nvPr/>
+        </p:nvSpPr>
+        <p:spPr>
+          <a:xfrm>
+            <a:off x="640080" y="713232"/>
+            <a:ext cx="10332720" cy="914400"/>
+          </a:xfrm>
+          <a:prstGeom prst="rect">
+            <a:avLst/>
+          </a:prstGeom>
+          <a:noFill/>
+        </p:spPr>
+        <p:txBody>
+          <a:bodyPr wrap="square">
+            <a:spAutoFit/>
+          </a:bodyPr>
+          <a:lstStyle/>
+          <a:p>
+            <a:pPr>
+              <a:defRPr sz="3600" b="1" i="0">
+                <a:solidFill>
+                  <a:srgbClr val="1E2A2F"/>
+                </a:solidFill>
+                <a:latin typeface="Georgia"/>
+              </a:defRPr>
+            </a:pPr>
+            <a:r>
+              <a:t>The two-country problem, in full</a:t>
+            </a:r>
+          </a:p>
+        </p:txBody>
+      </p:sp>
+      <p:sp>
+        <p:nvSpPr>
+          <p:cNvPr id="5" name="Rectangle 4"/>
+          <p:cNvSpPr/>
+          <p:nvPr/>
+        </p:nvSpPr>
+        <p:spPr>
+          <a:xfrm>
+            <a:off x="685800" y="1481328"/>
+            <a:ext cx="1234440" cy="44450"/>
+          </a:xfrm>
+          <a:prstGeom prst="rect">
+            <a:avLst/>
+          </a:prstGeom>
+          <a:solidFill>
+            <a:srgbClr val="C97B3D"/>
+          </a:solidFill>
+          <a:ln>
+            <a:noFill/>
+          </a:ln>
+          <a:effectLst/>
+        </p:spPr>
+        <p:style>
+          <a:lnRef idx="1">
+            <a:schemeClr val="accent1"/>
+          </a:lnRef>
+          <a:fillRef idx="3">
+            <a:schemeClr val="accent1"/>
+          </a:fillRef>
+          <a:effectRef idx="2">
+            <a:schemeClr val="accent1"/>
+          </a:effectRef>
+          <a:fontRef idx="minor">
+            <a:schemeClr val="lt1"/>
+          </a:fontRef>
+        </p:style>
+        <p:txBody>
+          <a:bodyPr rtlCol="0" anchor="ctr"/>
+          <a:lstStyle/>
+          <a:p>
+            <a:pPr algn="ctr"/>
+          </a:p>
+        </p:txBody>
+      </p:sp>
+      <p:sp>
+        <p:nvSpPr>
+          <p:cNvPr id="6" name="TextBox 5"/>
+          <p:cNvSpPr txBox="1"/>
+          <p:nvPr/>
+        </p:nvSpPr>
+        <p:spPr>
+          <a:xfrm>
+            <a:off x="685800" y="1783080"/>
+            <a:ext cx="6720840" cy="4526280"/>
+          </a:xfrm>
+          <a:prstGeom prst="rect">
+            <a:avLst/>
+          </a:prstGeom>
+          <a:noFill/>
+        </p:spPr>
+        <p:txBody>
+          <a:bodyPr wrap="square">
+            <a:spAutoFit/>
+          </a:bodyPr>
+          <a:lstStyle/>
+          <a:p>
+            <a:pPr>
+              <a:lnSpc>
+                <a:spcPct val="115000"/>
+              </a:lnSpc>
+              <a:spcAft>
+                <a:spcPts val="1200"/>
+              </a:spcAft>
+            </a:pPr>
+            <a:r>
+              <a:rPr sz="1600">
+                <a:solidFill>
+                  <a:srgbClr val="C97B3D"/>
+                </a:solidFill>
+                <a:latin typeface="Avenir Next"/>
+              </a:rPr>
+              <a:t>▪  </a:t>
+            </a:r>
+            <a:r>
+              <a:rPr sz="1650">
+                <a:solidFill>
+                  <a:srgbClr val="1E2A2F"/>
+                </a:solidFill>
+                <a:latin typeface="Avenir Next"/>
+              </a:rPr>
+              <a:t>Pooled categories: Middle East = Palestine + Yemen (14,946 loans); Central America = Honduras + Nicaragua (59,391); North America = Haiti alone.</a:t>
+            </a:r>
+          </a:p>
+          <a:p>
+            <a:pPr>
+              <a:lnSpc>
+                <a:spcPct val="115000"/>
+              </a:lnSpc>
+              <a:spcAft>
+                <a:spcPts val="1200"/>
+              </a:spcAft>
+            </a:pPr>
+            <a:r>
+              <a:rPr sz="1600">
+                <a:solidFill>
+                  <a:srgbClr val="C97B3D"/>
+                </a:solidFill>
+                <a:latin typeface="Avenir Next"/>
+              </a:rPr>
+              <a:t>▪  </a:t>
+            </a:r>
+            <a:r>
+              <a:rPr sz="1650">
+                <a:solidFill>
+                  <a:srgbClr val="1E2A2F"/>
+                </a:solidFill>
+                <a:latin typeface="Avenir Next"/>
+              </a:rPr>
+              <a:t>Few-cluster screen p (duration / 24h / notebook fit): ME 0.12 / 0.21 / 0.08 · CA 0.06 / 0.14 / 0.07 — same direction in every fit, none significant; t(1) critical value 12.7.</a:t>
+            </a:r>
+          </a:p>
+          <a:p>
+            <a:pPr>
+              <a:lnSpc>
+                <a:spcPct val="115000"/>
+              </a:lnSpc>
+              <a:spcAft>
+                <a:spcPts val="1200"/>
+              </a:spcAft>
+            </a:pPr>
+            <a:r>
+              <a:rPr sz="1600">
+                <a:solidFill>
+                  <a:srgbClr val="C97B3D"/>
+                </a:solidFill>
+                <a:latin typeface="Avenir Next"/>
+              </a:rPr>
+              <a:t>▪  </a:t>
+            </a:r>
+            <a:r>
+              <a:rPr sz="1650">
+                <a:solidFill>
+                  <a:srgbClr val="1E2A2F"/>
+                </a:solidFill>
+                <a:latin typeface="Avenir Next"/>
+              </a:rPr>
+              <a:t>North America: single country — between-country uncertainty not estimable at all.</a:t>
+            </a:r>
+          </a:p>
+          <a:p>
+            <a:pPr>
+              <a:lnSpc>
+                <a:spcPct val="115000"/>
+              </a:lnSpc>
+              <a:spcAft>
+                <a:spcPts val="1200"/>
+              </a:spcAft>
+            </a:pPr>
+            <a:r>
+              <a:rPr sz="1600">
+                <a:solidFill>
+                  <a:srgbClr val="C97B3D"/>
+                </a:solidFill>
+                <a:latin typeface="Avenir Next"/>
+              </a:rPr>
+              <a:t>▪  </a:t>
+            </a:r>
+            <a:r>
+              <a:rPr sz="1650">
+                <a:solidFill>
+                  <a:srgbClr val="1E2A2F"/>
+                </a:solidFill>
+                <a:latin typeface="Avenir Next"/>
+              </a:rPr>
+              <a:t>The screen is a conservative heuristic: it can downgrade a claim, never certify one. Next step: country-stratified A/B test in those four markets.</a:t>
+            </a:r>
+          </a:p>
+        </p:txBody>
+      </p:sp>
+      <p:pic>
+        <p:nvPicPr>
+          <p:cNvPr id="7" name="Picture 6" descr="eda_23.png"/>
+          <p:cNvPicPr>
+            <a:picLocks noChangeAspect="1"/>
+          </p:cNvPicPr>
+          <p:nvPr/>
+        </p:nvPicPr>
+        <p:blipFill>
+          <a:blip r:embed="rId2"/>
+          <a:stretch>
+            <a:fillRect/>
+          </a:stretch>
+        </p:blipFill>
+        <p:spPr>
+          <a:xfrm>
+            <a:off x="7498079" y="1783080"/>
+            <a:ext cx="4069080" cy="1717011"/>
+          </a:xfrm>
+          <a:prstGeom prst="rect">
+            <a:avLst/>
+          </a:prstGeom>
+        </p:spPr>
+      </p:pic>
+      <p:sp>
+        <p:nvSpPr>
+          <p:cNvPr id="8" name="TextBox 7"/>
+          <p:cNvSpPr txBox="1"/>
+          <p:nvPr/>
+        </p:nvSpPr>
+        <p:spPr>
+          <a:xfrm>
+            <a:off x="7498079" y="6172200"/>
+            <a:ext cx="4206240" cy="274320"/>
+          </a:xfrm>
+          <a:prstGeom prst="rect">
+            <a:avLst/>
+          </a:prstGeom>
+          <a:noFill/>
+        </p:spPr>
+        <p:txBody>
+          <a:bodyPr wrap="square">
+            <a:spAutoFit/>
+          </a:bodyPr>
+          <a:lstStyle/>
+          <a:p>
+            <a:pPr>
+              <a:defRPr sz="850" b="0" i="0">
+                <a:solidFill>
+                  <a:srgbClr val="6E6A5E"/>
+                </a:solidFill>
+                <a:latin typeface="Courier New"/>
+              </a:defRPr>
+            </a:pPr>
+            <a:r>
+              <a:t>EDA notebook §5 · regional speed context for the pooled categories</a:t>
+            </a:r>
+          </a:p>
+        </p:txBody>
+      </p:sp>
+      <p:sp>
+        <p:nvSpPr>
+          <p:cNvPr id="9" name="TextBox 8"/>
+          <p:cNvSpPr txBox="1"/>
+          <p:nvPr/>
+        </p:nvSpPr>
+        <p:spPr>
+          <a:xfrm>
+            <a:off x="685800" y="6446520"/>
+            <a:ext cx="8229600" cy="320040"/>
+          </a:xfrm>
+          <a:prstGeom prst="rect">
+            <a:avLst/>
+          </a:prstGeom>
+          <a:noFill/>
+        </p:spPr>
+        <p:txBody>
+          <a:bodyPr wrap="square">
+            <a:spAutoFit/>
+          </a:bodyPr>
+          <a:lstStyle/>
+          <a:p>
+            <a:pPr>
+              <a:defRPr sz="1000" b="0" i="0">
+                <a:solidFill>
+                  <a:srgbClr val="6E6A5E"/>
+                </a:solidFill>
+                <a:latin typeface="Courier New"/>
+              </a:defRPr>
+            </a:pPr>
+            <a:r>
+              <a:t>Cultural Blend · Kiva 2016–2025 · 1.45M loans</a:t>
+            </a:r>
+          </a:p>
+        </p:txBody>
+      </p:sp>
+    </p:spTree>
+  </p:cSld>
+  <p:clrMapOvr>
+    <a:masterClrMapping/>
+  </p:clrMapOvr>
+</p:sld>
+</file>
+
+<file path=ppt/slides/slide13.xml><?xml version="1.0" encoding="utf-8"?>
+<p:sld xmlns:a="http://schemas.openxmlformats.org/drawingml/2006/main" xmlns:p="http://schemas.openxmlformats.org/presentationml/2006/main" xmlns:r="http://schemas.openxmlformats.org/officeDocument/2006/relationships">
+  <p:cSld>
+    <p:bg>
+      <p:bgPr>
+        <a:solidFill>
+          <a:srgbClr val="FAF7F0"/>
+        </a:solidFill>
+        <a:effectLst/>
+      </p:bgPr>
+    </p:bg>
+    <p:spTree>
+      <p:nvGrpSpPr>
+        <p:cNvPr id="1" name=""/>
+        <p:cNvGrpSpPr/>
+        <p:nvPr/>
+      </p:nvGrpSpPr>
+      <p:grpSpPr/>
+      <p:sp>
+        <p:nvSpPr>
+          <p:cNvPr id="2" name="TextBox 1"/>
+          <p:cNvSpPr txBox="1"/>
+          <p:nvPr/>
+        </p:nvSpPr>
+        <p:spPr>
+          <a:xfrm>
+            <a:off x="685800" y="384048"/>
+            <a:ext cx="8229600" cy="320040"/>
+          </a:xfrm>
+          <a:prstGeom prst="rect">
+            <a:avLst/>
+          </a:prstGeom>
+          <a:noFill/>
+        </p:spPr>
+        <p:txBody>
+          <a:bodyPr wrap="square">
+            <a:spAutoFit/>
+          </a:bodyPr>
+          <a:lstStyle/>
+          <a:p>
+            <a:pPr>
+              <a:defRPr sz="1150" b="0" i="0">
+                <a:solidFill>
+                  <a:srgbClr val="C97B3D"/>
+                </a:solidFill>
+                <a:latin typeface="Courier New"/>
+              </a:defRPr>
+            </a:pPr>
+            <a:r>
+              <a:t>APPENDIX · A2</a:t>
+            </a:r>
+          </a:p>
+        </p:txBody>
+      </p:sp>
+      <p:sp>
+        <p:nvSpPr>
+          <p:cNvPr id="3" name="Rounded Rectangle 2"/>
+          <p:cNvSpPr/>
+          <p:nvPr/>
+        </p:nvSpPr>
+        <p:spPr>
+          <a:xfrm>
+            <a:off x="11109960" y="365760"/>
+            <a:ext cx="658368" cy="347472"/>
+          </a:xfrm>
+          <a:prstGeom prst="roundRect">
+            <a:avLst/>
+          </a:prstGeom>
+          <a:solidFill>
+            <a:srgbClr val="1F4E5F"/>
+          </a:solidFill>
+          <a:ln>
+            <a:noFill/>
+          </a:ln>
+          <a:effectLst/>
+        </p:spPr>
+        <p:style>
+          <a:lnRef idx="1">
+            <a:schemeClr val="accent1"/>
+          </a:lnRef>
+          <a:fillRef idx="3">
+            <a:schemeClr val="accent1"/>
+          </a:fillRef>
+          <a:effectRef idx="2">
+            <a:schemeClr val="accent1"/>
+          </a:effectRef>
+          <a:fontRef idx="minor">
+            <a:schemeClr val="lt1"/>
+          </a:fontRef>
+        </p:style>
+        <p:txBody>
+          <a:bodyPr rtlCol="0" anchor="ctr" tIns="0" bIns="0"/>
+          <a:lstStyle/>
+          <a:p>
+            <a:pPr algn="ctr">
+              <a:defRPr sz="1200" b="0" i="0">
+                <a:solidFill>
+                  <a:srgbClr val="FAF7F0"/>
+                </a:solidFill>
+                <a:latin typeface="Courier New"/>
+              </a:defRPr>
+            </a:pPr>
+            <a:r>
+              <a:t>A2</a:t>
+            </a:r>
+          </a:p>
+        </p:txBody>
+      </p:sp>
+      <p:sp>
+        <p:nvSpPr>
+          <p:cNvPr id="4" name="TextBox 3"/>
+          <p:cNvSpPr txBox="1"/>
+          <p:nvPr/>
+        </p:nvSpPr>
+        <p:spPr>
+          <a:xfrm>
+            <a:off x="640080" y="713232"/>
+            <a:ext cx="10332720" cy="914400"/>
+          </a:xfrm>
+          <a:prstGeom prst="rect">
+            <a:avLst/>
+          </a:prstGeom>
+          <a:noFill/>
+        </p:spPr>
+        <p:txBody>
+          <a:bodyPr wrap="square">
+            <a:spAutoFit/>
+          </a:bodyPr>
+          <a:lstStyle/>
+          <a:p>
+            <a:pPr>
+              <a:defRPr sz="3600" b="1" i="0">
+                <a:solidFill>
+                  <a:srgbClr val="1E2A2F"/>
+                </a:solidFill>
+                <a:latin typeface="Georgia"/>
+              </a:defRPr>
+            </a:pPr>
+            <a:r>
+              <a:t>Predictive weight ≠ statistical robustness</a:t>
+            </a:r>
+          </a:p>
+        </p:txBody>
+      </p:sp>
+      <p:sp>
+        <p:nvSpPr>
+          <p:cNvPr id="5" name="Rectangle 4"/>
+          <p:cNvSpPr/>
+          <p:nvPr/>
+        </p:nvSpPr>
+        <p:spPr>
+          <a:xfrm>
+            <a:off x="685800" y="1481328"/>
+            <a:ext cx="1234440" cy="44450"/>
+          </a:xfrm>
+          <a:prstGeom prst="rect">
+            <a:avLst/>
+          </a:prstGeom>
+          <a:solidFill>
+            <a:srgbClr val="C97B3D"/>
+          </a:solidFill>
+          <a:ln>
+            <a:noFill/>
+          </a:ln>
+          <a:effectLst/>
+        </p:spPr>
+        <p:style>
+          <a:lnRef idx="1">
+            <a:schemeClr val="accent1"/>
+          </a:lnRef>
+          <a:fillRef idx="3">
+            <a:schemeClr val="accent1"/>
+          </a:fillRef>
+          <a:effectRef idx="2">
+            <a:schemeClr val="accent1"/>
+          </a:effectRef>
+          <a:fontRef idx="minor">
+            <a:schemeClr val="lt1"/>
+          </a:fontRef>
+        </p:style>
+        <p:txBody>
+          <a:bodyPr rtlCol="0" anchor="ctr"/>
+          <a:lstStyle/>
+          <a:p>
+            <a:pPr algn="ctr"/>
+          </a:p>
+        </p:txBody>
+      </p:sp>
+      <p:sp>
+        <p:nvSpPr>
+          <p:cNvPr id="6" name="TextBox 5"/>
+          <p:cNvSpPr txBox="1"/>
+          <p:nvPr/>
+        </p:nvSpPr>
+        <p:spPr>
+          <a:xfrm>
+            <a:off x="685800" y="1783080"/>
+            <a:ext cx="6720840" cy="4526280"/>
+          </a:xfrm>
+          <a:prstGeom prst="rect">
+            <a:avLst/>
+          </a:prstGeom>
+          <a:noFill/>
+        </p:spPr>
+        <p:txBody>
+          <a:bodyPr wrap="square">
+            <a:spAutoFit/>
+          </a:bodyPr>
+          <a:lstStyle/>
+          <a:p>
+            <a:pPr>
+              <a:lnSpc>
+                <a:spcPct val="115000"/>
+              </a:lnSpc>
+              <a:spcAft>
+                <a:spcPts val="1200"/>
+              </a:spcAft>
+            </a:pPr>
+            <a:r>
+              <a:rPr sz="1600">
+                <a:solidFill>
+                  <a:srgbClr val="C97B3D"/>
+                </a:solidFill>
+                <a:latin typeface="Avenir Next"/>
+              </a:rPr>
+              <a:t>▪  </a:t>
+            </a:r>
+            <a:r>
+              <a:rPr sz="1650">
+                <a:solidFill>
+                  <a:srgbClr val="1E2A2F"/>
+                </a:solidFill>
+                <a:latin typeface="Avenir Next"/>
+              </a:rPr>
+              <a:t>SHAP importance from the boosted forecasting model: structure fills the top ranks (amount, term, period, size band, sector, gender).</a:t>
+            </a:r>
+          </a:p>
+          <a:p>
+            <a:pPr>
+              <a:lnSpc>
+                <a:spcPct val="115000"/>
+              </a:lnSpc>
+              <a:spcAft>
+                <a:spcPts val="1200"/>
+              </a:spcAft>
+            </a:pPr>
+            <a:r>
+              <a:rPr sz="1600">
+                <a:solidFill>
+                  <a:srgbClr val="C97B3D"/>
+                </a:solidFill>
+                <a:latin typeface="Avenir Next"/>
+              </a:rPr>
+              <a:t>▪  </a:t>
+            </a:r>
+            <a:r>
+              <a:rPr sz="1650">
+                <a:solidFill>
+                  <a:srgbClr val="1E2A2F"/>
+                </a:solidFill>
+                <a:latin typeface="Avenir Next"/>
+              </a:rPr>
+              <a:t>No family, agency, or urgency feature reaches the top 15; sentiment is 11th despite its disputed significance.</a:t>
+            </a:r>
+          </a:p>
+          <a:p>
+            <a:pPr>
+              <a:lnSpc>
+                <a:spcPct val="115000"/>
+              </a:lnSpc>
+              <a:spcAft>
+                <a:spcPts val="1200"/>
+              </a:spcAft>
+            </a:pPr>
+            <a:r>
+              <a:rPr sz="1600">
+                <a:solidFill>
+                  <a:srgbClr val="C97B3D"/>
+                </a:solidFill>
+                <a:latin typeface="Avenir Next"/>
+              </a:rPr>
+              <a:t>▪  </a:t>
+            </a:r>
+            <a:r>
+              <a:rPr sz="1650">
+                <a:solidFill>
+                  <a:srgbClr val="1E2A2F"/>
+                </a:solidFill>
+                <a:latin typeface="Avenir Next"/>
+              </a:rPr>
+              <a:t>Complementary predictive evidence only — a different model, no region interactions; it cannot confirm or refute any coefficient's sign or uncertainty.</a:t>
+            </a:r>
+          </a:p>
+        </p:txBody>
+      </p:sp>
+      <p:pic>
+        <p:nvPicPr>
+          <p:cNvPr id="7" name="Picture 6" descr="mod_39.png"/>
+          <p:cNvPicPr>
+            <a:picLocks noChangeAspect="1"/>
+          </p:cNvPicPr>
+          <p:nvPr/>
+        </p:nvPicPr>
+        <p:blipFill>
+          <a:blip r:embed="rId2"/>
+          <a:stretch>
+            <a:fillRect/>
+          </a:stretch>
+        </p:blipFill>
+        <p:spPr>
+          <a:xfrm>
+            <a:off x="7498079" y="1783080"/>
+            <a:ext cx="4069080" cy="2700514"/>
+          </a:xfrm>
+          <a:prstGeom prst="rect">
+            <a:avLst/>
+          </a:prstGeom>
+        </p:spPr>
+      </p:pic>
+      <p:sp>
+        <p:nvSpPr>
+          <p:cNvPr id="8" name="TextBox 7"/>
+          <p:cNvSpPr txBox="1"/>
+          <p:nvPr/>
+        </p:nvSpPr>
+        <p:spPr>
+          <a:xfrm>
+            <a:off x="7498079" y="6172200"/>
+            <a:ext cx="4206240" cy="274320"/>
+          </a:xfrm>
+          <a:prstGeom prst="rect">
+            <a:avLst/>
+          </a:prstGeom>
+          <a:noFill/>
+        </p:spPr>
+        <p:txBody>
+          <a:bodyPr wrap="square">
+            <a:spAutoFit/>
+          </a:bodyPr>
+          <a:lstStyle/>
+          <a:p>
+            <a:pPr>
+              <a:defRPr sz="850" b="0" i="0">
+                <a:solidFill>
+                  <a:srgbClr val="6E6A5E"/>
+                </a:solidFill>
+                <a:latin typeface="Courier New"/>
+              </a:defRPr>
+            </a:pPr>
+            <a:r>
+              <a:t>modeling notebook §8 · SHAP top-15</a:t>
+            </a:r>
+          </a:p>
+        </p:txBody>
+      </p:sp>
+      <p:sp>
+        <p:nvSpPr>
+          <p:cNvPr id="9" name="TextBox 8"/>
+          <p:cNvSpPr txBox="1"/>
+          <p:nvPr/>
+        </p:nvSpPr>
+        <p:spPr>
+          <a:xfrm>
+            <a:off x="685800" y="6446520"/>
+            <a:ext cx="8229600" cy="320040"/>
+          </a:xfrm>
+          <a:prstGeom prst="rect">
+            <a:avLst/>
+          </a:prstGeom>
+          <a:noFill/>
+        </p:spPr>
+        <p:txBody>
+          <a:bodyPr wrap="square">
+            <a:spAutoFit/>
+          </a:bodyPr>
+          <a:lstStyle/>
+          <a:p>
+            <a:pPr>
+              <a:defRPr sz="1000" b="0" i="0">
+                <a:solidFill>
+                  <a:srgbClr val="6E6A5E"/>
+                </a:solidFill>
+                <a:latin typeface="Courier New"/>
+              </a:defRPr>
+            </a:pPr>
+            <a:r>
+              <a:t>Cultural Blend · Kiva 2016–2025 · 1.45M loans</a:t>
+            </a:r>
+          </a:p>
+        </p:txBody>
+      </p:sp>
+    </p:spTree>
+  </p:cSld>
+  <p:clrMapOvr>
+    <a:masterClrMapping/>
+  </p:clrMapOvr>
+</p:sld>
+</file>
+
+<file path=ppt/slides/slide14.xml><?xml version="1.0" encoding="utf-8"?>
+<p:sld xmlns:a="http://schemas.openxmlformats.org/drawingml/2006/main" xmlns:p="http://schemas.openxmlformats.org/presentationml/2006/main" xmlns:r="http://schemas.openxmlformats.org/officeDocument/2006/relationships">
+  <p:cSld>
+    <p:bg>
+      <p:bgPr>
+        <a:solidFill>
+          <a:srgbClr val="FAF7F0"/>
+        </a:solidFill>
+        <a:effectLst/>
+      </p:bgPr>
+    </p:bg>
+    <p:spTree>
+      <p:nvGrpSpPr>
+        <p:cNvPr id="1" name=""/>
+        <p:cNvGrpSpPr/>
+        <p:nvPr/>
+      </p:nvGrpSpPr>
+      <p:grpSpPr/>
+      <p:sp>
+        <p:nvSpPr>
+          <p:cNvPr id="2" name="TextBox 1"/>
+          <p:cNvSpPr txBox="1"/>
+          <p:nvPr/>
+        </p:nvSpPr>
+        <p:spPr>
+          <a:xfrm>
+            <a:off x="685800" y="384048"/>
+            <a:ext cx="8229600" cy="320040"/>
+          </a:xfrm>
+          <a:prstGeom prst="rect">
+            <a:avLst/>
+          </a:prstGeom>
+          <a:noFill/>
+        </p:spPr>
+        <p:txBody>
+          <a:bodyPr wrap="square">
+            <a:spAutoFit/>
+          </a:bodyPr>
+          <a:lstStyle/>
+          <a:p>
+            <a:pPr>
+              <a:defRPr sz="1150" b="0" i="0">
+                <a:solidFill>
+                  <a:srgbClr val="C97B3D"/>
+                </a:solidFill>
+                <a:latin typeface="Courier New"/>
+              </a:defRPr>
+            </a:pPr>
+            <a:r>
+              <a:t>APPENDIX · A3</a:t>
+            </a:r>
+          </a:p>
+        </p:txBody>
+      </p:sp>
+      <p:sp>
+        <p:nvSpPr>
+          <p:cNvPr id="3" name="Rounded Rectangle 2"/>
+          <p:cNvSpPr/>
+          <p:nvPr/>
+        </p:nvSpPr>
+        <p:spPr>
+          <a:xfrm>
+            <a:off x="11109960" y="365760"/>
+            <a:ext cx="658368" cy="347472"/>
+          </a:xfrm>
+          <a:prstGeom prst="roundRect">
+            <a:avLst/>
+          </a:prstGeom>
+          <a:solidFill>
+            <a:srgbClr val="1F4E5F"/>
+          </a:solidFill>
+          <a:ln>
+            <a:noFill/>
+          </a:ln>
+          <a:effectLst/>
+        </p:spPr>
+        <p:style>
+          <a:lnRef idx="1">
+            <a:schemeClr val="accent1"/>
+          </a:lnRef>
+          <a:fillRef idx="3">
+            <a:schemeClr val="accent1"/>
+          </a:fillRef>
+          <a:effectRef idx="2">
+            <a:schemeClr val="accent1"/>
+          </a:effectRef>
+          <a:fontRef idx="minor">
+            <a:schemeClr val="lt1"/>
+          </a:fontRef>
+        </p:style>
+        <p:txBody>
+          <a:bodyPr rtlCol="0" anchor="ctr" tIns="0" bIns="0"/>
+          <a:lstStyle/>
+          <a:p>
+            <a:pPr algn="ctr">
+              <a:defRPr sz="1200" b="0" i="0">
+                <a:solidFill>
+                  <a:srgbClr val="FAF7F0"/>
+                </a:solidFill>
+                <a:latin typeface="Courier New"/>
+              </a:defRPr>
+            </a:pPr>
+            <a:r>
+              <a:t>A3</a:t>
+            </a:r>
+          </a:p>
+        </p:txBody>
+      </p:sp>
+      <p:sp>
+        <p:nvSpPr>
+          <p:cNvPr id="4" name="TextBox 3"/>
+          <p:cNvSpPr txBox="1"/>
+          <p:nvPr/>
+        </p:nvSpPr>
+        <p:spPr>
+          <a:xfrm>
+            <a:off x="640080" y="713232"/>
+            <a:ext cx="10332720" cy="914400"/>
+          </a:xfrm>
+          <a:prstGeom prst="rect">
+            <a:avLst/>
+          </a:prstGeom>
+          <a:noFill/>
+        </p:spPr>
+        <p:txBody>
+          <a:bodyPr wrap="square">
+            <a:spAutoFit/>
+          </a:bodyPr>
+          <a:lstStyle/>
+          <a:p>
+            <a:pPr>
+              <a:defRPr sz="3600" b="1" i="0">
+                <a:solidFill>
+                  <a:srgbClr val="1E2A2F"/>
+                </a:solidFill>
+                <a:latin typeface="Georgia"/>
+              </a:defRPr>
+            </a:pPr>
+            <a:r>
+              <a:t>Structure, dose-response</a:t>
+            </a:r>
+          </a:p>
+        </p:txBody>
+      </p:sp>
+      <p:sp>
+        <p:nvSpPr>
+          <p:cNvPr id="5" name="Rectangle 4"/>
+          <p:cNvSpPr/>
+          <p:nvPr/>
+        </p:nvSpPr>
+        <p:spPr>
+          <a:xfrm>
+            <a:off x="685800" y="1481328"/>
+            <a:ext cx="1234440" cy="44450"/>
+          </a:xfrm>
+          <a:prstGeom prst="rect">
+            <a:avLst/>
+          </a:prstGeom>
+          <a:solidFill>
+            <a:srgbClr val="C97B3D"/>
+          </a:solidFill>
+          <a:ln>
+            <a:noFill/>
+          </a:ln>
+          <a:effectLst/>
+        </p:spPr>
+        <p:style>
+          <a:lnRef idx="1">
+            <a:schemeClr val="accent1"/>
+          </a:lnRef>
+          <a:fillRef idx="3">
+            <a:schemeClr val="accent1"/>
+          </a:fillRef>
+          <a:effectRef idx="2">
+            <a:schemeClr val="accent1"/>
+          </a:effectRef>
+          <a:fontRef idx="minor">
+            <a:schemeClr val="lt1"/>
+          </a:fontRef>
+        </p:style>
+        <p:txBody>
+          <a:bodyPr rtlCol="0" anchor="ctr"/>
+          <a:lstStyle/>
+          <a:p>
+            <a:pPr algn="ctr"/>
+          </a:p>
+        </p:txBody>
+      </p:sp>
+      <p:sp>
+        <p:nvSpPr>
+          <p:cNvPr id="6" name="TextBox 5"/>
+          <p:cNvSpPr txBox="1"/>
+          <p:nvPr/>
+        </p:nvSpPr>
+        <p:spPr>
+          <a:xfrm>
+            <a:off x="685800" y="1783080"/>
+            <a:ext cx="6720840" cy="4526280"/>
+          </a:xfrm>
+          <a:prstGeom prst="rect">
+            <a:avLst/>
+          </a:prstGeom>
+          <a:noFill/>
+        </p:spPr>
+        <p:txBody>
+          <a:bodyPr wrap="square">
+            <a:spAutoFit/>
+          </a:bodyPr>
+          <a:lstStyle/>
+          <a:p>
+            <a:pPr>
+              <a:lnSpc>
+                <a:spcPct val="115000"/>
+              </a:lnSpc>
+              <a:spcAft>
+                <a:spcPts val="1200"/>
+              </a:spcAft>
+            </a:pPr>
+            <a:r>
+              <a:rPr sz="1600">
+                <a:solidFill>
+                  <a:srgbClr val="C97B3D"/>
+                </a:solidFill>
+                <a:latin typeface="Avenir Next"/>
+              </a:rPr>
+              <a:t>▪  </a:t>
+            </a:r>
+            <a:r>
+              <a:rPr sz="1650">
+                <a:solidFill>
+                  <a:srgbClr val="1E2A2F"/>
+                </a:solidFill>
+                <a:latin typeface="Avenir Next"/>
+              </a:rPr>
+              <a:t>Funding speed rises almost monotonically across loan-amount deciles — small asks fund in ~2 days, the largest in ~18.</a:t>
+            </a:r>
+          </a:p>
+          <a:p>
+            <a:pPr>
+              <a:lnSpc>
+                <a:spcPct val="115000"/>
+              </a:lnSpc>
+              <a:spcAft>
+                <a:spcPts val="1200"/>
+              </a:spcAft>
+            </a:pPr>
+            <a:r>
+              <a:rPr sz="1600">
+                <a:solidFill>
+                  <a:srgbClr val="C97B3D"/>
+                </a:solidFill>
+                <a:latin typeface="Avenir Next"/>
+              </a:rPr>
+              <a:t>▪  </a:t>
+            </a:r>
+            <a:r>
+              <a:rPr sz="1650">
+                <a:solidFill>
+                  <a:srgbClr val="1E2A2F"/>
+                </a:solidFill>
+                <a:latin typeface="Avenir Next"/>
+              </a:rPr>
+              <a:t>Gender: female-posted median 2.3 days vs male 7.7 (the duration-model male coefficient +0.430 survives HC3 AND country clustering, p &lt; 0.0001 — still associational).</a:t>
+            </a:r>
+          </a:p>
+          <a:p>
+            <a:pPr>
+              <a:lnSpc>
+                <a:spcPct val="115000"/>
+              </a:lnSpc>
+              <a:spcAft>
+                <a:spcPts val="1200"/>
+              </a:spcAft>
+            </a:pPr>
+            <a:r>
+              <a:rPr sz="1600">
+                <a:solidFill>
+                  <a:srgbClr val="C97B3D"/>
+                </a:solidFill>
+                <a:latin typeface="Avenir Next"/>
+              </a:rPr>
+              <a:t>▪  </a:t>
+            </a:r>
+            <a:r>
+              <a:rPr sz="1650">
+                <a:solidFill>
+                  <a:srgbClr val="1E2A2F"/>
+                </a:solidFill>
+                <a:latin typeface="Avenir Next"/>
+              </a:rPr>
+              <a:t>This dose-response pattern is what the '~10x stronger than narrative' comparison rests on.</a:t>
+            </a:r>
+          </a:p>
+        </p:txBody>
+      </p:sp>
+      <p:pic>
+        <p:nvPicPr>
+          <p:cNvPr id="7" name="Picture 6" descr="eda_36.png"/>
+          <p:cNvPicPr>
+            <a:picLocks noChangeAspect="1"/>
+          </p:cNvPicPr>
+          <p:nvPr/>
+        </p:nvPicPr>
+        <p:blipFill>
+          <a:blip r:embed="rId2"/>
+          <a:stretch>
+            <a:fillRect/>
+          </a:stretch>
+        </p:blipFill>
+        <p:spPr>
+          <a:xfrm>
+            <a:off x="7498079" y="1783080"/>
+            <a:ext cx="4069080" cy="2266323"/>
+          </a:xfrm>
+          <a:prstGeom prst="rect">
+            <a:avLst/>
+          </a:prstGeom>
+        </p:spPr>
+      </p:pic>
+      <p:sp>
+        <p:nvSpPr>
+          <p:cNvPr id="8" name="TextBox 7"/>
+          <p:cNvSpPr txBox="1"/>
+          <p:nvPr/>
+        </p:nvSpPr>
+        <p:spPr>
+          <a:xfrm>
+            <a:off x="7498079" y="6172200"/>
+            <a:ext cx="4206240" cy="274320"/>
+          </a:xfrm>
+          <a:prstGeom prst="rect">
+            <a:avLst/>
+          </a:prstGeom>
+          <a:noFill/>
+        </p:spPr>
+        <p:txBody>
+          <a:bodyPr wrap="square">
+            <a:spAutoFit/>
+          </a:bodyPr>
+          <a:lstStyle/>
+          <a:p>
+            <a:pPr>
+              <a:defRPr sz="850" b="0" i="0">
+                <a:solidFill>
+                  <a:srgbClr val="6E6A5E"/>
+                </a:solidFill>
+                <a:latin typeface="Courier New"/>
+              </a:defRPr>
+            </a:pPr>
+            <a:r>
+              <a:t>EDA notebook §9 · speed by loan-amount decile</a:t>
+            </a:r>
+          </a:p>
+        </p:txBody>
+      </p:sp>
+      <p:sp>
+        <p:nvSpPr>
+          <p:cNvPr id="9" name="TextBox 8"/>
+          <p:cNvSpPr txBox="1"/>
+          <p:nvPr/>
+        </p:nvSpPr>
+        <p:spPr>
+          <a:xfrm>
+            <a:off x="685800" y="6446520"/>
+            <a:ext cx="8229600" cy="320040"/>
+          </a:xfrm>
+          <a:prstGeom prst="rect">
+            <a:avLst/>
+          </a:prstGeom>
+          <a:noFill/>
+        </p:spPr>
+        <p:txBody>
+          <a:bodyPr wrap="square">
+            <a:spAutoFit/>
+          </a:bodyPr>
+          <a:lstStyle/>
+          <a:p>
+            <a:pPr>
+              <a:defRPr sz="1000" b="0" i="0">
+                <a:solidFill>
+                  <a:srgbClr val="6E6A5E"/>
+                </a:solidFill>
+                <a:latin typeface="Courier New"/>
+              </a:defRPr>
+            </a:pPr>
+            <a:r>
+              <a:t>Cultural Blend · Kiva 2016–2025 · 1.45M loans</a:t>
+            </a:r>
+          </a:p>
+        </p:txBody>
+      </p:sp>
+    </p:spTree>
+  </p:cSld>
+  <p:clrMapOvr>
+    <a:masterClrMapping/>
+  </p:clrMapOvr>
+</p:sld>
+</file>
+
+<file path=ppt/slides/slide15.xml><?xml version="1.0" encoding="utf-8"?>
+<p:sld xmlns:a="http://schemas.openxmlformats.org/drawingml/2006/main" xmlns:p="http://schemas.openxmlformats.org/presentationml/2006/main" xmlns:r="http://schemas.openxmlformats.org/officeDocument/2006/relationships">
+  <p:cSld>
+    <p:bg>
+      <p:bgPr>
+        <a:solidFill>
+          <a:srgbClr val="FAF7F0"/>
+        </a:solidFill>
+        <a:effectLst/>
+      </p:bgPr>
+    </p:bg>
+    <p:spTree>
+      <p:nvGrpSpPr>
+        <p:cNvPr id="1" name=""/>
+        <p:cNvGrpSpPr/>
+        <p:nvPr/>
+      </p:nvGrpSpPr>
+      <p:grpSpPr/>
+      <p:sp>
+        <p:nvSpPr>
+          <p:cNvPr id="2" name="TextBox 1"/>
+          <p:cNvSpPr txBox="1"/>
+          <p:nvPr/>
+        </p:nvSpPr>
+        <p:spPr>
+          <a:xfrm>
+            <a:off x="685800" y="384048"/>
+            <a:ext cx="8229600" cy="320040"/>
+          </a:xfrm>
+          <a:prstGeom prst="rect">
+            <a:avLst/>
+          </a:prstGeom>
+          <a:noFill/>
+        </p:spPr>
+        <p:txBody>
+          <a:bodyPr wrap="square">
+            <a:spAutoFit/>
+          </a:bodyPr>
+          <a:lstStyle/>
+          <a:p>
+            <a:pPr>
+              <a:defRPr sz="1150" b="0" i="0">
+                <a:solidFill>
+                  <a:srgbClr val="C97B3D"/>
+                </a:solidFill>
+                <a:latin typeface="Courier New"/>
+              </a:defRPr>
+            </a:pPr>
+            <a:r>
+              <a:t>APPENDIX · A4</a:t>
+            </a:r>
+          </a:p>
+        </p:txBody>
+      </p:sp>
+      <p:sp>
+        <p:nvSpPr>
+          <p:cNvPr id="3" name="Rounded Rectangle 2"/>
+          <p:cNvSpPr/>
+          <p:nvPr/>
+        </p:nvSpPr>
+        <p:spPr>
+          <a:xfrm>
+            <a:off x="11109960" y="365760"/>
+            <a:ext cx="658368" cy="347472"/>
+          </a:xfrm>
+          <a:prstGeom prst="roundRect">
+            <a:avLst/>
+          </a:prstGeom>
+          <a:solidFill>
+            <a:srgbClr val="1F4E5F"/>
+          </a:solidFill>
+          <a:ln>
+            <a:noFill/>
+          </a:ln>
+          <a:effectLst/>
+        </p:spPr>
+        <p:style>
+          <a:lnRef idx="1">
+            <a:schemeClr val="accent1"/>
+          </a:lnRef>
+          <a:fillRef idx="3">
+            <a:schemeClr val="accent1"/>
+          </a:fillRef>
+          <a:effectRef idx="2">
+            <a:schemeClr val="accent1"/>
+          </a:effectRef>
+          <a:fontRef idx="minor">
+            <a:schemeClr val="lt1"/>
+          </a:fontRef>
+        </p:style>
+        <p:txBody>
+          <a:bodyPr rtlCol="0" anchor="ctr" tIns="0" bIns="0"/>
+          <a:lstStyle/>
+          <a:p>
+            <a:pPr algn="ctr">
+              <a:defRPr sz="1200" b="0" i="0">
+                <a:solidFill>
+                  <a:srgbClr val="FAF7F0"/>
+                </a:solidFill>
+                <a:latin typeface="Courier New"/>
+              </a:defRPr>
+            </a:pPr>
+            <a:r>
+              <a:t>A4</a:t>
+            </a:r>
+          </a:p>
+        </p:txBody>
+      </p:sp>
+      <p:sp>
+        <p:nvSpPr>
+          <p:cNvPr id="4" name="TextBox 3"/>
+          <p:cNvSpPr txBox="1"/>
+          <p:nvPr/>
+        </p:nvSpPr>
+        <p:spPr>
+          <a:xfrm>
+            <a:off x="640080" y="713232"/>
+            <a:ext cx="10332720" cy="914400"/>
+          </a:xfrm>
+          <a:prstGeom prst="rect">
+            <a:avLst/>
+          </a:prstGeom>
+          <a:noFill/>
+        </p:spPr>
+        <p:txBody>
+          <a:bodyPr wrap="square">
+            <a:spAutoFit/>
+          </a:bodyPr>
+          <a:lstStyle/>
+          <a:p>
+            <a:pPr>
+              <a:defRPr sz="3600" b="1" i="0">
+                <a:solidFill>
+                  <a:srgbClr val="1E2A2F"/>
+                </a:solidFill>
+                <a:latin typeface="Georgia"/>
+              </a:defRPr>
+            </a:pPr>
+            <a:r>
+              <a:t>24h classifier — operating detail</a:t>
+            </a:r>
+          </a:p>
+        </p:txBody>
+      </p:sp>
+      <p:sp>
+        <p:nvSpPr>
+          <p:cNvPr id="5" name="Rectangle 4"/>
+          <p:cNvSpPr/>
+          <p:nvPr/>
+        </p:nvSpPr>
+        <p:spPr>
+          <a:xfrm>
+            <a:off x="685800" y="1481328"/>
+            <a:ext cx="1234440" cy="44450"/>
+          </a:xfrm>
+          <a:prstGeom prst="rect">
+            <a:avLst/>
+          </a:prstGeom>
+          <a:solidFill>
+            <a:srgbClr val="C97B3D"/>
+          </a:solidFill>
+          <a:ln>
+            <a:noFill/>
+          </a:ln>
+          <a:effectLst/>
+        </p:spPr>
+        <p:style>
+          <a:lnRef idx="1">
+            <a:schemeClr val="accent1"/>
+          </a:lnRef>
+          <a:fillRef idx="3">
+            <a:schemeClr val="accent1"/>
+          </a:fillRef>
+          <a:effectRef idx="2">
+            <a:schemeClr val="accent1"/>
+          </a:effectRef>
+          <a:fontRef idx="minor">
+            <a:schemeClr val="lt1"/>
+          </a:fontRef>
+        </p:style>
+        <p:txBody>
+          <a:bodyPr rtlCol="0" anchor="ctr"/>
+          <a:lstStyle/>
+          <a:p>
+            <a:pPr algn="ctr"/>
+          </a:p>
+        </p:txBody>
+      </p:sp>
+      <p:sp>
+        <p:nvSpPr>
+          <p:cNvPr id="6" name="TextBox 5"/>
+          <p:cNvSpPr txBox="1"/>
+          <p:nvPr/>
+        </p:nvSpPr>
+        <p:spPr>
+          <a:xfrm>
+            <a:off x="685800" y="1783080"/>
+            <a:ext cx="11064240" cy="4526280"/>
+          </a:xfrm>
+          <a:prstGeom prst="rect">
+            <a:avLst/>
+          </a:prstGeom>
+          <a:noFill/>
+        </p:spPr>
+        <p:txBody>
+          <a:bodyPr wrap="square">
+            <a:spAutoFit/>
+          </a:bodyPr>
+          <a:lstStyle/>
+          <a:p>
+            <a:pPr>
+              <a:lnSpc>
+                <a:spcPct val="115000"/>
+              </a:lnSpc>
+              <a:spcAft>
+                <a:spcPts val="1200"/>
+              </a:spcAft>
+            </a:pPr>
+            <a:r>
+              <a:rPr sz="1600">
+                <a:solidFill>
+                  <a:srgbClr val="C97B3D"/>
+                </a:solidFill>
+                <a:latin typeface="Avenir Next"/>
+              </a:rPr>
+              <a:t>▪  </a:t>
+            </a:r>
+            <a:r>
+              <a:rPr sz="1650">
+                <a:solidFill>
+                  <a:srgbClr val="1E2A2F"/>
+                </a:solidFill>
+                <a:latin typeface="Avenir Next"/>
+              </a:rPr>
+              <a:t>Holdout (posted 2024-01-01 onward): 278,887 loans; 87,466 funded within 24h vs 191,421 not.</a:t>
+            </a:r>
+          </a:p>
+          <a:p>
+            <a:pPr>
+              <a:lnSpc>
+                <a:spcPct val="115000"/>
+              </a:lnSpc>
+              <a:spcAft>
+                <a:spcPts val="1200"/>
+              </a:spcAft>
+            </a:pPr>
+            <a:r>
+              <a:rPr sz="1600">
+                <a:solidFill>
+                  <a:srgbClr val="C97B3D"/>
+                </a:solidFill>
+                <a:latin typeface="Avenir Next"/>
+              </a:rPr>
+              <a:t>▪  </a:t>
+            </a:r>
+            <a:r>
+              <a:rPr sz="1650">
+                <a:solidFill>
+                  <a:srgbClr val="1E2A2F"/>
+                </a:solidFill>
+                <a:latin typeface="Avenir Next"/>
+              </a:rPr>
+              <a:t>ROC AUC 0.8997 · average precision 0.8301 · Brier 0.1156 · accuracy 0.840 — no narrative features needed.</a:t>
+            </a:r>
+          </a:p>
+          <a:p>
+            <a:pPr>
+              <a:lnSpc>
+                <a:spcPct val="115000"/>
+              </a:lnSpc>
+              <a:spcAft>
+                <a:spcPts val="1200"/>
+              </a:spcAft>
+            </a:pPr>
+            <a:r>
+              <a:rPr sz="1600">
+                <a:solidFill>
+                  <a:srgbClr val="C97B3D"/>
+                </a:solidFill>
+                <a:latin typeface="Avenir Next"/>
+              </a:rPr>
+              <a:t>▪  </a:t>
+            </a:r>
+            <a:r>
+              <a:rPr sz="1650">
+                <a:solidFill>
+                  <a:srgbClr val="1E2A2F"/>
+                </a:solidFill>
+                <a:latin typeface="Avenir Next"/>
+              </a:rPr>
+              <a:t>Boundary: negative class = 'eventually funded, but not within 24h'. Expired/withdrawn listings never enter the data — a retrospective ranking prototype among eventual funders.</a:t>
+            </a:r>
+          </a:p>
+          <a:p>
+            <a:pPr>
+              <a:lnSpc>
+                <a:spcPct val="115000"/>
+              </a:lnSpc>
+              <a:spcAft>
+                <a:spcPts val="1200"/>
+              </a:spcAft>
+            </a:pPr>
+            <a:r>
+              <a:rPr sz="1600">
+                <a:solidFill>
+                  <a:srgbClr val="C97B3D"/>
+                </a:solidFill>
+                <a:latin typeface="Avenir Next"/>
+              </a:rPr>
+              <a:t>▪  </a:t>
+            </a:r>
+            <a:r>
+              <a:rPr sz="1650">
+                <a:solidFill>
+                  <a:srgbClr val="1E2A2F"/>
+                </a:solidFill>
+                <a:latin typeface="Avenir Next"/>
+              </a:rPr>
+              <a:t>Path to deployment: all posted listings incl. expired/withdrawn outcomes -&gt; define operational target + censoring window -&gt; retrain, validate -&gt; threshold, calibration, fairness, prospective test.</a:t>
+            </a:r>
+          </a:p>
+        </p:txBody>
+      </p:sp>
+      <p:sp>
+        <p:nvSpPr>
+          <p:cNvPr id="7" name="TextBox 6"/>
+          <p:cNvSpPr txBox="1"/>
+          <p:nvPr/>
+        </p:nvSpPr>
+        <p:spPr>
+          <a:xfrm>
+            <a:off x="685800" y="6446520"/>
+            <a:ext cx="8229600" cy="320040"/>
+          </a:xfrm>
+          <a:prstGeom prst="rect">
+            <a:avLst/>
+          </a:prstGeom>
+          <a:noFill/>
+        </p:spPr>
+        <p:txBody>
+          <a:bodyPr wrap="square">
+            <a:spAutoFit/>
+          </a:bodyPr>
+          <a:lstStyle/>
+          <a:p>
+            <a:pPr>
+              <a:defRPr sz="1000" b="0" i="0">
+                <a:solidFill>
+                  <a:srgbClr val="6E6A5E"/>
+                </a:solidFill>
+                <a:latin typeface="Courier New"/>
+              </a:defRPr>
+            </a:pPr>
+            <a:r>
+              <a:t>Cultural Blend · Kiva 2016–2025 · 1.45M loans</a:t>
             </a:r>
           </a:p>
         </p:txBody>

</xml_diff>

<commit_message>
docs: restyle deck + exhibits in the team palette (navy / viridis / #FFDD04)
New committed scripts/build_charts.py regenerates the five scripted
exhibits from verified printed values in the deck palette: viridis
sequential where order is the message (topics), navy base + one yellow
highlight group where emphasis is (period, SHAP sentiment, narrative
correlations), viridis-purple table header with pale-yellow ME/CA rows.
Generator palette matched (yellow as shape/chip colour only, never text
on light). All five exhibits visually verified; deck rebuilt, QA clean.

Co-Authored-By: Claude Fable 5 <noreply@anthropic.com>
</commit_message>
<xml_diff>
--- a/docs/presentation/slides_draft.pptx
+++ b/docs/presentation/slides_draft.pptx
@@ -4588,7 +4588,7 @@
     <p:bg>
       <p:bgPr>
         <a:solidFill>
-          <a:srgbClr val="1F4E5F"/>
+          <a:srgbClr val="1C2333"/>
         </a:solidFill>
         <a:effectLst/>
       </p:bgPr>
@@ -4615,7 +4615,7 @@
             <a:avLst/>
           </a:prstGeom>
           <a:solidFill>
-            <a:srgbClr val="C97B3D"/>
+            <a:srgbClr val="FFDD04"/>
           </a:solidFill>
           <a:ln>
             <a:noFill/>
@@ -4669,7 +4669,7 @@
             <a:pPr>
               <a:defRPr sz="1300" b="0" i="0">
                 <a:solidFill>
-                  <a:srgbClr val="C97B3D"/>
+                  <a:srgbClr val="FFDD04"/>
                 </a:solidFill>
                 <a:latin typeface="Courier New"/>
               </a:defRPr>
@@ -4705,7 +4705,7 @@
             <a:pPr>
               <a:defRPr sz="6600" b="1" i="0">
                 <a:solidFill>
-                  <a:srgbClr val="FAF7F0"/>
+                  <a:srgbClr val="FBFAF6"/>
                 </a:solidFill>
                 <a:latin typeface="Georgia"/>
               </a:defRPr>
@@ -4802,7 +4802,7 @@
     <p:bg>
       <p:bgPr>
         <a:solidFill>
-          <a:srgbClr val="1F4E5F"/>
+          <a:srgbClr val="1C2333"/>
         </a:solidFill>
         <a:effectLst/>
       </p:bgPr>
@@ -4829,7 +4829,7 @@
             <a:avLst/>
           </a:prstGeom>
           <a:solidFill>
-            <a:srgbClr val="C97B3D"/>
+            <a:srgbClr val="FFDD04"/>
           </a:solidFill>
           <a:ln>
             <a:noFill/>
@@ -4883,7 +4883,7 @@
             <a:pPr algn="ctr">
               <a:defRPr sz="4200" b="1" i="0">
                 <a:solidFill>
-                  <a:srgbClr val="FAF7F0"/>
+                  <a:srgbClr val="FBFAF6"/>
                 </a:solidFill>
                 <a:latin typeface="Georgia"/>
               </a:defRPr>
@@ -4896,7 +4896,7 @@
             <a:pPr algn="ctr">
               <a:defRPr sz="4200" b="1" i="0">
                 <a:solidFill>
-                  <a:srgbClr val="FAF7F0"/>
+                  <a:srgbClr val="FBFAF6"/>
                 </a:solidFill>
                 <a:latin typeface="Georgia"/>
               </a:defRPr>
@@ -4993,7 +4993,7 @@
     <p:bg>
       <p:bgPr>
         <a:solidFill>
-          <a:srgbClr val="1F4E5F"/>
+          <a:srgbClr val="1C2333"/>
         </a:solidFill>
         <a:effectLst/>
       </p:bgPr>
@@ -5020,7 +5020,7 @@
             <a:avLst/>
           </a:prstGeom>
           <a:solidFill>
-            <a:srgbClr val="C97B3D"/>
+            <a:srgbClr val="FFDD04"/>
           </a:solidFill>
           <a:ln>
             <a:noFill/>
@@ -5074,7 +5074,7 @@
             <a:pPr>
               <a:defRPr sz="5400" b="1" i="0">
                 <a:solidFill>
-                  <a:srgbClr val="FAF7F0"/>
+                  <a:srgbClr val="FBFAF6"/>
                 </a:solidFill>
                 <a:latin typeface="Georgia"/>
               </a:defRPr>
@@ -5135,7 +5135,7 @@
     <p:bg>
       <p:bgPr>
         <a:solidFill>
-          <a:srgbClr val="FAF7F0"/>
+          <a:srgbClr val="FBFAF6"/>
         </a:solidFill>
         <a:effectLst/>
       </p:bgPr>
@@ -5172,7 +5172,7 @@
             <a:pPr>
               <a:defRPr sz="1150" b="0" i="0">
                 <a:solidFill>
-                  <a:srgbClr val="C97B3D"/>
+                  <a:srgbClr val="31688E"/>
                 </a:solidFill>
                 <a:latin typeface="Courier New"/>
               </a:defRPr>
@@ -5198,7 +5198,7 @@
             <a:avLst/>
           </a:prstGeom>
           <a:solidFill>
-            <a:srgbClr val="1F4E5F"/>
+            <a:srgbClr val="1C2333"/>
           </a:solidFill>
           <a:ln>
             <a:noFill/>
@@ -5226,7 +5226,7 @@
             <a:pPr algn="ctr">
               <a:defRPr sz="1200" b="0" i="0">
                 <a:solidFill>
-                  <a:srgbClr val="FAF7F0"/>
+                  <a:srgbClr val="FFDD04"/>
                 </a:solidFill>
                 <a:latin typeface="Courier New"/>
               </a:defRPr>
@@ -5262,7 +5262,7 @@
             <a:pPr>
               <a:defRPr sz="3600" b="1" i="0">
                 <a:solidFill>
-                  <a:srgbClr val="1E2A2F"/>
+                  <a:srgbClr val="1C2333"/>
                 </a:solidFill>
                 <a:latin typeface="Georgia"/>
               </a:defRPr>
@@ -5288,7 +5288,7 @@
             <a:avLst/>
           </a:prstGeom>
           <a:solidFill>
-            <a:srgbClr val="C97B3D"/>
+            <a:srgbClr val="FFDD04"/>
           </a:solidFill>
           <a:ln>
             <a:noFill/>
@@ -5350,7 +5350,7 @@
             <a:r>
               <a:rPr sz="1600">
                 <a:solidFill>
-                  <a:srgbClr val="C97B3D"/>
+                  <a:srgbClr val="FFDD04"/>
                 </a:solidFill>
                 <a:latin typeface="Avenir Next"/>
               </a:rPr>
@@ -5359,7 +5359,7 @@
             <a:r>
               <a:rPr sz="1650">
                 <a:solidFill>
-                  <a:srgbClr val="1E2A2F"/>
+                  <a:srgbClr val="1C2333"/>
                 </a:solidFill>
                 <a:latin typeface="Avenir Next"/>
               </a:rPr>
@@ -5378,7 +5378,7 @@
             <a:r>
               <a:rPr sz="1600">
                 <a:solidFill>
-                  <a:srgbClr val="C97B3D"/>
+                  <a:srgbClr val="FFDD04"/>
                 </a:solidFill>
                 <a:latin typeface="Avenir Next"/>
               </a:rPr>
@@ -5387,7 +5387,7 @@
             <a:r>
               <a:rPr sz="1650">
                 <a:solidFill>
-                  <a:srgbClr val="1E2A2F"/>
+                  <a:srgbClr val="1C2333"/>
                 </a:solidFill>
                 <a:latin typeface="Avenir Next"/>
               </a:rPr>
@@ -5406,7 +5406,7 @@
             <a:r>
               <a:rPr sz="1600">
                 <a:solidFill>
-                  <a:srgbClr val="C97B3D"/>
+                  <a:srgbClr val="FFDD04"/>
                 </a:solidFill>
                 <a:latin typeface="Avenir Next"/>
               </a:rPr>
@@ -5415,7 +5415,7 @@
             <a:r>
               <a:rPr sz="1650">
                 <a:solidFill>
-                  <a:srgbClr val="1E2A2F"/>
+                  <a:srgbClr val="1C2333"/>
                 </a:solidFill>
                 <a:latin typeface="Avenir Next"/>
               </a:rPr>
@@ -5434,7 +5434,7 @@
             <a:r>
               <a:rPr sz="1600">
                 <a:solidFill>
-                  <a:srgbClr val="C97B3D"/>
+                  <a:srgbClr val="FFDD04"/>
                 </a:solidFill>
                 <a:latin typeface="Avenir Next"/>
               </a:rPr>
@@ -5443,7 +5443,7 @@
             <a:r>
               <a:rPr sz="1650">
                 <a:solidFill>
-                  <a:srgbClr val="1E2A2F"/>
+                  <a:srgbClr val="1C2333"/>
                 </a:solidFill>
                 <a:latin typeface="Avenir Next"/>
               </a:rPr>
@@ -5501,7 +5501,7 @@
             <a:pPr>
               <a:defRPr sz="850" b="0" i="0">
                 <a:solidFill>
-                  <a:srgbClr val="6E6A5E"/>
+                  <a:srgbClr val="6E7278"/>
                 </a:solidFill>
                 <a:latin typeface="Courier New"/>
               </a:defRPr>
@@ -5537,7 +5537,7 @@
             <a:pPr>
               <a:defRPr sz="1000" b="0" i="0">
                 <a:solidFill>
-                  <a:srgbClr val="6E6A5E"/>
+                  <a:srgbClr val="6E7278"/>
                 </a:solidFill>
                 <a:latin typeface="Courier New"/>
               </a:defRPr>
@@ -5562,7 +5562,7 @@
     <p:bg>
       <p:bgPr>
         <a:solidFill>
-          <a:srgbClr val="FAF7F0"/>
+          <a:srgbClr val="FBFAF6"/>
         </a:solidFill>
         <a:effectLst/>
       </p:bgPr>
@@ -5599,7 +5599,7 @@
             <a:pPr>
               <a:defRPr sz="1150" b="0" i="0">
                 <a:solidFill>
-                  <a:srgbClr val="C97B3D"/>
+                  <a:srgbClr val="31688E"/>
                 </a:solidFill>
                 <a:latin typeface="Courier New"/>
               </a:defRPr>
@@ -5625,7 +5625,7 @@
             <a:avLst/>
           </a:prstGeom>
           <a:solidFill>
-            <a:srgbClr val="1F4E5F"/>
+            <a:srgbClr val="1C2333"/>
           </a:solidFill>
           <a:ln>
             <a:noFill/>
@@ -5653,7 +5653,7 @@
             <a:pPr algn="ctr">
               <a:defRPr sz="1200" b="0" i="0">
                 <a:solidFill>
-                  <a:srgbClr val="FAF7F0"/>
+                  <a:srgbClr val="FFDD04"/>
                 </a:solidFill>
                 <a:latin typeface="Courier New"/>
               </a:defRPr>
@@ -5689,7 +5689,7 @@
             <a:pPr>
               <a:defRPr sz="3600" b="1" i="0">
                 <a:solidFill>
-                  <a:srgbClr val="1E2A2F"/>
+                  <a:srgbClr val="1C2333"/>
                 </a:solidFill>
                 <a:latin typeface="Georgia"/>
               </a:defRPr>
@@ -5715,7 +5715,7 @@
             <a:avLst/>
           </a:prstGeom>
           <a:solidFill>
-            <a:srgbClr val="C97B3D"/>
+            <a:srgbClr val="FFDD04"/>
           </a:solidFill>
           <a:ln>
             <a:noFill/>
@@ -5777,7 +5777,7 @@
             <a:r>
               <a:rPr sz="1600">
                 <a:solidFill>
-                  <a:srgbClr val="C97B3D"/>
+                  <a:srgbClr val="FFDD04"/>
                 </a:solidFill>
                 <a:latin typeface="Avenir Next"/>
               </a:rPr>
@@ -5786,7 +5786,7 @@
             <a:r>
               <a:rPr sz="1650">
                 <a:solidFill>
-                  <a:srgbClr val="1E2A2F"/>
+                  <a:srgbClr val="1C2333"/>
                 </a:solidFill>
                 <a:latin typeface="Avenir Next"/>
               </a:rPr>
@@ -5805,7 +5805,7 @@
             <a:r>
               <a:rPr sz="1600">
                 <a:solidFill>
-                  <a:srgbClr val="C97B3D"/>
+                  <a:srgbClr val="FFDD04"/>
                 </a:solidFill>
                 <a:latin typeface="Avenir Next"/>
               </a:rPr>
@@ -5814,7 +5814,7 @@
             <a:r>
               <a:rPr sz="1650">
                 <a:solidFill>
-                  <a:srgbClr val="1E2A2F"/>
+                  <a:srgbClr val="1C2333"/>
                 </a:solidFill>
                 <a:latin typeface="Avenir Next"/>
               </a:rPr>
@@ -5833,7 +5833,7 @@
             <a:r>
               <a:rPr sz="1600">
                 <a:solidFill>
-                  <a:srgbClr val="C97B3D"/>
+                  <a:srgbClr val="FFDD04"/>
                 </a:solidFill>
                 <a:latin typeface="Avenir Next"/>
               </a:rPr>
@@ -5842,7 +5842,7 @@
             <a:r>
               <a:rPr sz="1650">
                 <a:solidFill>
-                  <a:srgbClr val="1E2A2F"/>
+                  <a:srgbClr val="1C2333"/>
                 </a:solidFill>
                 <a:latin typeface="Avenir Next"/>
               </a:rPr>
@@ -5900,7 +5900,7 @@
             <a:pPr>
               <a:defRPr sz="850" b="0" i="0">
                 <a:solidFill>
-                  <a:srgbClr val="6E6A5E"/>
+                  <a:srgbClr val="6E7278"/>
                 </a:solidFill>
                 <a:latin typeface="Courier New"/>
               </a:defRPr>
@@ -5936,7 +5936,7 @@
             <a:pPr>
               <a:defRPr sz="1000" b="0" i="0">
                 <a:solidFill>
-                  <a:srgbClr val="6E6A5E"/>
+                  <a:srgbClr val="6E7278"/>
                 </a:solidFill>
                 <a:latin typeface="Courier New"/>
               </a:defRPr>
@@ -5961,7 +5961,7 @@
     <p:bg>
       <p:bgPr>
         <a:solidFill>
-          <a:srgbClr val="FAF7F0"/>
+          <a:srgbClr val="FBFAF6"/>
         </a:solidFill>
         <a:effectLst/>
       </p:bgPr>
@@ -5998,7 +5998,7 @@
             <a:pPr>
               <a:defRPr sz="1150" b="0" i="0">
                 <a:solidFill>
-                  <a:srgbClr val="C97B3D"/>
+                  <a:srgbClr val="31688E"/>
                 </a:solidFill>
                 <a:latin typeface="Courier New"/>
               </a:defRPr>
@@ -6024,7 +6024,7 @@
             <a:avLst/>
           </a:prstGeom>
           <a:solidFill>
-            <a:srgbClr val="1F4E5F"/>
+            <a:srgbClr val="1C2333"/>
           </a:solidFill>
           <a:ln>
             <a:noFill/>
@@ -6052,7 +6052,7 @@
             <a:pPr algn="ctr">
               <a:defRPr sz="1200" b="0" i="0">
                 <a:solidFill>
-                  <a:srgbClr val="FAF7F0"/>
+                  <a:srgbClr val="FFDD04"/>
                 </a:solidFill>
                 <a:latin typeface="Courier New"/>
               </a:defRPr>
@@ -6088,7 +6088,7 @@
             <a:pPr>
               <a:defRPr sz="3600" b="1" i="0">
                 <a:solidFill>
-                  <a:srgbClr val="1E2A2F"/>
+                  <a:srgbClr val="1C2333"/>
                 </a:solidFill>
                 <a:latin typeface="Georgia"/>
               </a:defRPr>
@@ -6114,7 +6114,7 @@
             <a:avLst/>
           </a:prstGeom>
           <a:solidFill>
-            <a:srgbClr val="C97B3D"/>
+            <a:srgbClr val="FFDD04"/>
           </a:solidFill>
           <a:ln>
             <a:noFill/>
@@ -6176,7 +6176,7 @@
             <a:r>
               <a:rPr sz="1600">
                 <a:solidFill>
-                  <a:srgbClr val="C97B3D"/>
+                  <a:srgbClr val="FFDD04"/>
                 </a:solidFill>
                 <a:latin typeface="Avenir Next"/>
               </a:rPr>
@@ -6185,7 +6185,7 @@
             <a:r>
               <a:rPr sz="1650">
                 <a:solidFill>
-                  <a:srgbClr val="1E2A2F"/>
+                  <a:srgbClr val="1C2333"/>
                 </a:solidFill>
                 <a:latin typeface="Avenir Next"/>
               </a:rPr>
@@ -6204,7 +6204,7 @@
             <a:r>
               <a:rPr sz="1600">
                 <a:solidFill>
-                  <a:srgbClr val="C97B3D"/>
+                  <a:srgbClr val="FFDD04"/>
                 </a:solidFill>
                 <a:latin typeface="Avenir Next"/>
               </a:rPr>
@@ -6213,7 +6213,7 @@
             <a:r>
               <a:rPr sz="1650">
                 <a:solidFill>
-                  <a:srgbClr val="1E2A2F"/>
+                  <a:srgbClr val="1C2333"/>
                 </a:solidFill>
                 <a:latin typeface="Avenir Next"/>
               </a:rPr>
@@ -6232,7 +6232,7 @@
             <a:r>
               <a:rPr sz="1600">
                 <a:solidFill>
-                  <a:srgbClr val="C97B3D"/>
+                  <a:srgbClr val="FFDD04"/>
                 </a:solidFill>
                 <a:latin typeface="Avenir Next"/>
               </a:rPr>
@@ -6241,7 +6241,7 @@
             <a:r>
               <a:rPr sz="1650">
                 <a:solidFill>
-                  <a:srgbClr val="1E2A2F"/>
+                  <a:srgbClr val="1C2333"/>
                 </a:solidFill>
                 <a:latin typeface="Avenir Next"/>
               </a:rPr>
@@ -6299,7 +6299,7 @@
             <a:pPr>
               <a:defRPr sz="850" b="0" i="0">
                 <a:solidFill>
-                  <a:srgbClr val="6E6A5E"/>
+                  <a:srgbClr val="6E7278"/>
                 </a:solidFill>
                 <a:latin typeface="Courier New"/>
               </a:defRPr>
@@ -6335,7 +6335,7 @@
             <a:pPr>
               <a:defRPr sz="1000" b="0" i="0">
                 <a:solidFill>
-                  <a:srgbClr val="6E6A5E"/>
+                  <a:srgbClr val="6E7278"/>
                 </a:solidFill>
                 <a:latin typeface="Courier New"/>
               </a:defRPr>
@@ -6360,7 +6360,7 @@
     <p:bg>
       <p:bgPr>
         <a:solidFill>
-          <a:srgbClr val="FAF7F0"/>
+          <a:srgbClr val="FBFAF6"/>
         </a:solidFill>
         <a:effectLst/>
       </p:bgPr>
@@ -6397,7 +6397,7 @@
             <a:pPr>
               <a:defRPr sz="1150" b="0" i="0">
                 <a:solidFill>
-                  <a:srgbClr val="C97B3D"/>
+                  <a:srgbClr val="31688E"/>
                 </a:solidFill>
                 <a:latin typeface="Courier New"/>
               </a:defRPr>
@@ -6423,7 +6423,7 @@
             <a:avLst/>
           </a:prstGeom>
           <a:solidFill>
-            <a:srgbClr val="1F4E5F"/>
+            <a:srgbClr val="1C2333"/>
           </a:solidFill>
           <a:ln>
             <a:noFill/>
@@ -6451,7 +6451,7 @@
             <a:pPr algn="ctr">
               <a:defRPr sz="1200" b="0" i="0">
                 <a:solidFill>
-                  <a:srgbClr val="FAF7F0"/>
+                  <a:srgbClr val="FFDD04"/>
                 </a:solidFill>
                 <a:latin typeface="Courier New"/>
               </a:defRPr>
@@ -6487,7 +6487,7 @@
             <a:pPr>
               <a:defRPr sz="3600" b="1" i="0">
                 <a:solidFill>
-                  <a:srgbClr val="1E2A2F"/>
+                  <a:srgbClr val="1C2333"/>
                 </a:solidFill>
                 <a:latin typeface="Georgia"/>
               </a:defRPr>
@@ -6513,7 +6513,7 @@
             <a:avLst/>
           </a:prstGeom>
           <a:solidFill>
-            <a:srgbClr val="C97B3D"/>
+            <a:srgbClr val="FFDD04"/>
           </a:solidFill>
           <a:ln>
             <a:noFill/>
@@ -6575,7 +6575,7 @@
             <a:r>
               <a:rPr sz="1600">
                 <a:solidFill>
-                  <a:srgbClr val="C97B3D"/>
+                  <a:srgbClr val="FFDD04"/>
                 </a:solidFill>
                 <a:latin typeface="Avenir Next"/>
               </a:rPr>
@@ -6584,7 +6584,7 @@
             <a:r>
               <a:rPr sz="1650">
                 <a:solidFill>
-                  <a:srgbClr val="1E2A2F"/>
+                  <a:srgbClr val="1C2333"/>
                 </a:solidFill>
                 <a:latin typeface="Avenir Next"/>
               </a:rPr>
@@ -6603,7 +6603,7 @@
             <a:r>
               <a:rPr sz="1600">
                 <a:solidFill>
-                  <a:srgbClr val="C97B3D"/>
+                  <a:srgbClr val="FFDD04"/>
                 </a:solidFill>
                 <a:latin typeface="Avenir Next"/>
               </a:rPr>
@@ -6612,7 +6612,7 @@
             <a:r>
               <a:rPr sz="1650">
                 <a:solidFill>
-                  <a:srgbClr val="1E2A2F"/>
+                  <a:srgbClr val="1C2333"/>
                 </a:solidFill>
                 <a:latin typeface="Avenir Next"/>
               </a:rPr>
@@ -6631,7 +6631,7 @@
             <a:r>
               <a:rPr sz="1600">
                 <a:solidFill>
-                  <a:srgbClr val="C97B3D"/>
+                  <a:srgbClr val="FFDD04"/>
                 </a:solidFill>
                 <a:latin typeface="Avenir Next"/>
               </a:rPr>
@@ -6640,7 +6640,7 @@
             <a:r>
               <a:rPr sz="1650">
                 <a:solidFill>
-                  <a:srgbClr val="1E2A2F"/>
+                  <a:srgbClr val="1C2333"/>
                 </a:solidFill>
                 <a:latin typeface="Avenir Next"/>
               </a:rPr>
@@ -6659,7 +6659,7 @@
             <a:r>
               <a:rPr sz="1600">
                 <a:solidFill>
-                  <a:srgbClr val="C97B3D"/>
+                  <a:srgbClr val="FFDD04"/>
                 </a:solidFill>
                 <a:latin typeface="Avenir Next"/>
               </a:rPr>
@@ -6668,7 +6668,7 @@
             <a:r>
               <a:rPr sz="1650">
                 <a:solidFill>
-                  <a:srgbClr val="1E2A2F"/>
+                  <a:srgbClr val="1C2333"/>
                 </a:solidFill>
                 <a:latin typeface="Avenir Next"/>
               </a:rPr>
@@ -6702,7 +6702,7 @@
             <a:pPr>
               <a:defRPr sz="1000" b="0" i="0">
                 <a:solidFill>
-                  <a:srgbClr val="6E6A5E"/>
+                  <a:srgbClr val="6E7278"/>
                 </a:solidFill>
                 <a:latin typeface="Courier New"/>
               </a:defRPr>
@@ -6727,7 +6727,7 @@
     <p:bg>
       <p:bgPr>
         <a:solidFill>
-          <a:srgbClr val="FAF7F0"/>
+          <a:srgbClr val="FBFAF6"/>
         </a:solidFill>
         <a:effectLst/>
       </p:bgPr>
@@ -6764,7 +6764,7 @@
             <a:pPr>
               <a:defRPr sz="1150" b="0" i="0">
                 <a:solidFill>
-                  <a:srgbClr val="C97B3D"/>
+                  <a:srgbClr val="31688E"/>
                 </a:solidFill>
                 <a:latin typeface="Courier New"/>
               </a:defRPr>
@@ -6790,7 +6790,7 @@
             <a:avLst/>
           </a:prstGeom>
           <a:solidFill>
-            <a:srgbClr val="1F4E5F"/>
+            <a:srgbClr val="1C2333"/>
           </a:solidFill>
           <a:ln>
             <a:noFill/>
@@ -6818,7 +6818,7 @@
             <a:pPr algn="ctr">
               <a:defRPr sz="1200" b="0" i="0">
                 <a:solidFill>
-                  <a:srgbClr val="FAF7F0"/>
+                  <a:srgbClr val="FFDD04"/>
                 </a:solidFill>
                 <a:latin typeface="Courier New"/>
               </a:defRPr>
@@ -6854,7 +6854,7 @@
             <a:pPr>
               <a:defRPr sz="3600" b="1" i="0">
                 <a:solidFill>
-                  <a:srgbClr val="1E2A2F"/>
+                  <a:srgbClr val="1C2333"/>
                 </a:solidFill>
                 <a:latin typeface="Georgia"/>
               </a:defRPr>
@@ -6880,7 +6880,7 @@
             <a:avLst/>
           </a:prstGeom>
           <a:solidFill>
-            <a:srgbClr val="C97B3D"/>
+            <a:srgbClr val="FFDD04"/>
           </a:solidFill>
           <a:ln>
             <a:noFill/>
@@ -6942,7 +6942,7 @@
             <a:r>
               <a:rPr sz="1600">
                 <a:solidFill>
-                  <a:srgbClr val="C97B3D"/>
+                  <a:srgbClr val="FFDD04"/>
                 </a:solidFill>
                 <a:latin typeface="Avenir Next"/>
               </a:rPr>
@@ -6951,7 +6951,7 @@
             <a:r>
               <a:rPr sz="1650">
                 <a:solidFill>
-                  <a:srgbClr val="1E2A2F"/>
+                  <a:srgbClr val="1C2333"/>
                 </a:solidFill>
                 <a:latin typeface="Avenir Next"/>
               </a:rPr>
@@ -6970,7 +6970,7 @@
             <a:r>
               <a:rPr sz="1600">
                 <a:solidFill>
-                  <a:srgbClr val="C97B3D"/>
+                  <a:srgbClr val="FFDD04"/>
                 </a:solidFill>
                 <a:latin typeface="Avenir Next"/>
               </a:rPr>
@@ -6979,7 +6979,7 @@
             <a:r>
               <a:rPr sz="1650">
                 <a:solidFill>
-                  <a:srgbClr val="1E2A2F"/>
+                  <a:srgbClr val="1C2333"/>
                 </a:solidFill>
                 <a:latin typeface="Avenir Next"/>
               </a:rPr>
@@ -6998,7 +6998,7 @@
             <a:r>
               <a:rPr sz="1600">
                 <a:solidFill>
-                  <a:srgbClr val="C97B3D"/>
+                  <a:srgbClr val="FFDD04"/>
                 </a:solidFill>
                 <a:latin typeface="Avenir Next"/>
               </a:rPr>
@@ -7007,7 +7007,7 @@
             <a:r>
               <a:rPr sz="1650">
                 <a:solidFill>
-                  <a:srgbClr val="1E2A2F"/>
+                  <a:srgbClr val="1C2333"/>
                 </a:solidFill>
                 <a:latin typeface="Avenir Next"/>
               </a:rPr>
@@ -7041,7 +7041,7 @@
             <a:pPr>
               <a:defRPr sz="1000" b="0" i="0">
                 <a:solidFill>
-                  <a:srgbClr val="6E6A5E"/>
+                  <a:srgbClr val="6E7278"/>
                 </a:solidFill>
                 <a:latin typeface="Courier New"/>
               </a:defRPr>
@@ -7066,7 +7066,7 @@
     <p:bg>
       <p:bgPr>
         <a:solidFill>
-          <a:srgbClr val="FAF7F0"/>
+          <a:srgbClr val="FBFAF6"/>
         </a:solidFill>
         <a:effectLst/>
       </p:bgPr>
@@ -7103,7 +7103,7 @@
             <a:pPr>
               <a:defRPr sz="1150" b="0" i="0">
                 <a:solidFill>
-                  <a:srgbClr val="C97B3D"/>
+                  <a:srgbClr val="31688E"/>
                 </a:solidFill>
                 <a:latin typeface="Courier New"/>
               </a:defRPr>
@@ -7129,7 +7129,7 @@
             <a:avLst/>
           </a:prstGeom>
           <a:solidFill>
-            <a:srgbClr val="1F4E5F"/>
+            <a:srgbClr val="1C2333"/>
           </a:solidFill>
           <a:ln>
             <a:noFill/>
@@ -7157,7 +7157,7 @@
             <a:pPr algn="ctr">
               <a:defRPr sz="1200" b="0" i="0">
                 <a:solidFill>
-                  <a:srgbClr val="FAF7F0"/>
+                  <a:srgbClr val="FFDD04"/>
                 </a:solidFill>
                 <a:latin typeface="Courier New"/>
               </a:defRPr>
@@ -7193,7 +7193,7 @@
             <a:pPr>
               <a:defRPr sz="3600" b="1" i="0">
                 <a:solidFill>
-                  <a:srgbClr val="1E2A2F"/>
+                  <a:srgbClr val="1C2333"/>
                 </a:solidFill>
                 <a:latin typeface="Georgia"/>
               </a:defRPr>
@@ -7219,7 +7219,7 @@
             <a:avLst/>
           </a:prstGeom>
           <a:solidFill>
-            <a:srgbClr val="C97B3D"/>
+            <a:srgbClr val="FFDD04"/>
           </a:solidFill>
           <a:ln>
             <a:noFill/>
@@ -7281,7 +7281,7 @@
             <a:r>
               <a:rPr sz="1600">
                 <a:solidFill>
-                  <a:srgbClr val="C97B3D"/>
+                  <a:srgbClr val="FFDD04"/>
                 </a:solidFill>
                 <a:latin typeface="Avenir Next"/>
               </a:rPr>
@@ -7290,7 +7290,7 @@
             <a:r>
               <a:rPr sz="1650">
                 <a:solidFill>
-                  <a:srgbClr val="1E2A2F"/>
+                  <a:srgbClr val="1C2333"/>
                 </a:solidFill>
                 <a:latin typeface="Avenir Next"/>
               </a:rPr>
@@ -7309,7 +7309,7 @@
             <a:r>
               <a:rPr sz="1600">
                 <a:solidFill>
-                  <a:srgbClr val="C97B3D"/>
+                  <a:srgbClr val="FFDD04"/>
                 </a:solidFill>
                 <a:latin typeface="Avenir Next"/>
               </a:rPr>
@@ -7318,7 +7318,7 @@
             <a:r>
               <a:rPr sz="1650">
                 <a:solidFill>
-                  <a:srgbClr val="1E2A2F"/>
+                  <a:srgbClr val="1C2333"/>
                 </a:solidFill>
                 <a:latin typeface="Avenir Next"/>
               </a:rPr>
@@ -7337,7 +7337,7 @@
             <a:r>
               <a:rPr sz="1600">
                 <a:solidFill>
-                  <a:srgbClr val="C97B3D"/>
+                  <a:srgbClr val="FFDD04"/>
                 </a:solidFill>
                 <a:latin typeface="Avenir Next"/>
               </a:rPr>
@@ -7346,7 +7346,7 @@
             <a:r>
               <a:rPr sz="1650">
                 <a:solidFill>
-                  <a:srgbClr val="1E2A2F"/>
+                  <a:srgbClr val="1C2333"/>
                 </a:solidFill>
                 <a:latin typeface="Avenir Next"/>
               </a:rPr>
@@ -7365,7 +7365,7 @@
             <a:r>
               <a:rPr sz="1600">
                 <a:solidFill>
-                  <a:srgbClr val="C97B3D"/>
+                  <a:srgbClr val="FFDD04"/>
                 </a:solidFill>
                 <a:latin typeface="Avenir Next"/>
               </a:rPr>
@@ -7374,7 +7374,7 @@
             <a:r>
               <a:rPr sz="1650">
                 <a:solidFill>
-                  <a:srgbClr val="1E2A2F"/>
+                  <a:srgbClr val="1C2333"/>
                 </a:solidFill>
                 <a:latin typeface="Avenir Next"/>
               </a:rPr>
@@ -7432,7 +7432,7 @@
             <a:pPr>
               <a:defRPr sz="850" b="0" i="0">
                 <a:solidFill>
-                  <a:srgbClr val="6E6A5E"/>
+                  <a:srgbClr val="6E7278"/>
                 </a:solidFill>
                 <a:latin typeface="Courier New"/>
               </a:defRPr>
@@ -7468,7 +7468,7 @@
             <a:pPr>
               <a:defRPr sz="1000" b="0" i="0">
                 <a:solidFill>
-                  <a:srgbClr val="6E6A5E"/>
+                  <a:srgbClr val="6E7278"/>
                 </a:solidFill>
                 <a:latin typeface="Courier New"/>
               </a:defRPr>
@@ -7493,7 +7493,7 @@
     <p:bg>
       <p:bgPr>
         <a:solidFill>
-          <a:srgbClr val="FAF7F0"/>
+          <a:srgbClr val="FBFAF6"/>
         </a:solidFill>
         <a:effectLst/>
       </p:bgPr>
@@ -7530,7 +7530,7 @@
             <a:pPr>
               <a:defRPr sz="1150" b="0" i="0">
                 <a:solidFill>
-                  <a:srgbClr val="C97B3D"/>
+                  <a:srgbClr val="31688E"/>
                 </a:solidFill>
                 <a:latin typeface="Courier New"/>
               </a:defRPr>
@@ -7556,7 +7556,7 @@
             <a:avLst/>
           </a:prstGeom>
           <a:solidFill>
-            <a:srgbClr val="1F4E5F"/>
+            <a:srgbClr val="1C2333"/>
           </a:solidFill>
           <a:ln>
             <a:noFill/>
@@ -7584,7 +7584,7 @@
             <a:pPr algn="ctr">
               <a:defRPr sz="1200" b="0" i="0">
                 <a:solidFill>
-                  <a:srgbClr val="FAF7F0"/>
+                  <a:srgbClr val="FFDD04"/>
                 </a:solidFill>
                 <a:latin typeface="Courier New"/>
               </a:defRPr>
@@ -7620,7 +7620,7 @@
             <a:pPr>
               <a:defRPr sz="3600" b="1" i="0">
                 <a:solidFill>
-                  <a:srgbClr val="1E2A2F"/>
+                  <a:srgbClr val="1C2333"/>
                 </a:solidFill>
                 <a:latin typeface="Georgia"/>
               </a:defRPr>
@@ -7646,7 +7646,7 @@
             <a:avLst/>
           </a:prstGeom>
           <a:solidFill>
-            <a:srgbClr val="C97B3D"/>
+            <a:srgbClr val="FFDD04"/>
           </a:solidFill>
           <a:ln>
             <a:noFill/>
@@ -7700,7 +7700,7 @@
             <a:pPr>
               <a:defRPr sz="4000" b="1" i="0">
                 <a:solidFill>
-                  <a:srgbClr val="C97B3D"/>
+                  <a:srgbClr val="1C2333"/>
                 </a:solidFill>
                 <a:latin typeface="Georgia"/>
               </a:defRPr>
@@ -7711,7 +7711,7 @@
             <a:r>
               <a:rPr sz="1600" b="0">
                 <a:solidFill>
-                  <a:srgbClr val="6E6A5E"/>
+                  <a:srgbClr val="6E7278"/>
                 </a:solidFill>
                 <a:latin typeface="Avenir Next"/>
               </a:rPr>
@@ -7753,7 +7753,7 @@
             <a:r>
               <a:rPr sz="1600">
                 <a:solidFill>
-                  <a:srgbClr val="C97B3D"/>
+                  <a:srgbClr val="FFDD04"/>
                 </a:solidFill>
                 <a:latin typeface="Avenir Next"/>
               </a:rPr>
@@ -7762,7 +7762,7 @@
             <a:r>
               <a:rPr sz="1650">
                 <a:solidFill>
-                  <a:srgbClr val="1E2A2F"/>
+                  <a:srgbClr val="1C2333"/>
                 </a:solidFill>
                 <a:latin typeface="Avenir Next"/>
               </a:rPr>
@@ -7781,7 +7781,7 @@
             <a:r>
               <a:rPr sz="1600">
                 <a:solidFill>
-                  <a:srgbClr val="C97B3D"/>
+                  <a:srgbClr val="FFDD04"/>
                 </a:solidFill>
                 <a:latin typeface="Avenir Next"/>
               </a:rPr>
@@ -7790,7 +7790,7 @@
             <a:r>
               <a:rPr sz="1650">
                 <a:solidFill>
-                  <a:srgbClr val="1E2A2F"/>
+                  <a:srgbClr val="1C2333"/>
                 </a:solidFill>
                 <a:latin typeface="Avenir Next"/>
               </a:rPr>
@@ -7809,7 +7809,7 @@
             <a:r>
               <a:rPr sz="1600">
                 <a:solidFill>
-                  <a:srgbClr val="C97B3D"/>
+                  <a:srgbClr val="FFDD04"/>
                 </a:solidFill>
                 <a:latin typeface="Avenir Next"/>
               </a:rPr>
@@ -7818,7 +7818,7 @@
             <a:r>
               <a:rPr sz="1650">
                 <a:solidFill>
-                  <a:srgbClr val="1E2A2F"/>
+                  <a:srgbClr val="1C2333"/>
                 </a:solidFill>
                 <a:latin typeface="Avenir Next"/>
               </a:rPr>
@@ -7876,7 +7876,7 @@
             <a:pPr>
               <a:defRPr sz="850" b="0" i="0">
                 <a:solidFill>
-                  <a:srgbClr val="6E6A5E"/>
+                  <a:srgbClr val="6E7278"/>
                 </a:solidFill>
                 <a:latin typeface="Courier New"/>
               </a:defRPr>
@@ -7912,7 +7912,7 @@
             <a:pPr>
               <a:defRPr sz="1000" b="0" i="0">
                 <a:solidFill>
-                  <a:srgbClr val="6E6A5E"/>
+                  <a:srgbClr val="6E7278"/>
                 </a:solidFill>
                 <a:latin typeface="Courier New"/>
               </a:defRPr>
@@ -7937,7 +7937,7 @@
     <p:bg>
       <p:bgPr>
         <a:solidFill>
-          <a:srgbClr val="FAF7F0"/>
+          <a:srgbClr val="FBFAF6"/>
         </a:solidFill>
         <a:effectLst/>
       </p:bgPr>
@@ -7974,7 +7974,7 @@
             <a:pPr>
               <a:defRPr sz="1150" b="0" i="0">
                 <a:solidFill>
-                  <a:srgbClr val="C97B3D"/>
+                  <a:srgbClr val="31688E"/>
                 </a:solidFill>
                 <a:latin typeface="Courier New"/>
               </a:defRPr>
@@ -8000,7 +8000,7 @@
             <a:avLst/>
           </a:prstGeom>
           <a:solidFill>
-            <a:srgbClr val="1F4E5F"/>
+            <a:srgbClr val="1C2333"/>
           </a:solidFill>
           <a:ln>
             <a:noFill/>
@@ -8028,7 +8028,7 @@
             <a:pPr algn="ctr">
               <a:defRPr sz="1200" b="0" i="0">
                 <a:solidFill>
-                  <a:srgbClr val="FAF7F0"/>
+                  <a:srgbClr val="FFDD04"/>
                 </a:solidFill>
                 <a:latin typeface="Courier New"/>
               </a:defRPr>
@@ -8064,7 +8064,7 @@
             <a:pPr>
               <a:defRPr sz="3600" b="1" i="0">
                 <a:solidFill>
-                  <a:srgbClr val="1E2A2F"/>
+                  <a:srgbClr val="1C2333"/>
                 </a:solidFill>
                 <a:latin typeface="Georgia"/>
               </a:defRPr>
@@ -8090,7 +8090,7 @@
             <a:avLst/>
           </a:prstGeom>
           <a:solidFill>
-            <a:srgbClr val="C97B3D"/>
+            <a:srgbClr val="FFDD04"/>
           </a:solidFill>
           <a:ln>
             <a:noFill/>
@@ -8144,7 +8144,7 @@
             <a:pPr>
               <a:defRPr sz="4000" b="1" i="0">
                 <a:solidFill>
-                  <a:srgbClr val="C97B3D"/>
+                  <a:srgbClr val="1C2333"/>
                 </a:solidFill>
                 <a:latin typeface="Georgia"/>
               </a:defRPr>
@@ -8155,7 +8155,7 @@
             <a:r>
               <a:rPr sz="1600" b="0">
                 <a:solidFill>
-                  <a:srgbClr val="6E6A5E"/>
+                  <a:srgbClr val="6E7278"/>
                 </a:solidFill>
                 <a:latin typeface="Avenir Next"/>
               </a:rPr>
@@ -8197,7 +8197,7 @@
             <a:r>
               <a:rPr sz="1600">
                 <a:solidFill>
-                  <a:srgbClr val="C97B3D"/>
+                  <a:srgbClr val="FFDD04"/>
                 </a:solidFill>
                 <a:latin typeface="Avenir Next"/>
               </a:rPr>
@@ -8206,7 +8206,7 @@
             <a:r>
               <a:rPr sz="1650">
                 <a:solidFill>
-                  <a:srgbClr val="1E2A2F"/>
+                  <a:srgbClr val="1C2333"/>
                 </a:solidFill>
                 <a:latin typeface="Avenir Next"/>
               </a:rPr>
@@ -8225,7 +8225,7 @@
             <a:r>
               <a:rPr sz="1600">
                 <a:solidFill>
-                  <a:srgbClr val="C97B3D"/>
+                  <a:srgbClr val="FFDD04"/>
                 </a:solidFill>
                 <a:latin typeface="Avenir Next"/>
               </a:rPr>
@@ -8234,7 +8234,7 @@
             <a:r>
               <a:rPr sz="1650">
                 <a:solidFill>
-                  <a:srgbClr val="1E2A2F"/>
+                  <a:srgbClr val="1C2333"/>
                 </a:solidFill>
                 <a:latin typeface="Avenir Next"/>
               </a:rPr>
@@ -8253,7 +8253,7 @@
             <a:r>
               <a:rPr sz="1600">
                 <a:solidFill>
-                  <a:srgbClr val="C97B3D"/>
+                  <a:srgbClr val="FFDD04"/>
                 </a:solidFill>
                 <a:latin typeface="Avenir Next"/>
               </a:rPr>
@@ -8262,7 +8262,7 @@
             <a:r>
               <a:rPr sz="1650">
                 <a:solidFill>
-                  <a:srgbClr val="1E2A2F"/>
+                  <a:srgbClr val="1C2333"/>
                 </a:solidFill>
                 <a:latin typeface="Avenir Next"/>
               </a:rPr>
@@ -8320,7 +8320,7 @@
             <a:pPr>
               <a:defRPr sz="850" b="0" i="0">
                 <a:solidFill>
-                  <a:srgbClr val="6E6A5E"/>
+                  <a:srgbClr val="6E7278"/>
                 </a:solidFill>
                 <a:latin typeface="Courier New"/>
               </a:defRPr>
@@ -8356,7 +8356,7 @@
             <a:pPr>
               <a:defRPr sz="1000" b="0" i="0">
                 <a:solidFill>
-                  <a:srgbClr val="6E6A5E"/>
+                  <a:srgbClr val="6E7278"/>
                 </a:solidFill>
                 <a:latin typeface="Courier New"/>
               </a:defRPr>
@@ -8381,7 +8381,7 @@
     <p:bg>
       <p:bgPr>
         <a:solidFill>
-          <a:srgbClr val="FAF7F0"/>
+          <a:srgbClr val="FBFAF6"/>
         </a:solidFill>
         <a:effectLst/>
       </p:bgPr>
@@ -8418,7 +8418,7 @@
             <a:pPr>
               <a:defRPr sz="1150" b="0" i="0">
                 <a:solidFill>
-                  <a:srgbClr val="C97B3D"/>
+                  <a:srgbClr val="31688E"/>
                 </a:solidFill>
                 <a:latin typeface="Courier New"/>
               </a:defRPr>
@@ -8444,7 +8444,7 @@
             <a:avLst/>
           </a:prstGeom>
           <a:solidFill>
-            <a:srgbClr val="1F4E5F"/>
+            <a:srgbClr val="1C2333"/>
           </a:solidFill>
           <a:ln>
             <a:noFill/>
@@ -8472,7 +8472,7 @@
             <a:pPr algn="ctr">
               <a:defRPr sz="1200" b="0" i="0">
                 <a:solidFill>
-                  <a:srgbClr val="FAF7F0"/>
+                  <a:srgbClr val="FFDD04"/>
                 </a:solidFill>
                 <a:latin typeface="Courier New"/>
               </a:defRPr>
@@ -8508,7 +8508,7 @@
             <a:pPr>
               <a:defRPr sz="3600" b="1" i="0">
                 <a:solidFill>
-                  <a:srgbClr val="1E2A2F"/>
+                  <a:srgbClr val="1C2333"/>
                 </a:solidFill>
                 <a:latin typeface="Georgia"/>
               </a:defRPr>
@@ -8534,7 +8534,7 @@
             <a:avLst/>
           </a:prstGeom>
           <a:solidFill>
-            <a:srgbClr val="C97B3D"/>
+            <a:srgbClr val="FFDD04"/>
           </a:solidFill>
           <a:ln>
             <a:noFill/>
@@ -8588,7 +8588,7 @@
             <a:pPr>
               <a:defRPr sz="4000" b="1" i="0">
                 <a:solidFill>
-                  <a:srgbClr val="C97B3D"/>
+                  <a:srgbClr val="1C2333"/>
                 </a:solidFill>
                 <a:latin typeface="Georgia"/>
               </a:defRPr>
@@ -8599,7 +8599,7 @@
             <a:r>
               <a:rPr sz="1600" b="0">
                 <a:solidFill>
-                  <a:srgbClr val="6E6A5E"/>
+                  <a:srgbClr val="6E7278"/>
                 </a:solidFill>
                 <a:latin typeface="Avenir Next"/>
               </a:rPr>
@@ -8641,7 +8641,7 @@
             <a:r>
               <a:rPr sz="1600">
                 <a:solidFill>
-                  <a:srgbClr val="C97B3D"/>
+                  <a:srgbClr val="FFDD04"/>
                 </a:solidFill>
                 <a:latin typeface="Avenir Next"/>
               </a:rPr>
@@ -8650,7 +8650,7 @@
             <a:r>
               <a:rPr sz="1650">
                 <a:solidFill>
-                  <a:srgbClr val="1E2A2F"/>
+                  <a:srgbClr val="1C2333"/>
                 </a:solidFill>
                 <a:latin typeface="Avenir Next"/>
               </a:rPr>
@@ -8669,7 +8669,7 @@
             <a:r>
               <a:rPr sz="1600">
                 <a:solidFill>
-                  <a:srgbClr val="C97B3D"/>
+                  <a:srgbClr val="FFDD04"/>
                 </a:solidFill>
                 <a:latin typeface="Avenir Next"/>
               </a:rPr>
@@ -8678,7 +8678,7 @@
             <a:r>
               <a:rPr sz="1650">
                 <a:solidFill>
-                  <a:srgbClr val="1E2A2F"/>
+                  <a:srgbClr val="1C2333"/>
                 </a:solidFill>
                 <a:latin typeface="Avenir Next"/>
               </a:rPr>
@@ -8697,7 +8697,7 @@
             <a:r>
               <a:rPr sz="1600">
                 <a:solidFill>
-                  <a:srgbClr val="C97B3D"/>
+                  <a:srgbClr val="FFDD04"/>
                 </a:solidFill>
                 <a:latin typeface="Avenir Next"/>
               </a:rPr>
@@ -8706,7 +8706,7 @@
             <a:r>
               <a:rPr sz="1650">
                 <a:solidFill>
-                  <a:srgbClr val="1E2A2F"/>
+                  <a:srgbClr val="1C2333"/>
                 </a:solidFill>
                 <a:latin typeface="Avenir Next"/>
               </a:rPr>
@@ -8725,7 +8725,7 @@
             <a:r>
               <a:rPr sz="1600">
                 <a:solidFill>
-                  <a:srgbClr val="C97B3D"/>
+                  <a:srgbClr val="FFDD04"/>
                 </a:solidFill>
                 <a:latin typeface="Avenir Next"/>
               </a:rPr>
@@ -8734,7 +8734,7 @@
             <a:r>
               <a:rPr sz="1650">
                 <a:solidFill>
-                  <a:srgbClr val="1E2A2F"/>
+                  <a:srgbClr val="1C2333"/>
                 </a:solidFill>
                 <a:latin typeface="Avenir Next"/>
               </a:rPr>
@@ -8760,7 +8760,7 @@
         <p:spPr>
           <a:xfrm>
             <a:off x="7498079" y="2834639"/>
-            <a:ext cx="4069080" cy="2264914"/>
+            <a:ext cx="4069080" cy="2179495"/>
           </a:xfrm>
           <a:prstGeom prst="rect">
             <a:avLst/>
@@ -8792,7 +8792,7 @@
             <a:pPr>
               <a:defRPr sz="850" b="0" i="0">
                 <a:solidFill>
-                  <a:srgbClr val="6E6A5E"/>
+                  <a:srgbClr val="6E7278"/>
                 </a:solidFill>
                 <a:latin typeface="Courier New"/>
               </a:defRPr>
@@ -8828,7 +8828,7 @@
             <a:pPr>
               <a:defRPr sz="1000" b="0" i="0">
                 <a:solidFill>
-                  <a:srgbClr val="6E6A5E"/>
+                  <a:srgbClr val="6E7278"/>
                 </a:solidFill>
                 <a:latin typeface="Courier New"/>
               </a:defRPr>
@@ -8853,7 +8853,7 @@
     <p:bg>
       <p:bgPr>
         <a:solidFill>
-          <a:srgbClr val="FAF7F0"/>
+          <a:srgbClr val="FBFAF6"/>
         </a:solidFill>
         <a:effectLst/>
       </p:bgPr>
@@ -8890,7 +8890,7 @@
             <a:pPr>
               <a:defRPr sz="1150" b="0" i="0">
                 <a:solidFill>
-                  <a:srgbClr val="C97B3D"/>
+                  <a:srgbClr val="31688E"/>
                 </a:solidFill>
                 <a:latin typeface="Courier New"/>
               </a:defRPr>
@@ -8916,7 +8916,7 @@
             <a:avLst/>
           </a:prstGeom>
           <a:solidFill>
-            <a:srgbClr val="1F4E5F"/>
+            <a:srgbClr val="1C2333"/>
           </a:solidFill>
           <a:ln>
             <a:noFill/>
@@ -8944,7 +8944,7 @@
             <a:pPr algn="ctr">
               <a:defRPr sz="1200" b="0" i="0">
                 <a:solidFill>
-                  <a:srgbClr val="FAF7F0"/>
+                  <a:srgbClr val="FFDD04"/>
                 </a:solidFill>
                 <a:latin typeface="Courier New"/>
               </a:defRPr>
@@ -8980,7 +8980,7 @@
             <a:pPr>
               <a:defRPr sz="3600" b="1" i="0">
                 <a:solidFill>
-                  <a:srgbClr val="1E2A2F"/>
+                  <a:srgbClr val="1C2333"/>
                 </a:solidFill>
                 <a:latin typeface="Georgia"/>
               </a:defRPr>
@@ -9006,7 +9006,7 @@
             <a:avLst/>
           </a:prstGeom>
           <a:solidFill>
-            <a:srgbClr val="C97B3D"/>
+            <a:srgbClr val="FFDD04"/>
           </a:solidFill>
           <a:ln>
             <a:noFill/>
@@ -9060,7 +9060,7 @@
             <a:pPr>
               <a:defRPr sz="4000" b="1" i="0">
                 <a:solidFill>
-                  <a:srgbClr val="C97B3D"/>
+                  <a:srgbClr val="1C2333"/>
                 </a:solidFill>
                 <a:latin typeface="Georgia"/>
               </a:defRPr>
@@ -9071,7 +9071,7 @@
             <a:r>
               <a:rPr sz="1600" b="0">
                 <a:solidFill>
-                  <a:srgbClr val="6E6A5E"/>
+                  <a:srgbClr val="6E7278"/>
                 </a:solidFill>
                 <a:latin typeface="Avenir Next"/>
               </a:rPr>
@@ -9113,7 +9113,7 @@
             <a:r>
               <a:rPr sz="1600">
                 <a:solidFill>
-                  <a:srgbClr val="C97B3D"/>
+                  <a:srgbClr val="FFDD04"/>
                 </a:solidFill>
                 <a:latin typeface="Avenir Next"/>
               </a:rPr>
@@ -9122,7 +9122,7 @@
             <a:r>
               <a:rPr sz="1650">
                 <a:solidFill>
-                  <a:srgbClr val="1E2A2F"/>
+                  <a:srgbClr val="1C2333"/>
                 </a:solidFill>
                 <a:latin typeface="Avenir Next"/>
               </a:rPr>
@@ -9141,7 +9141,7 @@
             <a:r>
               <a:rPr sz="1600">
                 <a:solidFill>
-                  <a:srgbClr val="C97B3D"/>
+                  <a:srgbClr val="FFDD04"/>
                 </a:solidFill>
                 <a:latin typeface="Avenir Next"/>
               </a:rPr>
@@ -9150,7 +9150,7 @@
             <a:r>
               <a:rPr sz="1650">
                 <a:solidFill>
-                  <a:srgbClr val="1E2A2F"/>
+                  <a:srgbClr val="1C2333"/>
                 </a:solidFill>
                 <a:latin typeface="Avenir Next"/>
               </a:rPr>
@@ -9208,7 +9208,7 @@
             <a:pPr>
               <a:defRPr sz="850" b="0" i="0">
                 <a:solidFill>
-                  <a:srgbClr val="6E6A5E"/>
+                  <a:srgbClr val="6E7278"/>
                 </a:solidFill>
                 <a:latin typeface="Courier New"/>
               </a:defRPr>
@@ -9244,7 +9244,7 @@
             <a:pPr>
               <a:defRPr sz="1000" b="0" i="0">
                 <a:solidFill>
-                  <a:srgbClr val="6E6A5E"/>
+                  <a:srgbClr val="6E7278"/>
                 </a:solidFill>
                 <a:latin typeface="Courier New"/>
               </a:defRPr>
@@ -9269,7 +9269,7 @@
     <p:bg>
       <p:bgPr>
         <a:solidFill>
-          <a:srgbClr val="FAF7F0"/>
+          <a:srgbClr val="FBFAF6"/>
         </a:solidFill>
         <a:effectLst/>
       </p:bgPr>
@@ -9306,7 +9306,7 @@
             <a:pPr>
               <a:defRPr sz="1150" b="0" i="0">
                 <a:solidFill>
-                  <a:srgbClr val="C97B3D"/>
+                  <a:srgbClr val="31688E"/>
                 </a:solidFill>
                 <a:latin typeface="Courier New"/>
               </a:defRPr>
@@ -9332,7 +9332,7 @@
             <a:avLst/>
           </a:prstGeom>
           <a:solidFill>
-            <a:srgbClr val="1F4E5F"/>
+            <a:srgbClr val="1C2333"/>
           </a:solidFill>
           <a:ln>
             <a:noFill/>
@@ -9360,7 +9360,7 @@
             <a:pPr algn="ctr">
               <a:defRPr sz="1200" b="0" i="0">
                 <a:solidFill>
-                  <a:srgbClr val="FAF7F0"/>
+                  <a:srgbClr val="FFDD04"/>
                 </a:solidFill>
                 <a:latin typeface="Courier New"/>
               </a:defRPr>
@@ -9396,7 +9396,7 @@
             <a:pPr>
               <a:defRPr sz="3600" b="1" i="0">
                 <a:solidFill>
-                  <a:srgbClr val="1E2A2F"/>
+                  <a:srgbClr val="1C2333"/>
                 </a:solidFill>
                 <a:latin typeface="Georgia"/>
               </a:defRPr>
@@ -9422,7 +9422,7 @@
             <a:avLst/>
           </a:prstGeom>
           <a:solidFill>
-            <a:srgbClr val="C97B3D"/>
+            <a:srgbClr val="FFDD04"/>
           </a:solidFill>
           <a:ln>
             <a:noFill/>
@@ -9484,7 +9484,7 @@
             <a:r>
               <a:rPr sz="1600">
                 <a:solidFill>
-                  <a:srgbClr val="C97B3D"/>
+                  <a:srgbClr val="FFDD04"/>
                 </a:solidFill>
                 <a:latin typeface="Avenir Next"/>
               </a:rPr>
@@ -9493,7 +9493,7 @@
             <a:r>
               <a:rPr sz="1650">
                 <a:solidFill>
-                  <a:srgbClr val="1E2A2F"/>
+                  <a:srgbClr val="1C2333"/>
                 </a:solidFill>
                 <a:latin typeface="Avenir Next"/>
               </a:rPr>
@@ -9512,7 +9512,7 @@
             <a:r>
               <a:rPr sz="1600">
                 <a:solidFill>
-                  <a:srgbClr val="C97B3D"/>
+                  <a:srgbClr val="FFDD04"/>
                 </a:solidFill>
                 <a:latin typeface="Avenir Next"/>
               </a:rPr>
@@ -9521,7 +9521,7 @@
             <a:r>
               <a:rPr sz="1650">
                 <a:solidFill>
-                  <a:srgbClr val="1E2A2F"/>
+                  <a:srgbClr val="1C2333"/>
                 </a:solidFill>
                 <a:latin typeface="Avenir Next"/>
               </a:rPr>
@@ -9540,7 +9540,7 @@
             <a:r>
               <a:rPr sz="1600">
                 <a:solidFill>
-                  <a:srgbClr val="C97B3D"/>
+                  <a:srgbClr val="FFDD04"/>
                 </a:solidFill>
                 <a:latin typeface="Avenir Next"/>
               </a:rPr>
@@ -9549,7 +9549,7 @@
             <a:r>
               <a:rPr sz="1650">
                 <a:solidFill>
-                  <a:srgbClr val="1E2A2F"/>
+                  <a:srgbClr val="1C2333"/>
                 </a:solidFill>
                 <a:latin typeface="Avenir Next"/>
               </a:rPr>
@@ -9568,7 +9568,7 @@
             <a:r>
               <a:rPr sz="1600">
                 <a:solidFill>
-                  <a:srgbClr val="C97B3D"/>
+                  <a:srgbClr val="FFDD04"/>
                 </a:solidFill>
                 <a:latin typeface="Avenir Next"/>
               </a:rPr>
@@ -9577,7 +9577,7 @@
             <a:r>
               <a:rPr sz="1650">
                 <a:solidFill>
-                  <a:srgbClr val="1E2A2F"/>
+                  <a:srgbClr val="1C2333"/>
                 </a:solidFill>
                 <a:latin typeface="Avenir Next"/>
               </a:rPr>
@@ -9611,7 +9611,7 @@
             <a:pPr>
               <a:defRPr sz="1000" b="0" i="0">
                 <a:solidFill>
-                  <a:srgbClr val="6E6A5E"/>
+                  <a:srgbClr val="6E7278"/>
                 </a:solidFill>
                 <a:latin typeface="Courier New"/>
               </a:defRPr>
@@ -9636,7 +9636,7 @@
     <p:bg>
       <p:bgPr>
         <a:solidFill>
-          <a:srgbClr val="FAF7F0"/>
+          <a:srgbClr val="FBFAF6"/>
         </a:solidFill>
         <a:effectLst/>
       </p:bgPr>
@@ -9673,7 +9673,7 @@
             <a:pPr>
               <a:defRPr sz="1150" b="0" i="0">
                 <a:solidFill>
-                  <a:srgbClr val="C97B3D"/>
+                  <a:srgbClr val="31688E"/>
                 </a:solidFill>
                 <a:latin typeface="Courier New"/>
               </a:defRPr>
@@ -9699,7 +9699,7 @@
             <a:avLst/>
           </a:prstGeom>
           <a:solidFill>
-            <a:srgbClr val="1F4E5F"/>
+            <a:srgbClr val="1C2333"/>
           </a:solidFill>
           <a:ln>
             <a:noFill/>
@@ -9727,7 +9727,7 @@
             <a:pPr algn="ctr">
               <a:defRPr sz="1200" b="0" i="0">
                 <a:solidFill>
-                  <a:srgbClr val="FAF7F0"/>
+                  <a:srgbClr val="FFDD04"/>
                 </a:solidFill>
                 <a:latin typeface="Courier New"/>
               </a:defRPr>
@@ -9763,7 +9763,7 @@
             <a:pPr>
               <a:defRPr sz="3600" b="1" i="0">
                 <a:solidFill>
-                  <a:srgbClr val="1E2A2F"/>
+                  <a:srgbClr val="1C2333"/>
                 </a:solidFill>
                 <a:latin typeface="Georgia"/>
               </a:defRPr>
@@ -9789,7 +9789,7 @@
             <a:avLst/>
           </a:prstGeom>
           <a:solidFill>
-            <a:srgbClr val="C97B3D"/>
+            <a:srgbClr val="FFDD04"/>
           </a:solidFill>
           <a:ln>
             <a:noFill/>
@@ -9851,7 +9851,7 @@
             <a:r>
               <a:rPr sz="1600">
                 <a:solidFill>
-                  <a:srgbClr val="C97B3D"/>
+                  <a:srgbClr val="FFDD04"/>
                 </a:solidFill>
                 <a:latin typeface="Avenir Next"/>
               </a:rPr>
@@ -9860,7 +9860,7 @@
             <a:r>
               <a:rPr sz="1650">
                 <a:solidFill>
-                  <a:srgbClr val="1E2A2F"/>
+                  <a:srgbClr val="1C2333"/>
                 </a:solidFill>
                 <a:latin typeface="Avenir Next"/>
               </a:rPr>
@@ -9879,7 +9879,7 @@
             <a:r>
               <a:rPr sz="1600">
                 <a:solidFill>
-                  <a:srgbClr val="C97B3D"/>
+                  <a:srgbClr val="FFDD04"/>
                 </a:solidFill>
                 <a:latin typeface="Avenir Next"/>
               </a:rPr>
@@ -9888,7 +9888,7 @@
             <a:r>
               <a:rPr sz="1650">
                 <a:solidFill>
-                  <a:srgbClr val="1E2A2F"/>
+                  <a:srgbClr val="1C2333"/>
                 </a:solidFill>
                 <a:latin typeface="Avenir Next"/>
               </a:rPr>
@@ -9907,7 +9907,7 @@
             <a:r>
               <a:rPr sz="1600">
                 <a:solidFill>
-                  <a:srgbClr val="C97B3D"/>
+                  <a:srgbClr val="FFDD04"/>
                 </a:solidFill>
                 <a:latin typeface="Avenir Next"/>
               </a:rPr>
@@ -9916,7 +9916,7 @@
             <a:r>
               <a:rPr sz="1650">
                 <a:solidFill>
-                  <a:srgbClr val="1E2A2F"/>
+                  <a:srgbClr val="1C2333"/>
                 </a:solidFill>
                 <a:latin typeface="Avenir Next"/>
               </a:rPr>
@@ -9950,7 +9950,7 @@
             <a:pPr>
               <a:defRPr sz="1000" b="0" i="0">
                 <a:solidFill>
-                  <a:srgbClr val="6E6A5E"/>
+                  <a:srgbClr val="6E7278"/>
                 </a:solidFill>
                 <a:latin typeface="Courier New"/>
               </a:defRPr>

</xml_diff>

<commit_message>
docs: DM Sans typeface for exhibits + academic figure captions
- Charts now set in DM Sans (committed under docs/presentation/fonts/
  with its OFL licence) - the open Google-commissioned substitute for
  Google Sans, which is not freely redistributable; the build script
  auto-prefers a real GoogleSans/ProductSans TTF if the team drops one
  into the fonts dir (kept uncommitted)
- Every embedded exhibit now carries a 'Figure N. <name>' + 'Notes: ...'
  caption (8 figures, numbered in slide order, sources and sample sizes
  in the notes line); slide-5 image height re-capped so captions clear
- QA clean: 15 slides, 8 captions, no overlaps

Co-Authored-By: Claude Fable 5 <noreply@anthropic.com>
</commit_message>
<xml_diff>
--- a/docs/presentation/slides_draft.pptx
+++ b/docs/presentation/slides_draft.pptx
@@ -5484,8 +5484,8 @@
         </p:nvSpPr>
         <p:spPr>
           <a:xfrm>
-            <a:off x="7498079" y="6172200"/>
-            <a:ext cx="4206240" cy="274320"/>
+            <a:off x="7498079" y="6053328"/>
+            <a:ext cx="4297680" cy="685800"/>
           </a:xfrm>
           <a:prstGeom prst="rect">
             <a:avLst/>
@@ -5498,16 +5498,34 @@
           </a:bodyPr>
           <a:lstStyle/>
           <a:p>
-            <a:pPr>
-              <a:defRPr sz="850" b="0" i="0">
+            <a:r>
+              <a:rPr sz="900" b="1">
+                <a:solidFill>
+                  <a:srgbClr val="1C2333"/>
+                </a:solidFill>
+                <a:latin typeface="Avenir Next"/>
+              </a:rPr>
+              <a:t>Figure 6. </a:t>
+            </a:r>
+            <a:r>
+              <a:rPr sz="900">
+                <a:solidFill>
+                  <a:srgbClr val="1C2333"/>
+                </a:solidFill>
+                <a:latin typeface="Avenir Next"/>
+              </a:rPr>
+              <a:t>Average funding speed by region.</a:t>
+            </a:r>
+          </a:p>
+          <a:p>
+            <a:r>
+              <a:rPr sz="800">
                 <a:solidFill>
                   <a:srgbClr val="6E7278"/>
                 </a:solidFill>
-                <a:latin typeface="Courier New"/>
-              </a:defRPr>
-            </a:pPr>
-            <a:r>
-              <a:t>EDA notebook §5 · regional speed context for the pooled categories</a:t>
+                <a:latin typeface="Avenir Next"/>
+              </a:rPr>
+              <a:t>Notes: Bar annotations give per-region loan counts; dashed line = overall average. EDA notebook §5.</a:t>
             </a:r>
           </a:p>
         </p:txBody>
@@ -5868,7 +5886,7 @@
         <p:spPr>
           <a:xfrm>
             <a:off x="7498079" y="1783080"/>
-            <a:ext cx="4069080" cy="2335995"/>
+            <a:ext cx="4069080" cy="2386105"/>
           </a:xfrm>
           <a:prstGeom prst="rect">
             <a:avLst/>
@@ -5883,8 +5901,8 @@
         </p:nvSpPr>
         <p:spPr>
           <a:xfrm>
-            <a:off x="7498079" y="6172200"/>
-            <a:ext cx="4206240" cy="274320"/>
+            <a:off x="7498079" y="6053328"/>
+            <a:ext cx="4297680" cy="685800"/>
           </a:xfrm>
           <a:prstGeom prst="rect">
             <a:avLst/>
@@ -5897,16 +5915,34 @@
           </a:bodyPr>
           <a:lstStyle/>
           <a:p>
-            <a:pPr>
-              <a:defRPr sz="850" b="0" i="0">
+            <a:r>
+              <a:rPr sz="900" b="1">
+                <a:solidFill>
+                  <a:srgbClr val="1C2333"/>
+                </a:solidFill>
+                <a:latin typeface="Avenir Next"/>
+              </a:rPr>
+              <a:t>Figure 7. </a:t>
+            </a:r>
+            <a:r>
+              <a:rPr sz="900">
+                <a:solidFill>
+                  <a:srgbClr val="1C2333"/>
+                </a:solidFill>
+                <a:latin typeface="Avenir Next"/>
+              </a:rPr>
+              <a:t>Top 15 features by mean |SHAP| value, boosted model.</a:t>
+            </a:r>
+          </a:p>
+          <a:p>
+            <a:r>
+              <a:rPr sz="800">
                 <a:solidFill>
                   <a:srgbClr val="6E7278"/>
                 </a:solidFill>
-                <a:latin typeface="Courier New"/>
-              </a:defRPr>
-            </a:pPr>
-            <a:r>
-              <a:t>modeling notebook §8 · SHAP top-15</a:t>
+                <a:latin typeface="Avenir Next"/>
+              </a:rPr>
+              <a:t>Notes: 2,000-loan holdout sample; sentiment (11th) highlighted as the only narrative feature. Modeling notebook §8.</a:t>
             </a:r>
           </a:p>
         </p:txBody>
@@ -6267,7 +6303,7 @@
         <p:spPr>
           <a:xfrm>
             <a:off x="7498079" y="1783080"/>
-            <a:ext cx="4069080" cy="2062319"/>
+            <a:ext cx="4069080" cy="2099003"/>
           </a:xfrm>
           <a:prstGeom prst="rect">
             <a:avLst/>
@@ -6282,8 +6318,8 @@
         </p:nvSpPr>
         <p:spPr>
           <a:xfrm>
-            <a:off x="7498079" y="6172200"/>
-            <a:ext cx="4206240" cy="274320"/>
+            <a:off x="7498079" y="6053328"/>
+            <a:ext cx="4297680" cy="685800"/>
           </a:xfrm>
           <a:prstGeom prst="rect">
             <a:avLst/>
@@ -6296,16 +6332,34 @@
           </a:bodyPr>
           <a:lstStyle/>
           <a:p>
-            <a:pPr>
-              <a:defRPr sz="850" b="0" i="0">
+            <a:r>
+              <a:rPr sz="900" b="1">
+                <a:solidFill>
+                  <a:srgbClr val="1C2333"/>
+                </a:solidFill>
+                <a:latin typeface="Avenir Next"/>
+              </a:rPr>
+              <a:t>Figure 8. </a:t>
+            </a:r>
+            <a:r>
+              <a:rPr sz="900">
+                <a:solidFill>
+                  <a:srgbClr val="1C2333"/>
+                </a:solidFill>
+                <a:latin typeface="Avenir Next"/>
+              </a:rPr>
+              <a:t>Correlation with funding speed: structural vs narrative features.</a:t>
+            </a:r>
+          </a:p>
+          <a:p>
+            <a:r>
+              <a:rPr sz="800">
                 <a:solidFill>
                   <a:srgbClr val="6E7278"/>
                 </a:solidFill>
-                <a:latin typeface="Courier New"/>
-              </a:defRPr>
-            </a:pPr>
-            <a:r>
-              <a:t>EDA notebook §9 · correlation table (the 10x basis)</a:t>
+                <a:latin typeface="Avenir Next"/>
+              </a:rPr>
+              <a:t>Notes: Absolute Pearson correlations from the full valid sample. EDA notebook §9.</a:t>
             </a:r>
           </a:p>
         </p:txBody>
@@ -7415,8 +7469,8 @@
         </p:nvSpPr>
         <p:spPr>
           <a:xfrm>
-            <a:off x="7498079" y="6172200"/>
-            <a:ext cx="4206240" cy="274320"/>
+            <a:off x="7498079" y="6053328"/>
+            <a:ext cx="4297680" cy="685800"/>
           </a:xfrm>
           <a:prstGeom prst="rect">
             <a:avLst/>
@@ -7429,16 +7483,34 @@
           </a:bodyPr>
           <a:lstStyle/>
           <a:p>
-            <a:pPr>
-              <a:defRPr sz="850" b="0" i="0">
+            <a:r>
+              <a:rPr sz="900" b="1">
+                <a:solidFill>
+                  <a:srgbClr val="1C2333"/>
+                </a:solidFill>
+                <a:latin typeface="Avenir Next"/>
+              </a:rPr>
+              <a:t>Figure 1. </a:t>
+            </a:r>
+            <a:r>
+              <a:rPr sz="900">
+                <a:solidFill>
+                  <a:srgbClr val="1C2333"/>
+                </a:solidFill>
+                <a:latin typeface="Avenir Next"/>
+              </a:rPr>
+              <a:t>Predicted vs. actual funding speed on the chronological holdout.</a:t>
+            </a:r>
+          </a:p>
+          <a:p>
+            <a:r>
+              <a:rPr sz="800">
                 <a:solidFill>
                   <a:srgbClr val="6E7278"/>
                 </a:solidFill>
-                <a:latin typeface="Courier New"/>
-              </a:defRPr>
-            </a:pPr>
-            <a:r>
-              <a:t>modeling notebook §6 · boosted forecast vs actual on the chronological holdout</a:t>
+                <a:latin typeface="Avenir Next"/>
+              </a:rPr>
+              <a:t>Notes: Boosted model; loans posted 2024-01-01 onward (n = 278,887). Modeling notebook §6.</a:t>
             </a:r>
           </a:p>
         </p:txBody>
@@ -7844,7 +7916,7 @@
         <p:spPr>
           <a:xfrm>
             <a:off x="7498079" y="2834639"/>
-            <a:ext cx="4069080" cy="2801311"/>
+            <a:ext cx="4069080" cy="2835091"/>
           </a:xfrm>
           <a:prstGeom prst="rect">
             <a:avLst/>
@@ -7859,8 +7931,8 @@
         </p:nvSpPr>
         <p:spPr>
           <a:xfrm>
-            <a:off x="7498079" y="6172200"/>
-            <a:ext cx="4206240" cy="274320"/>
+            <a:off x="7498079" y="6053328"/>
+            <a:ext cx="4297680" cy="685800"/>
           </a:xfrm>
           <a:prstGeom prst="rect">
             <a:avLst/>
@@ -7873,16 +7945,34 @@
           </a:bodyPr>
           <a:lstStyle/>
           <a:p>
-            <a:pPr>
-              <a:defRPr sz="850" b="0" i="0">
+            <a:r>
+              <a:rPr sz="900" b="1">
+                <a:solidFill>
+                  <a:srgbClr val="1C2333"/>
+                </a:solidFill>
+                <a:latin typeface="Avenir Next"/>
+              </a:rPr>
+              <a:t>Figure 2. </a:t>
+            </a:r>
+            <a:r>
+              <a:rPr sz="900">
+                <a:solidFill>
+                  <a:srgbClr val="1C2333"/>
+                </a:solidFill>
+                <a:latin typeface="Avenir Next"/>
+              </a:rPr>
+              <a:t>Share of loans funded within 24 hours, by analysis period.</a:t>
+            </a:r>
+          </a:p>
+          <a:p>
+            <a:r>
+              <a:rPr sz="800">
                 <a:solidFill>
                   <a:srgbClr val="6E7278"/>
                 </a:solidFill>
-                <a:latin typeface="Courier New"/>
-              </a:defRPr>
-            </a:pPr>
-            <a:r>
-              <a:t>EDA notebook §4 categorical trends (period chart)</a:t>
+                <a:latin typeface="Avenir Next"/>
+              </a:rPr>
+              <a:t>Notes: Exact shares 46.0% / 30.3% / 30.0%; period sizes shown in axis labels. EDA notebook §4.</a:t>
             </a:r>
           </a:p>
         </p:txBody>
@@ -8287,8 +8377,8 @@
         </p:blipFill>
         <p:spPr>
           <a:xfrm>
-            <a:off x="7672562" y="2834639"/>
-            <a:ext cx="3720114" cy="3291840"/>
+            <a:off x="7750064" y="2834639"/>
+            <a:ext cx="3565109" cy="3154680"/>
           </a:xfrm>
           <a:prstGeom prst="rect">
             <a:avLst/>
@@ -8303,8 +8393,8 @@
         </p:nvSpPr>
         <p:spPr>
           <a:xfrm>
-            <a:off x="7498079" y="6172200"/>
-            <a:ext cx="4206240" cy="274320"/>
+            <a:off x="7498079" y="6053328"/>
+            <a:ext cx="4297680" cy="685800"/>
           </a:xfrm>
           <a:prstGeom prst="rect">
             <a:avLst/>
@@ -8317,16 +8407,34 @@
           </a:bodyPr>
           <a:lstStyle/>
           <a:p>
-            <a:pPr>
-              <a:defRPr sz="850" b="0" i="0">
+            <a:r>
+              <a:rPr sz="900" b="1">
+                <a:solidFill>
+                  <a:srgbClr val="1C2333"/>
+                </a:solidFill>
+                <a:latin typeface="Avenir Next"/>
+              </a:rPr>
+              <a:t>Figure 3. </a:t>
+            </a:r>
+            <a:r>
+              <a:rPr sz="900">
+                <a:solidFill>
+                  <a:srgbClr val="1C2333"/>
+                </a:solidFill>
+                <a:latin typeface="Avenir Next"/>
+              </a:rPr>
+              <a:t>Average funding speed by sector.</a:t>
+            </a:r>
+          </a:p>
+          <a:p>
+            <a:r>
+              <a:rPr sz="800">
                 <a:solidFill>
                   <a:srgbClr val="6E7278"/>
                 </a:solidFill>
-                <a:latin typeface="Courier New"/>
-              </a:defRPr>
-            </a:pPr>
-            <a:r>
-              <a:t>EDA notebook §5 categorical features · §9 feature correlations</a:t>
+                <a:latin typeface="Avenir Next"/>
+              </a:rPr>
+              <a:t>Notes: Bar annotations give per-sector loan counts; dashed line = overall average. EDA notebook §5.</a:t>
             </a:r>
           </a:p>
         </p:txBody>
@@ -8760,7 +8868,7 @@
         <p:spPr>
           <a:xfrm>
             <a:off x="7498079" y="2834639"/>
-            <a:ext cx="4069080" cy="2179495"/>
+            <a:ext cx="4069080" cy="2423160"/>
           </a:xfrm>
           <a:prstGeom prst="rect">
             <a:avLst/>
@@ -8775,8 +8883,8 @@
         </p:nvSpPr>
         <p:spPr>
           <a:xfrm>
-            <a:off x="7498079" y="6172200"/>
-            <a:ext cx="4206240" cy="274320"/>
+            <a:off x="7498079" y="6053328"/>
+            <a:ext cx="4297680" cy="685800"/>
           </a:xfrm>
           <a:prstGeom prst="rect">
             <a:avLst/>
@@ -8789,16 +8897,34 @@
           </a:bodyPr>
           <a:lstStyle/>
           <a:p>
-            <a:pPr>
-              <a:defRPr sz="850" b="0" i="0">
+            <a:r>
+              <a:rPr sz="900" b="1">
+                <a:solidFill>
+                  <a:srgbClr val="1C2333"/>
+                </a:solidFill>
+                <a:latin typeface="Avenir Next"/>
+              </a:rPr>
+              <a:t>Figure 4. </a:t>
+            </a:r>
+            <a:r>
+              <a:rPr sz="900">
+                <a:solidFill>
+                  <a:srgbClr val="1C2333"/>
+                </a:solidFill>
+                <a:latin typeface="Avenir Next"/>
+              </a:rPr>
+              <a:t>Average within-region family-framing slope (duration model).</a:t>
+            </a:r>
+          </a:p>
+          <a:p>
+            <a:r>
+              <a:rPr sz="800">
                 <a:solidFill>
                   <a:srgbClr val="6E7278"/>
                 </a:solidFill>
-                <a:latin typeface="Courier New"/>
-              </a:defRPr>
-            </a:pPr>
-            <a:r>
-              <a:t>modeling notebook §7.2 within-region slopes · §7.1 check</a:t>
+                <a:latin typeface="Avenir Next"/>
+              </a:rPr>
+              <a:t>Notes: Slopes averaged over each region's own moderator mix; few-cluster screen is a conservative heuristic. Executed modeling notebook §7.2.</a:t>
             </a:r>
           </a:p>
         </p:txBody>
@@ -9176,7 +9302,7 @@
         <p:spPr>
           <a:xfrm>
             <a:off x="7498079" y="2834639"/>
-            <a:ext cx="4069080" cy="2255841"/>
+            <a:ext cx="4069080" cy="2312363"/>
           </a:xfrm>
           <a:prstGeom prst="rect">
             <a:avLst/>
@@ -9191,8 +9317,8 @@
         </p:nvSpPr>
         <p:spPr>
           <a:xfrm>
-            <a:off x="7498079" y="6172200"/>
-            <a:ext cx="4206240" cy="274320"/>
+            <a:off x="7498079" y="6053328"/>
+            <a:ext cx="4297680" cy="685800"/>
           </a:xfrm>
           <a:prstGeom prst="rect">
             <a:avLst/>
@@ -9205,16 +9331,34 @@
           </a:bodyPr>
           <a:lstStyle/>
           <a:p>
-            <a:pPr>
-              <a:defRPr sz="850" b="0" i="0">
+            <a:r>
+              <a:rPr sz="900" b="1">
+                <a:solidFill>
+                  <a:srgbClr val="1C2333"/>
+                </a:solidFill>
+                <a:latin typeface="Avenir Next"/>
+              </a:rPr>
+              <a:t>Figure 5. </a:t>
+            </a:r>
+            <a:r>
+              <a:rPr sz="900">
+                <a:solidFill>
+                  <a:srgbClr val="1C2333"/>
+                </a:solidFill>
+                <a:latin typeface="Avenir Next"/>
+              </a:rPr>
+              <a:t>Mean funding speed by story theme.</a:t>
+            </a:r>
+          </a:p>
+          <a:p>
+            <a:r>
+              <a:rPr sz="800">
                 <a:solidFill>
                   <a:srgbClr val="6E7278"/>
                 </a:solidFill>
-                <a:latin typeface="Courier New"/>
-              </a:defRPr>
-            </a:pPr>
-            <a:r>
-              <a:t>EDA notebook §8 topic modeling</a:t>
+                <a:latin typeface="Avenir Next"/>
+              </a:rPr>
+              <a:t>Notes: TF-IDF + NMF, 8 topics, 20K-description sample; themes named from each topic's top words. EDA notebook §8.</a:t>
             </a:r>
           </a:p>
         </p:txBody>

</xml_diff>

<commit_message>
docs: deck body text in DM Sans to match the exhibits
Co-Authored-By: Claude Fable 5 <noreply@anthropic.com>
</commit_message>
<xml_diff>
--- a/docs/presentation/slides_draft.pptx
+++ b/docs/presentation/slides_draft.pptx
@@ -4743,7 +4743,7 @@
                 <a:solidFill>
                   <a:srgbClr val="B8CED6"/>
                 </a:solidFill>
-                <a:latin typeface="Avenir Next"/>
+                <a:latin typeface="DM Sans"/>
               </a:defRPr>
             </a:pPr>
             <a:r>
@@ -4934,7 +4934,7 @@
                 <a:solidFill>
                   <a:srgbClr val="B8CED6"/>
                 </a:solidFill>
-                <a:latin typeface="Avenir Next"/>
+                <a:latin typeface="DM Sans"/>
               </a:defRPr>
             </a:pPr>
             <a:r>
@@ -5112,7 +5112,7 @@
                 <a:solidFill>
                   <a:srgbClr val="B8CED6"/>
                 </a:solidFill>
-                <a:latin typeface="Avenir Next"/>
+                <a:latin typeface="DM Sans"/>
               </a:defRPr>
             </a:pPr>
             <a:r>
@@ -5352,7 +5352,7 @@
                 <a:solidFill>
                   <a:srgbClr val="FFDD04"/>
                 </a:solidFill>
-                <a:latin typeface="Avenir Next"/>
+                <a:latin typeface="DM Sans"/>
               </a:rPr>
               <a:t>▪  </a:t>
             </a:r>
@@ -5361,7 +5361,7 @@
                 <a:solidFill>
                   <a:srgbClr val="1C2333"/>
                 </a:solidFill>
-                <a:latin typeface="Avenir Next"/>
+                <a:latin typeface="DM Sans"/>
               </a:rPr>
               <a:t>Pooled categories: Middle East = Palestine + Yemen (14,946 loans); Central America = Honduras + Nicaragua (59,391); North America = Haiti alone.</a:t>
             </a:r>
@@ -5380,7 +5380,7 @@
                 <a:solidFill>
                   <a:srgbClr val="FFDD04"/>
                 </a:solidFill>
-                <a:latin typeface="Avenir Next"/>
+                <a:latin typeface="DM Sans"/>
               </a:rPr>
               <a:t>▪  </a:t>
             </a:r>
@@ -5389,7 +5389,7 @@
                 <a:solidFill>
                   <a:srgbClr val="1C2333"/>
                 </a:solidFill>
-                <a:latin typeface="Avenir Next"/>
+                <a:latin typeface="DM Sans"/>
               </a:rPr>
               <a:t>Few-cluster screen p (duration / 24h / notebook fit): ME 0.12 / 0.21 / 0.08 · CA 0.06 / 0.14 / 0.07 — same direction in every fit, none significant; t(1) critical value 12.7.</a:t>
             </a:r>
@@ -5408,7 +5408,7 @@
                 <a:solidFill>
                   <a:srgbClr val="FFDD04"/>
                 </a:solidFill>
-                <a:latin typeface="Avenir Next"/>
+                <a:latin typeface="DM Sans"/>
               </a:rPr>
               <a:t>▪  </a:t>
             </a:r>
@@ -5417,7 +5417,7 @@
                 <a:solidFill>
                   <a:srgbClr val="1C2333"/>
                 </a:solidFill>
-                <a:latin typeface="Avenir Next"/>
+                <a:latin typeface="DM Sans"/>
               </a:rPr>
               <a:t>North America: single country — between-country uncertainty not estimable at all.</a:t>
             </a:r>
@@ -5436,7 +5436,7 @@
                 <a:solidFill>
                   <a:srgbClr val="FFDD04"/>
                 </a:solidFill>
-                <a:latin typeface="Avenir Next"/>
+                <a:latin typeface="DM Sans"/>
               </a:rPr>
               <a:t>▪  </a:t>
             </a:r>
@@ -5445,7 +5445,7 @@
                 <a:solidFill>
                   <a:srgbClr val="1C2333"/>
                 </a:solidFill>
-                <a:latin typeface="Avenir Next"/>
+                <a:latin typeface="DM Sans"/>
               </a:rPr>
               <a:t>The screen is a conservative heuristic: it can downgrade a claim, never certify one. Next step: country-stratified A/B test in those four markets.</a:t>
             </a:r>
@@ -5503,7 +5503,7 @@
                 <a:solidFill>
                   <a:srgbClr val="1C2333"/>
                 </a:solidFill>
-                <a:latin typeface="Avenir Next"/>
+                <a:latin typeface="DM Sans"/>
               </a:rPr>
               <a:t>Figure 6. </a:t>
             </a:r>
@@ -5512,7 +5512,7 @@
                 <a:solidFill>
                   <a:srgbClr val="1C2333"/>
                 </a:solidFill>
-                <a:latin typeface="Avenir Next"/>
+                <a:latin typeface="DM Sans"/>
               </a:rPr>
               <a:t>Average funding speed by region.</a:t>
             </a:r>
@@ -5523,7 +5523,7 @@
                 <a:solidFill>
                   <a:srgbClr val="6E7278"/>
                 </a:solidFill>
-                <a:latin typeface="Avenir Next"/>
+                <a:latin typeface="DM Sans"/>
               </a:rPr>
               <a:t>Notes: Bar annotations give per-region loan counts; dashed line = overall average. EDA notebook §5.</a:t>
             </a:r>
@@ -5797,7 +5797,7 @@
                 <a:solidFill>
                   <a:srgbClr val="FFDD04"/>
                 </a:solidFill>
-                <a:latin typeface="Avenir Next"/>
+                <a:latin typeface="DM Sans"/>
               </a:rPr>
               <a:t>▪  </a:t>
             </a:r>
@@ -5806,7 +5806,7 @@
                 <a:solidFill>
                   <a:srgbClr val="1C2333"/>
                 </a:solidFill>
-                <a:latin typeface="Avenir Next"/>
+                <a:latin typeface="DM Sans"/>
               </a:rPr>
               <a:t>SHAP importance from the boosted forecasting model: structure fills the top ranks (amount, term, period, size band, sector, gender).</a:t>
             </a:r>
@@ -5825,7 +5825,7 @@
                 <a:solidFill>
                   <a:srgbClr val="FFDD04"/>
                 </a:solidFill>
-                <a:latin typeface="Avenir Next"/>
+                <a:latin typeface="DM Sans"/>
               </a:rPr>
               <a:t>▪  </a:t>
             </a:r>
@@ -5834,7 +5834,7 @@
                 <a:solidFill>
                   <a:srgbClr val="1C2333"/>
                 </a:solidFill>
-                <a:latin typeface="Avenir Next"/>
+                <a:latin typeface="DM Sans"/>
               </a:rPr>
               <a:t>No family, agency, or urgency feature reaches the top 15; sentiment is 11th despite its disputed significance.</a:t>
             </a:r>
@@ -5853,7 +5853,7 @@
                 <a:solidFill>
                   <a:srgbClr val="FFDD04"/>
                 </a:solidFill>
-                <a:latin typeface="Avenir Next"/>
+                <a:latin typeface="DM Sans"/>
               </a:rPr>
               <a:t>▪  </a:t>
             </a:r>
@@ -5862,7 +5862,7 @@
                 <a:solidFill>
                   <a:srgbClr val="1C2333"/>
                 </a:solidFill>
-                <a:latin typeface="Avenir Next"/>
+                <a:latin typeface="DM Sans"/>
               </a:rPr>
               <a:t>Complementary predictive evidence only — a different model, no region interactions; it cannot confirm or refute any coefficient's sign or uncertainty.</a:t>
             </a:r>
@@ -5920,7 +5920,7 @@
                 <a:solidFill>
                   <a:srgbClr val="1C2333"/>
                 </a:solidFill>
-                <a:latin typeface="Avenir Next"/>
+                <a:latin typeface="DM Sans"/>
               </a:rPr>
               <a:t>Figure 7. </a:t>
             </a:r>
@@ -5929,7 +5929,7 @@
                 <a:solidFill>
                   <a:srgbClr val="1C2333"/>
                 </a:solidFill>
-                <a:latin typeface="Avenir Next"/>
+                <a:latin typeface="DM Sans"/>
               </a:rPr>
               <a:t>Top 15 features by mean |SHAP| value, boosted model.</a:t>
             </a:r>
@@ -5940,7 +5940,7 @@
                 <a:solidFill>
                   <a:srgbClr val="6E7278"/>
                 </a:solidFill>
-                <a:latin typeface="Avenir Next"/>
+                <a:latin typeface="DM Sans"/>
               </a:rPr>
               <a:t>Notes: 2,000-loan holdout sample; sentiment (11th) highlighted as the only narrative feature. Modeling notebook §8.</a:t>
             </a:r>
@@ -6214,7 +6214,7 @@
                 <a:solidFill>
                   <a:srgbClr val="FFDD04"/>
                 </a:solidFill>
-                <a:latin typeface="Avenir Next"/>
+                <a:latin typeface="DM Sans"/>
               </a:rPr>
               <a:t>▪  </a:t>
             </a:r>
@@ -6223,7 +6223,7 @@
                 <a:solidFill>
                   <a:srgbClr val="1C2333"/>
                 </a:solidFill>
-                <a:latin typeface="Avenir Next"/>
+                <a:latin typeface="DM Sans"/>
               </a:rPr>
               <a:t>Correlation with funding speed: loan amount (log) r = 0.43, repayment term r = 0.28 — vs competence 0.058, family 0.019, urgency 0.010.</a:t>
             </a:r>
@@ -6242,7 +6242,7 @@
                 <a:solidFill>
                   <a:srgbClr val="FFDD04"/>
                 </a:solidFill>
-                <a:latin typeface="Avenir Next"/>
+                <a:latin typeface="DM Sans"/>
               </a:rPr>
               <a:t>▪  </a:t>
             </a:r>
@@ -6251,7 +6251,7 @@
                 <a:solidFill>
                   <a:srgbClr val="1C2333"/>
                 </a:solidFill>
-                <a:latin typeface="Avenir Next"/>
+                <a:latin typeface="DM Sans"/>
               </a:rPr>
               <a:t>Loan-amount deciles also rise almost monotonically (~2 days for the smallest asks, ~18 for the largest) — monotonicity, not the 10x basis itself.</a:t>
             </a:r>
@@ -6270,7 +6270,7 @@
                 <a:solidFill>
                   <a:srgbClr val="FFDD04"/>
                 </a:solidFill>
-                <a:latin typeface="Avenir Next"/>
+                <a:latin typeface="DM Sans"/>
               </a:rPr>
               <a:t>▪  </a:t>
             </a:r>
@@ -6279,7 +6279,7 @@
                 <a:solidFill>
                   <a:srgbClr val="1C2333"/>
                 </a:solidFill>
-                <a:latin typeface="Avenir Next"/>
+                <a:latin typeface="DM Sans"/>
               </a:rPr>
               <a:t>Gender: female-posted median 2.3 days vs male 7.7 (male coefficient +0.430 survives HC3 AND country clustering, p &lt; 0.0001 — still associational).</a:t>
             </a:r>
@@ -6337,7 +6337,7 @@
                 <a:solidFill>
                   <a:srgbClr val="1C2333"/>
                 </a:solidFill>
-                <a:latin typeface="Avenir Next"/>
+                <a:latin typeface="DM Sans"/>
               </a:rPr>
               <a:t>Figure 8. </a:t>
             </a:r>
@@ -6346,7 +6346,7 @@
                 <a:solidFill>
                   <a:srgbClr val="1C2333"/>
                 </a:solidFill>
-                <a:latin typeface="Avenir Next"/>
+                <a:latin typeface="DM Sans"/>
               </a:rPr>
               <a:t>Correlation with funding speed: structural vs narrative features.</a:t>
             </a:r>
@@ -6357,7 +6357,7 @@
                 <a:solidFill>
                   <a:srgbClr val="6E7278"/>
                 </a:solidFill>
-                <a:latin typeface="Avenir Next"/>
+                <a:latin typeface="DM Sans"/>
               </a:rPr>
               <a:t>Notes: Absolute Pearson correlations from the full valid sample. EDA notebook §9.</a:t>
             </a:r>
@@ -6631,7 +6631,7 @@
                 <a:solidFill>
                   <a:srgbClr val="FFDD04"/>
                 </a:solidFill>
-                <a:latin typeface="Avenir Next"/>
+                <a:latin typeface="DM Sans"/>
               </a:rPr>
               <a:t>▪  </a:t>
             </a:r>
@@ -6640,7 +6640,7 @@
                 <a:solidFill>
                   <a:srgbClr val="1C2333"/>
                 </a:solidFill>
-                <a:latin typeface="Avenir Next"/>
+                <a:latin typeface="DM Sans"/>
               </a:rPr>
               <a:t>Holdout (posted 2024-01-01 onward): 278,887 loans; 87,466 funded within 24h vs 191,421 not.</a:t>
             </a:r>
@@ -6659,7 +6659,7 @@
                 <a:solidFill>
                   <a:srgbClr val="FFDD04"/>
                 </a:solidFill>
-                <a:latin typeface="Avenir Next"/>
+                <a:latin typeface="DM Sans"/>
               </a:rPr>
               <a:t>▪  </a:t>
             </a:r>
@@ -6668,7 +6668,7 @@
                 <a:solidFill>
                   <a:srgbClr val="1C2333"/>
                 </a:solidFill>
-                <a:latin typeface="Avenir Next"/>
+                <a:latin typeface="DM Sans"/>
               </a:rPr>
               <a:t>ROC AUC 0.8997 · average precision 0.8301 · Brier 0.1156 · accuracy 0.840 — no narrative features needed.</a:t>
             </a:r>
@@ -6687,7 +6687,7 @@
                 <a:solidFill>
                   <a:srgbClr val="FFDD04"/>
                 </a:solidFill>
-                <a:latin typeface="Avenir Next"/>
+                <a:latin typeface="DM Sans"/>
               </a:rPr>
               <a:t>▪  </a:t>
             </a:r>
@@ -6696,7 +6696,7 @@
                 <a:solidFill>
                   <a:srgbClr val="1C2333"/>
                 </a:solidFill>
-                <a:latin typeface="Avenir Next"/>
+                <a:latin typeface="DM Sans"/>
               </a:rPr>
               <a:t>Boundary: negative class = 'eventually funded, but not within 24h'. Expired/withdrawn listings never enter the data — a retrospective ranking prototype among eventual funders.</a:t>
             </a:r>
@@ -6715,7 +6715,7 @@
                 <a:solidFill>
                   <a:srgbClr val="FFDD04"/>
                 </a:solidFill>
-                <a:latin typeface="Avenir Next"/>
+                <a:latin typeface="DM Sans"/>
               </a:rPr>
               <a:t>▪  </a:t>
             </a:r>
@@ -6724,7 +6724,7 @@
                 <a:solidFill>
                   <a:srgbClr val="1C2333"/>
                 </a:solidFill>
-                <a:latin typeface="Avenir Next"/>
+                <a:latin typeface="DM Sans"/>
               </a:rPr>
               <a:t>Path to deployment: all posted listings incl. expired/withdrawn outcomes -&gt; define operational target + censoring window -&gt; retrain, validate -&gt; threshold, calibration, fairness, prospective test.</a:t>
             </a:r>
@@ -6998,7 +6998,7 @@
                 <a:solidFill>
                   <a:srgbClr val="FFDD04"/>
                 </a:solidFill>
-                <a:latin typeface="Avenir Next"/>
+                <a:latin typeface="DM Sans"/>
               </a:rPr>
               <a:t>▪  </a:t>
             </a:r>
@@ -7007,7 +7007,7 @@
                 <a:solidFill>
                   <a:srgbClr val="1C2333"/>
                 </a:solidFill>
-                <a:latin typeface="Avenir Next"/>
+                <a:latin typeface="DM Sans"/>
               </a:rPr>
               <a:t>When a loan's story leans on family, competence, or urgency — does it fund faster?</a:t>
             </a:r>
@@ -7026,7 +7026,7 @@
                 <a:solidFill>
                   <a:srgbClr val="FFDD04"/>
                 </a:solidFill>
-                <a:latin typeface="Avenir Next"/>
+                <a:latin typeface="DM Sans"/>
               </a:rPr>
               <a:t>▪  </a:t>
             </a:r>
@@ -7035,7 +7035,7 @@
                 <a:solidFill>
                   <a:srgbClr val="1C2333"/>
                 </a:solidFill>
-                <a:latin typeface="Avenir Next"/>
+                <a:latin typeface="DM Sans"/>
               </a:rPr>
               <a:t>Does the answer depend on WHO is asking and WHEN?</a:t>
             </a:r>
@@ -7054,7 +7054,7 @@
                 <a:solidFill>
                   <a:srgbClr val="FFDD04"/>
                 </a:solidFill>
-                <a:latin typeface="Avenir Next"/>
+                <a:latin typeface="DM Sans"/>
               </a:rPr>
               <a:t>▪  </a:t>
             </a:r>
@@ -7063,7 +7063,7 @@
                 <a:solidFill>
                   <a:srgbClr val="1C2333"/>
                 </a:solidFill>
-                <a:latin typeface="Avenir Next"/>
+                <a:latin typeface="DM Sans"/>
               </a:rPr>
               <a:t>Why it matters: framing is the one thing a platform can coach — loan size, sector and geography can't be rewritten after the fact.</a:t>
             </a:r>
@@ -7337,7 +7337,7 @@
                 <a:solidFill>
                   <a:srgbClr val="FFDD04"/>
                 </a:solidFill>
-                <a:latin typeface="Avenir Next"/>
+                <a:latin typeface="DM Sans"/>
               </a:rPr>
               <a:t>▪  </a:t>
             </a:r>
@@ -7346,7 +7346,7 @@
                 <a:solidFill>
                   <a:srgbClr val="1C2333"/>
                 </a:solidFill>
-                <a:latin typeface="Avenir Next"/>
+                <a:latin typeface="DM Sans"/>
               </a:rPr>
               <a:t>Predictive claims: trained only on the past, tested only on loans posted 2024–2025 — no peeking at the future.</a:t>
             </a:r>
@@ -7365,7 +7365,7 @@
                 <a:solidFill>
                   <a:srgbClr val="FFDD04"/>
                 </a:solidFill>
-                <a:latin typeface="Avenir Next"/>
+                <a:latin typeface="DM Sans"/>
               </a:rPr>
               <a:t>▪  </a:t>
             </a:r>
@@ -7374,7 +7374,7 @@
                 <a:solidFill>
                   <a:srgbClr val="1C2333"/>
                 </a:solidFill>
-                <a:latin typeface="Avenir Next"/>
+                <a:latin typeface="DM Sans"/>
               </a:rPr>
               <a:t>Framing claims: every 'significant' result re-tested with country-clustered standard errors, then a harsher few-cluster reference where a result rests on a handful of countries.</a:t>
             </a:r>
@@ -7393,7 +7393,7 @@
                 <a:solidFill>
                   <a:srgbClr val="FFDD04"/>
                 </a:solidFill>
-                <a:latin typeface="Avenir Next"/>
+                <a:latin typeface="DM Sans"/>
               </a:rPr>
               <a:t>▪  </a:t>
             </a:r>
@@ -7402,7 +7402,7 @@
                 <a:solidFill>
                   <a:srgbClr val="1C2333"/>
                 </a:solidFill>
-                <a:latin typeface="Avenir Next"/>
+                <a:latin typeface="DM Sans"/>
               </a:rPr>
               <a:t>Most headline-looking results did NOT survive — that is the point of the method.</a:t>
             </a:r>
@@ -7421,7 +7421,7 @@
                 <a:solidFill>
                   <a:srgbClr val="FFDD04"/>
                 </a:solidFill>
-                <a:latin typeface="Avenir Next"/>
+                <a:latin typeface="DM Sans"/>
               </a:rPr>
               <a:t>▪  </a:t>
             </a:r>
@@ -7430,7 +7430,7 @@
                 <a:solidFill>
                   <a:srgbClr val="1C2333"/>
                 </a:solidFill>
-                <a:latin typeface="Avenir Next"/>
+                <a:latin typeface="DM Sans"/>
               </a:rPr>
               <a:t>SHAP importance shown as complementary predictive evidence only — it cannot confirm or refute a statistical finding.</a:t>
             </a:r>
@@ -7488,7 +7488,7 @@
                 <a:solidFill>
                   <a:srgbClr val="1C2333"/>
                 </a:solidFill>
-                <a:latin typeface="Avenir Next"/>
+                <a:latin typeface="DM Sans"/>
               </a:rPr>
               <a:t>Figure 1. </a:t>
             </a:r>
@@ -7497,7 +7497,7 @@
                 <a:solidFill>
                   <a:srgbClr val="1C2333"/>
                 </a:solidFill>
-                <a:latin typeface="Avenir Next"/>
+                <a:latin typeface="DM Sans"/>
               </a:rPr>
               <a:t>Predicted vs. actual funding speed on the chronological holdout.</a:t>
             </a:r>
@@ -7508,7 +7508,7 @@
                 <a:solidFill>
                   <a:srgbClr val="6E7278"/>
                 </a:solidFill>
-                <a:latin typeface="Avenir Next"/>
+                <a:latin typeface="DM Sans"/>
               </a:rPr>
               <a:t>Notes: Boosted model; loans posted 2024-01-01 onward (n = 278,887). Modeling notebook §6.</a:t>
             </a:r>
@@ -7785,7 +7785,7 @@
                 <a:solidFill>
                   <a:srgbClr val="6E7278"/>
                 </a:solidFill>
-                <a:latin typeface="Avenir Next"/>
+                <a:latin typeface="DM Sans"/>
               </a:rPr>
               <a:t>funded within 24 hours</a:t>
             </a:r>
@@ -7827,7 +7827,7 @@
                 <a:solidFill>
                   <a:srgbClr val="FFDD04"/>
                 </a:solidFill>
-                <a:latin typeface="Avenir Next"/>
+                <a:latin typeface="DM Sans"/>
               </a:rPr>
               <a:t>▪  </a:t>
             </a:r>
@@ -7836,7 +7836,7 @@
                 <a:solidFill>
                   <a:srgbClr val="1C2333"/>
                 </a:solidFill>
-                <a:latin typeface="Avenir Next"/>
+                <a:latin typeface="DM Sans"/>
               </a:rPr>
               <a:t>Pre-pandemic, almost half of all loans funded within a day.</a:t>
             </a:r>
@@ -7855,7 +7855,7 @@
                 <a:solidFill>
                   <a:srgbClr val="FFDD04"/>
                 </a:solidFill>
-                <a:latin typeface="Avenir Next"/>
+                <a:latin typeface="DM Sans"/>
               </a:rPr>
               <a:t>▪  </a:t>
             </a:r>
@@ -7864,7 +7864,7 @@
                 <a:solidFill>
                   <a:srgbClr val="1C2333"/>
                 </a:solidFill>
-                <a:latin typeface="Avenir Next"/>
+                <a:latin typeface="DM Sans"/>
               </a:rPr>
               <a:t>Since 2020: under a third — and through the end of the data (2025) it has NOT recovered. Persistence to date, not proof it never will.</a:t>
             </a:r>
@@ -7883,7 +7883,7 @@
                 <a:solidFill>
                   <a:srgbClr val="FFDD04"/>
                 </a:solidFill>
-                <a:latin typeface="Avenir Next"/>
+                <a:latin typeface="DM Sans"/>
               </a:rPr>
               <a:t>▪  </a:t>
             </a:r>
@@ -7892,7 +7892,7 @@
                 <a:solidFill>
                   <a:srgbClr val="1C2333"/>
                 </a:solidFill>
-                <a:latin typeface="Avenir Next"/>
+                <a:latin typeface="DM Sans"/>
               </a:rPr>
               <a:t>589,823 loans before vs. 565,474 after — not a small, noisy sample.</a:t>
             </a:r>
@@ -7950,7 +7950,7 @@
                 <a:solidFill>
                   <a:srgbClr val="1C2333"/>
                 </a:solidFill>
-                <a:latin typeface="Avenir Next"/>
+                <a:latin typeface="DM Sans"/>
               </a:rPr>
               <a:t>Figure 2. </a:t>
             </a:r>
@@ -7959,7 +7959,7 @@
                 <a:solidFill>
                   <a:srgbClr val="1C2333"/>
                 </a:solidFill>
-                <a:latin typeface="Avenir Next"/>
+                <a:latin typeface="DM Sans"/>
               </a:rPr>
               <a:t>Share of loans funded within 24 hours, by analysis period.</a:t>
             </a:r>
@@ -7970,7 +7970,7 @@
                 <a:solidFill>
                   <a:srgbClr val="6E7278"/>
                 </a:solidFill>
-                <a:latin typeface="Avenir Next"/>
+                <a:latin typeface="DM Sans"/>
               </a:rPr>
               <a:t>Notes: Exact shares 46.0% / 30.3% / 30.0%; period sizes shown in axis labels. EDA notebook §4.</a:t>
             </a:r>
@@ -8247,7 +8247,7 @@
                 <a:solidFill>
                   <a:srgbClr val="6E7278"/>
                 </a:solidFill>
-                <a:latin typeface="Avenir Next"/>
+                <a:latin typeface="DM Sans"/>
               </a:rPr>
               <a:t>median funding speed — female- vs male-posted loans</a:t>
             </a:r>
@@ -8289,7 +8289,7 @@
                 <a:solidFill>
                   <a:srgbClr val="FFDD04"/>
                 </a:solidFill>
-                <a:latin typeface="Avenir Next"/>
+                <a:latin typeface="DM Sans"/>
               </a:rPr>
               <a:t>▪  </a:t>
             </a:r>
@@ -8298,7 +8298,7 @@
                 <a:solidFill>
                   <a:srgbClr val="1C2333"/>
                 </a:solidFill>
-                <a:latin typeface="Avenir Next"/>
+                <a:latin typeface="DM Sans"/>
               </a:rPr>
               <a:t>Loan amount + repayment terms: linked to funding speed ~10x more strongly than any single narrative choice.</a:t>
             </a:r>
@@ -8317,7 +8317,7 @@
                 <a:solidFill>
                   <a:srgbClr val="FFDD04"/>
                 </a:solidFill>
-                <a:latin typeface="Avenir Next"/>
+                <a:latin typeface="DM Sans"/>
               </a:rPr>
               <a:t>▪  </a:t>
             </a:r>
@@ -8326,7 +8326,7 @@
                 <a:solidFill>
                   <a:srgbClr val="1C2333"/>
                 </a:solidFill>
-                <a:latin typeface="Avenir Next"/>
+                <a:latin typeface="DM Sans"/>
               </a:rPr>
               <a:t>Sector alone spans well over an order of magnitude in speed; region shows similarly large gaps.</a:t>
             </a:r>
@@ -8345,7 +8345,7 @@
                 <a:solidFill>
                   <a:srgbClr val="FFDD04"/>
                 </a:solidFill>
-                <a:latin typeface="Avenir Next"/>
+                <a:latin typeface="DM Sans"/>
               </a:rPr>
               <a:t>▪  </a:t>
             </a:r>
@@ -8354,7 +8354,7 @@
                 <a:solidFill>
                   <a:srgbClr val="1C2333"/>
                 </a:solidFill>
-                <a:latin typeface="Avenir Next"/>
+                <a:latin typeface="DM Sans"/>
               </a:rPr>
               <a:t>None of this is causal — but it dwarfs anything the words do.</a:t>
             </a:r>
@@ -8412,7 +8412,7 @@
                 <a:solidFill>
                   <a:srgbClr val="1C2333"/>
                 </a:solidFill>
-                <a:latin typeface="Avenir Next"/>
+                <a:latin typeface="DM Sans"/>
               </a:rPr>
               <a:t>Figure 3. </a:t>
             </a:r>
@@ -8421,7 +8421,7 @@
                 <a:solidFill>
                   <a:srgbClr val="1C2333"/>
                 </a:solidFill>
-                <a:latin typeface="Avenir Next"/>
+                <a:latin typeface="DM Sans"/>
               </a:rPr>
               <a:t>Average funding speed by sector.</a:t>
             </a:r>
@@ -8432,7 +8432,7 @@
                 <a:solidFill>
                   <a:srgbClr val="6E7278"/>
                 </a:solidFill>
-                <a:latin typeface="Avenir Next"/>
+                <a:latin typeface="DM Sans"/>
               </a:rPr>
               <a:t>Notes: Bar annotations give per-sector loan counts; dashed line = overall average. EDA notebook §5.</a:t>
             </a:r>
@@ -8709,7 +8709,7 @@
                 <a:solidFill>
                   <a:srgbClr val="6E7278"/>
                 </a:solidFill>
-                <a:latin typeface="Avenir Next"/>
+                <a:latin typeface="DM Sans"/>
               </a:rPr>
               <a:t>is robust enough to support a recommendation</a:t>
             </a:r>
@@ -8751,7 +8751,7 @@
                 <a:solidFill>
                   <a:srgbClr val="FFDD04"/>
                 </a:solidFill>
-                <a:latin typeface="Avenir Next"/>
+                <a:latin typeface="DM Sans"/>
               </a:rPr>
               <a:t>▪  </a:t>
             </a:r>
@@ -8760,7 +8760,7 @@
                 <a:solidFill>
                   <a:srgbClr val="1C2333"/>
                 </a:solidFill>
-                <a:latin typeface="Avenir Next"/>
+                <a:latin typeface="DM Sans"/>
               </a:rPr>
               <a:t>Urgency: looked universal (p&lt;0.001) — collapses under country clustering (p≈0.44). Not recommended.</a:t>
             </a:r>
@@ -8779,7 +8779,7 @@
                 <a:solidFill>
                   <a:srgbClr val="FFDD04"/>
                 </a:solidFill>
-                <a:latin typeface="Avenir Next"/>
+                <a:latin typeface="DM Sans"/>
               </a:rPr>
               <a:t>▪  </a:t>
             </a:r>
@@ -8788,7 +8788,7 @@
                 <a:solidFill>
                   <a:srgbClr val="1C2333"/>
                 </a:solidFill>
-                <a:latin typeface="Avenir Next"/>
+                <a:latin typeface="DM Sans"/>
               </a:rPr>
               <a:t>Family: corrected test → Middle East (Palestine+Yemen) &amp; Central America (Honduras+Nicaragua) same direction in every fit — but 2 countries each; few-cluster t(1) screen bar is 12.7, not 1.96: p≈0.06–0.21. A hypothesis, not a finding.</a:t>
             </a:r>
@@ -8807,7 +8807,7 @@
                 <a:solidFill>
                   <a:srgbClr val="FFDD04"/>
                 </a:solidFill>
-                <a:latin typeface="Avenir Next"/>
+                <a:latin typeface="DM Sans"/>
               </a:rPr>
               <a:t>▪  </a:t>
             </a:r>
@@ -8816,7 +8816,7 @@
                 <a:solidFill>
                   <a:srgbClr val="1C2333"/>
                 </a:solidFill>
-                <a:latin typeface="Avenir Next"/>
+                <a:latin typeface="DM Sans"/>
               </a:rPr>
               <a:t>Sentiment: positive tone &lt;-&gt; slower funding, but significance flips between specifications — genuinely open.</a:t>
             </a:r>
@@ -8835,7 +8835,7 @@
                 <a:solidFill>
                   <a:srgbClr val="FFDD04"/>
                 </a:solidFill>
-                <a:latin typeface="Avenir Next"/>
+                <a:latin typeface="DM Sans"/>
               </a:rPr>
               <a:t>▪  </a:t>
             </a:r>
@@ -8844,7 +8844,7 @@
                 <a:solidFill>
                   <a:srgbClr val="1C2333"/>
                 </a:solidFill>
-                <a:latin typeface="Avenir Next"/>
+                <a:latin typeface="DM Sans"/>
               </a:rPr>
               <a:t>SHAP: no family / agency / urgency feature in the model's top 15 — complementary evidence, not confirmation.</a:t>
             </a:r>
@@ -8902,7 +8902,7 @@
                 <a:solidFill>
                   <a:srgbClr val="1C2333"/>
                 </a:solidFill>
-                <a:latin typeface="Avenir Next"/>
+                <a:latin typeface="DM Sans"/>
               </a:rPr>
               <a:t>Figure 4. </a:t>
             </a:r>
@@ -8911,7 +8911,7 @@
                 <a:solidFill>
                   <a:srgbClr val="1C2333"/>
                 </a:solidFill>
-                <a:latin typeface="Avenir Next"/>
+                <a:latin typeface="DM Sans"/>
               </a:rPr>
               <a:t>Average within-region family-framing slope (duration model).</a:t>
             </a:r>
@@ -8922,7 +8922,7 @@
                 <a:solidFill>
                   <a:srgbClr val="6E7278"/>
                 </a:solidFill>
-                <a:latin typeface="Avenir Next"/>
+                <a:latin typeface="DM Sans"/>
               </a:rPr>
               <a:t>Notes: Slopes averaged over each region's own moderator mix; few-cluster screen is a conservative heuristic. Executed modeling notebook §7.2.</a:t>
             </a:r>
@@ -9199,7 +9199,7 @@
                 <a:solidFill>
                   <a:srgbClr val="6E7278"/>
                 </a:solidFill>
-                <a:latin typeface="Avenir Next"/>
+                <a:latin typeface="DM Sans"/>
               </a:rPr>
               <a:t>mean funding speed across story topics — a &gt;9x swing</a:t>
             </a:r>
@@ -9241,7 +9241,7 @@
                 <a:solidFill>
                   <a:srgbClr val="FFDD04"/>
                 </a:solidFill>
-                <a:latin typeface="Avenir Next"/>
+                <a:latin typeface="DM Sans"/>
               </a:rPr>
               <a:t>▪  </a:t>
             </a:r>
@@ -9250,7 +9250,7 @@
                 <a:solidFill>
                   <a:srgbClr val="1C2333"/>
                 </a:solidFill>
-                <a:latin typeface="Avenir Next"/>
+                <a:latin typeface="DM Sans"/>
               </a:rPr>
               <a:t>Topic modeling on the descriptions (TF-IDF + NMF, 8 topics — not keyword counts) surfaces coherent themes: sanitation, clean water, pig raising, family business, smallholder farming.</a:t>
             </a:r>
@@ -9269,7 +9269,7 @@
                 <a:solidFill>
                   <a:srgbClr val="FFDD04"/>
                 </a:solidFill>
-                <a:latin typeface="Avenir Next"/>
+                <a:latin typeface="DM Sans"/>
               </a:rPr>
               <a:t>▪  </a:t>
             </a:r>
@@ -9278,7 +9278,7 @@
                 <a:solidFill>
                   <a:srgbClr val="1C2333"/>
                 </a:solidFill>
-                <a:latin typeface="Avenir Next"/>
+                <a:latin typeface="DM Sans"/>
               </a:rPr>
               <a:t>The largest single gap anywhere in the analysis — but a topic mostly encodes what the loan is FOR. Structure again, not persuasion.</a:t>
             </a:r>
@@ -9336,7 +9336,7 @@
                 <a:solidFill>
                   <a:srgbClr val="1C2333"/>
                 </a:solidFill>
-                <a:latin typeface="Avenir Next"/>
+                <a:latin typeface="DM Sans"/>
               </a:rPr>
               <a:t>Figure 5. </a:t>
             </a:r>
@@ -9345,7 +9345,7 @@
                 <a:solidFill>
                   <a:srgbClr val="1C2333"/>
                 </a:solidFill>
-                <a:latin typeface="Avenir Next"/>
+                <a:latin typeface="DM Sans"/>
               </a:rPr>
               <a:t>Mean funding speed by story theme.</a:t>
             </a:r>
@@ -9356,7 +9356,7 @@
                 <a:solidFill>
                   <a:srgbClr val="6E7278"/>
                 </a:solidFill>
-                <a:latin typeface="Avenir Next"/>
+                <a:latin typeface="DM Sans"/>
               </a:rPr>
               <a:t>Notes: TF-IDF + NMF, 8 topics, 20K-description sample; themes named from each topic's top words. EDA notebook §8.</a:t>
             </a:r>
@@ -9630,7 +9630,7 @@
                 <a:solidFill>
                   <a:srgbClr val="FFDD04"/>
                 </a:solidFill>
-                <a:latin typeface="Avenir Next"/>
+                <a:latin typeface="DM Sans"/>
               </a:rPr>
               <a:t>▪  </a:t>
             </a:r>
@@ -9639,7 +9639,7 @@
                 <a:solidFill>
                   <a:srgbClr val="1C2333"/>
                 </a:solidFill>
-                <a:latin typeface="Avenir Next"/>
+                <a:latin typeface="DM Sans"/>
               </a:rPr>
               <a:t>DON'T ship writing tips — a platform-wide 'add urgency' nudge would be built on a result that doesn't survive testing.</a:t>
             </a:r>
@@ -9658,7 +9658,7 @@
                 <a:solidFill>
                   <a:srgbClr val="FFDD04"/>
                 </a:solidFill>
-                <a:latin typeface="Avenir Next"/>
+                <a:latin typeface="DM Sans"/>
               </a:rPr>
               <a:t>▪  </a:t>
             </a:r>
@@ -9667,7 +9667,7 @@
                 <a:solidFill>
                   <a:srgbClr val="1C2333"/>
                 </a:solidFill>
-                <a:latin typeface="Avenir Next"/>
+                <a:latin typeface="DM Sans"/>
               </a:rPr>
               <a:t>DO run a country-stratified A/B test of family framing in exactly those 4 markets — that's how a hypothesis becomes a decision.</a:t>
             </a:r>
@@ -9686,7 +9686,7 @@
                 <a:solidFill>
                   <a:srgbClr val="FFDD04"/>
                 </a:solidFill>
-                <a:latin typeface="Avenir Next"/>
+                <a:latin typeface="DM Sans"/>
               </a:rPr>
               <a:t>▪  </a:t>
             </a:r>
@@ -9695,7 +9695,7 @@
                 <a:solidFill>
                   <a:srgbClr val="1C2333"/>
                 </a:solidFill>
-                <a:latin typeface="Avenir Next"/>
+                <a:latin typeface="DM Sans"/>
               </a:rPr>
               <a:t>DO review the structural gaps (sector / region / gender) — they are ~10x the size of any wording effect.</a:t>
             </a:r>
@@ -9714,7 +9714,7 @@
                 <a:solidFill>
                   <a:srgbClr val="FFDD04"/>
                 </a:solidFill>
-                <a:latin typeface="Avenir Next"/>
+                <a:latin typeface="DM Sans"/>
               </a:rPr>
               <a:t>▪  </a:t>
             </a:r>
@@ -9723,7 +9723,7 @@
                 <a:solidFill>
                   <a:srgbClr val="1C2333"/>
                 </a:solidFill>
-                <a:latin typeface="Avenir Next"/>
+                <a:latin typeface="DM Sans"/>
               </a:rPr>
               <a:t>PROTOTYPE, then re-validate: the 24h classifier ranks well among eventually-funded loans (AUC ≈ 0.90, strictly future data) — but expired/withdrawn listings aren't in the data, so an early-warning flag first needs all posted listings, a defined target, and retraining on that population.</a:t>
             </a:r>
@@ -9997,7 +9997,7 @@
                 <a:solidFill>
                   <a:srgbClr val="FFDD04"/>
                 </a:solidFill>
-                <a:latin typeface="Avenir Next"/>
+                <a:latin typeface="DM Sans"/>
               </a:rPr>
               <a:t>▪  </a:t>
             </a:r>
@@ -10006,7 +10006,7 @@
                 <a:solidFill>
                   <a:srgbClr val="1C2333"/>
                 </a:solidFill>
-                <a:latin typeface="Avenir Next"/>
+                <a:latin typeface="DM Sans"/>
               </a:rPr>
               <a:t>Association, never causation — no borrower was randomly assigned a writing style.</a:t>
             </a:r>
@@ -10025,7 +10025,7 @@
                 <a:solidFill>
                   <a:srgbClr val="FFDD04"/>
                 </a:solidFill>
-                <a:latin typeface="Avenir Next"/>
+                <a:latin typeface="DM Sans"/>
               </a:rPr>
               <a:t>▪  </a:t>
             </a:r>
@@ -10034,7 +10034,7 @@
                 <a:solidFill>
                   <a:srgbClr val="1C2333"/>
                 </a:solidFill>
-                <a:latin typeface="Avenir Next"/>
+                <a:latin typeface="DM Sans"/>
               </a:rPr>
               <a:t>Measures how fast a FUNDED loan funds — not whether a loan gets funded at all (expired/withdrawn listings never enter the data).</a:t>
             </a:r>
@@ -10053,7 +10053,7 @@
                 <a:solidFill>
                   <a:srgbClr val="FFDD04"/>
                 </a:solidFill>
-                <a:latin typeface="Avenir Next"/>
+                <a:latin typeface="DM Sans"/>
               </a:rPr>
               <a:t>▪  </a:t>
             </a:r>
@@ -10062,7 +10062,7 @@
                 <a:solidFill>
                   <a:srgbClr val="1C2333"/>
                 </a:solidFill>
-                <a:latin typeface="Avenir Next"/>
+                <a:latin typeface="DM Sans"/>
               </a:rPr>
               <a:t>Framing measured with transparent, simple rules — not every nuance of persuasive writing.</a:t>
             </a:r>

</xml_diff>

<commit_message>
docs: all deck exhibits now purpose-built in house style
Replaced the last three notebook screenshots with scripted exhibits:
- S3: chronological-split schematic (train 1,174,953 / test 278,887,
  boundary 2024-01-01, from the authoritative snapshot)
- S5 sector + A1 region: mean speeds computed from data/Kiva_Loans.pkl
  replicating the EDA notebook's exact grouping - every per-category
  count verified identical to the executed notebook's printed n=
  annotations before charting
All 8 exhibits: DM Sans, left-aligned titles, navy/viridis/#FFDD04,
Figure+Notes captions; unused screenshot assets removed; QA clean.

Co-Authored-By: Claude Fable 5 <noreply@anthropic.com>
</commit_message>
<xml_diff>
--- a/docs/presentation/slides_draft.pptx
+++ b/docs/presentation/slides_draft.pptx
@@ -750,7 +750,7 @@
           <a:p/>
           <a:p>
             <a:r>
-              <a:t>[Sources] Region panel: EDA SS5 figure. Pooled definitions + p-values: association_summary.txt within-region section.</a:t>
+              <a:t>[Sources] Region means computed from data/Kiva_Loans.pkl replicating EDA SS5 grouping (counts verified). Pooled definitions + p-values: association_summary.txt.</a:t>
             </a:r>
           </a:p>
         </p:txBody>
@@ -1130,7 +1130,7 @@
           <a:p/>
           <a:p>
             <a:r>
-              <a:t>[Sources] Chart: modeling notebook SS6 (boosted forecast vs actual, chronological holdout). Split sizes: analysis_summary.json.</a:t>
+              <a:t>[Sources] Split schematic drawn from analysis_summary.json split sizes (train 1,174,953 / holdout 278,887; boundary 2024-01-01).</a:t>
             </a:r>
           </a:p>
         </p:txBody>
@@ -1282,7 +1282,7 @@
           <a:p/>
           <a:p>
             <a:r>
-              <a:t>[Sources] Chart: EDA SS5 sector figure (executed notebook). Gender medians: EDA SS4 printout. 10x basis: EDA SS9 correlations.</a:t>
+              <a:t>[Sources] Sector means computed from data/Kiva_Loans.pkl replicating EDA SS5 grouping (counts verified vs executed notebook). Gender medians: EDA SS4 printout.</a:t>
             </a:r>
           </a:p>
         </p:txBody>
@@ -5454,7 +5454,7 @@
       </p:sp>
       <p:pic>
         <p:nvPicPr>
-          <p:cNvPr id="7" name="Picture 6" descr="region_speed.png"/>
+          <p:cNvPr id="7" name="Picture 6" descr="region.png"/>
           <p:cNvPicPr>
             <a:picLocks noChangeAspect="1"/>
           </p:cNvPicPr>
@@ -5469,7 +5469,7 @@
         <p:spPr>
           <a:xfrm>
             <a:off x="7498079" y="1783080"/>
-            <a:ext cx="4069080" cy="3259729"/>
+            <a:ext cx="4069080" cy="2411608"/>
           </a:xfrm>
           <a:prstGeom prst="rect">
             <a:avLst/>
@@ -5514,7 +5514,7 @@
                 </a:solidFill>
                 <a:latin typeface="DM Sans"/>
               </a:rPr>
-              <a:t>Average funding speed by region.</a:t>
+              <a:t>Mean funding speed by region.</a:t>
             </a:r>
           </a:p>
           <a:p>
@@ -5525,7 +5525,7 @@
                 </a:solidFill>
                 <a:latin typeface="DM Sans"/>
               </a:rPr>
-              <a:t>Notes: Bar annotations give per-region loan counts; dashed line = overall average. EDA notebook §5.</a:t>
+              <a:t>Notes: Computed from the raw data replicating EDA §5 grouping; all counts match the executed notebook.</a:t>
             </a:r>
           </a:p>
         </p:txBody>
@@ -7439,7 +7439,7 @@
       </p:sp>
       <p:pic>
         <p:nvPicPr>
-          <p:cNvPr id="7" name="Picture 6" descr="mod_21.png"/>
+          <p:cNvPr id="7" name="Picture 6" descr="data_split.png"/>
           <p:cNvPicPr>
             <a:picLocks noChangeAspect="1"/>
           </p:cNvPicPr>
@@ -7454,7 +7454,7 @@
         <p:spPr>
           <a:xfrm>
             <a:off x="7498079" y="1783080"/>
-            <a:ext cx="4069080" cy="4074986"/>
+            <a:ext cx="4069080" cy="2128811"/>
           </a:xfrm>
           <a:prstGeom prst="rect">
             <a:avLst/>
@@ -7499,7 +7499,7 @@
                 </a:solidFill>
                 <a:latin typeface="DM Sans"/>
               </a:rPr>
-              <a:t>Predicted vs. actual funding speed on the chronological holdout.</a:t>
+              <a:t>Chronological train/test split.</a:t>
             </a:r>
           </a:p>
           <a:p>
@@ -7510,7 +7510,7 @@
                 </a:solidFill>
                 <a:latin typeface="DM Sans"/>
               </a:rPr>
-              <a:t>Notes: Boosted model; loans posted 2024-01-01 onward (n = 278,887). Modeling notebook §6.</a:t>
+              <a:t>Notes: Train 1,174,953 loans (2016-2023); test 278,887 (posted 2024-01-01 onward). Counts from the authoritative snapshot.</a:t>
             </a:r>
           </a:p>
         </p:txBody>
@@ -8363,7 +8363,7 @@
       </p:sp>
       <p:pic>
         <p:nvPicPr>
-          <p:cNvPr id="8" name="Picture 7" descr="eda_22.png"/>
+          <p:cNvPr id="8" name="Picture 7" descr="sector.png"/>
           <p:cNvPicPr>
             <a:picLocks noChangeAspect="1"/>
           </p:cNvPicPr>
@@ -8377,8 +8377,8 @@
         </p:blipFill>
         <p:spPr>
           <a:xfrm>
-            <a:off x="7750064" y="2834639"/>
-            <a:ext cx="3565109" cy="3154680"/>
+            <a:off x="7498079" y="2834639"/>
+            <a:ext cx="4069080" cy="3010314"/>
           </a:xfrm>
           <a:prstGeom prst="rect">
             <a:avLst/>
@@ -8423,7 +8423,7 @@
                 </a:solidFill>
                 <a:latin typeface="DM Sans"/>
               </a:rPr>
-              <a:t>Average funding speed by sector.</a:t>
+              <a:t>Mean funding speed by sector.</a:t>
             </a:r>
           </a:p>
           <a:p>
@@ -8434,7 +8434,7 @@
                 </a:solidFill>
                 <a:latin typeface="DM Sans"/>
               </a:rPr>
-              <a:t>Notes: Bar annotations give per-sector loan counts; dashed line = overall average. EDA notebook §5.</a:t>
+              <a:t>Notes: Computed from the raw data replicating EDA §5 grouping (sectors under 1,000 loans folded into Other); all counts match the executed notebook.</a:t>
             </a:r>
           </a:p>
         </p:txBody>

</xml_diff>

<commit_message>
docs: uniform typography across all exhibits at native on-slide sizes
Chart builder rewritten around a fixed type spec (title 13pt / labels
10.5 / ticks 10 / annotations 9.5) with each figure authored at its
physical on-slide size and saved at 300 dpi - inserting any PNG at
native size renders identical text across charts, no rescaling needed.
Draft deck now places exhibits at native size (downscales only on
overflow). Period tick labels shortened (Ns moved to the Figure Notes).
All rebuilt exhibits visually verified.

Co-Authored-By: Claude Fable 5 <noreply@anthropic.com>
</commit_message>
<xml_diff>
--- a/docs/presentation/slides_draft.pptx
+++ b/docs/presentation/slides_draft.pptx
@@ -5469,7 +5469,7 @@
         <p:spPr>
           <a:xfrm>
             <a:off x="7498079" y="1783080"/>
-            <a:ext cx="4069080" cy="2411608"/>
+            <a:ext cx="4160519" cy="2667361"/>
           </a:xfrm>
           <a:prstGeom prst="rect">
             <a:avLst/>
@@ -5886,7 +5886,7 @@
         <p:spPr>
           <a:xfrm>
             <a:off x="7498079" y="1783080"/>
-            <a:ext cx="4069080" cy="2386105"/>
+            <a:ext cx="4160520" cy="3164840"/>
           </a:xfrm>
           <a:prstGeom prst="rect">
             <a:avLst/>
@@ -6303,7 +6303,7 @@
         <p:spPr>
           <a:xfrm>
             <a:off x="7498079" y="1783080"/>
-            <a:ext cx="4069080" cy="2099003"/>
+            <a:ext cx="4160520" cy="2329705"/>
           </a:xfrm>
           <a:prstGeom prst="rect">
             <a:avLst/>
@@ -7453,8 +7453,8 @@
         </p:blipFill>
         <p:spPr>
           <a:xfrm>
-            <a:off x="7498079" y="1783080"/>
-            <a:ext cx="4069080" cy="2128811"/>
+            <a:off x="7892795" y="1783080"/>
+            <a:ext cx="3371088" cy="2206752"/>
           </a:xfrm>
           <a:prstGeom prst="rect">
             <a:avLst/>
@@ -7915,8 +7915,8 @@
         </p:blipFill>
         <p:spPr>
           <a:xfrm>
-            <a:off x="7498079" y="2834639"/>
-            <a:ext cx="4069080" cy="2835091"/>
+            <a:off x="7676387" y="2834639"/>
+            <a:ext cx="3803904" cy="3112008"/>
           </a:xfrm>
           <a:prstGeom prst="rect">
             <a:avLst/>
@@ -7972,7 +7972,7 @@
                 </a:solidFill>
                 <a:latin typeface="DM Sans"/>
               </a:rPr>
-              <a:t>Notes: Exact shares 46.0% / 30.3% / 30.0%; period sizes shown in axis labels. EDA notebook §4.</a:t>
+              <a:t>Notes: Exact shares 46.0% / 30.3% / 30.0%; period sizes 589,823 / 298,549 / 565,474 loans. EDA notebook §4.</a:t>
             </a:r>
           </a:p>
         </p:txBody>
@@ -8377,8 +8377,8 @@
         </p:blipFill>
         <p:spPr>
           <a:xfrm>
-            <a:off x="7498079" y="2834639"/>
-            <a:ext cx="4069080" cy="3010314"/>
+            <a:off x="7808916" y="2834639"/>
+            <a:ext cx="3538845" cy="3154680"/>
           </a:xfrm>
           <a:prstGeom prst="rect">
             <a:avLst/>
@@ -8868,7 +8868,7 @@
         <p:spPr>
           <a:xfrm>
             <a:off x="7498079" y="2834639"/>
-            <a:ext cx="4069080" cy="2423160"/>
+            <a:ext cx="4160520" cy="2017503"/>
           </a:xfrm>
           <a:prstGeom prst="rect">
             <a:avLst/>
@@ -9302,7 +9302,7 @@
         <p:spPr>
           <a:xfrm>
             <a:off x="7498079" y="2834639"/>
-            <a:ext cx="4069080" cy="2312363"/>
+            <a:ext cx="4160519" cy="2696957"/>
           </a:xfrm>
           <a:prstGeom prst="rect">
             <a:avLst/>

</xml_diff>

<commit_message>
docs: close Codex round 10 - true native-size exhibits, honest chart provenance
- Slide 3 contract fixed: brief + caption + generator all name the split
  schematic actually shown (forecast scatter noted as optional backup)
- Exhibits saved at exact authored size (no bbox growth); every chart
  authored within its placed column; deck QA now asserts scale=1.000 for
  all 8 (previously 74-91% silent downscales); compact 10pt few-cluster
  table; captions raised to 10/9pt; 4 visual regressions caught+fixed
- build_charts.py docstring/README now honestly label values as
  transcribed literals; new --verify path recomputes every pkl-derived
  aggregate from raw data and asserts equality (run green; caught one
  decile transcription slip)
- Font-install handoff documented (fonts/README + main README); icons
  README reframed as unplaced candidates pending provenance
- 114 tests pass; PDF re-rendered; artifact republished

Co-Authored-By: Claude Fable 5 <noreply@anthropic.com>
</commit_message>
<xml_diff>
--- a/docs/presentation/slides_draft.pptx
+++ b/docs/presentation/slides_draft.pptx
@@ -5469,7 +5469,7 @@
         <p:spPr>
           <a:xfrm>
             <a:off x="7498079" y="1783080"/>
-            <a:ext cx="4160519" cy="2667361"/>
+            <a:ext cx="4160520" cy="2468880"/>
           </a:xfrm>
           <a:prstGeom prst="rect">
             <a:avLst/>
@@ -5499,7 +5499,7 @@
           <a:lstStyle/>
           <a:p>
             <a:r>
-              <a:rPr sz="900" b="1">
+              <a:rPr sz="1000" b="1">
                 <a:solidFill>
                   <a:srgbClr val="1C2333"/>
                 </a:solidFill>
@@ -5508,7 +5508,7 @@
               <a:t>Figure 6. </a:t>
             </a:r>
             <a:r>
-              <a:rPr sz="900">
+              <a:rPr sz="1000">
                 <a:solidFill>
                   <a:srgbClr val="1C2333"/>
                 </a:solidFill>
@@ -5519,7 +5519,7 @@
           </a:p>
           <a:p>
             <a:r>
-              <a:rPr sz="800">
+              <a:rPr sz="900">
                 <a:solidFill>
                   <a:srgbClr val="6E7278"/>
                 </a:solidFill>
@@ -5886,7 +5886,7 @@
         <p:spPr>
           <a:xfrm>
             <a:off x="7498079" y="1783080"/>
-            <a:ext cx="4160520" cy="3164840"/>
+            <a:ext cx="4160520" cy="3566160"/>
           </a:xfrm>
           <a:prstGeom prst="rect">
             <a:avLst/>
@@ -5916,7 +5916,7 @@
           <a:lstStyle/>
           <a:p>
             <a:r>
-              <a:rPr sz="900" b="1">
+              <a:rPr sz="1000" b="1">
                 <a:solidFill>
                   <a:srgbClr val="1C2333"/>
                 </a:solidFill>
@@ -5925,7 +5925,7 @@
               <a:t>Figure 7. </a:t>
             </a:r>
             <a:r>
-              <a:rPr sz="900">
+              <a:rPr sz="1000">
                 <a:solidFill>
                   <a:srgbClr val="1C2333"/>
                 </a:solidFill>
@@ -5936,7 +5936,7 @@
           </a:p>
           <a:p>
             <a:r>
-              <a:rPr sz="800">
+              <a:rPr sz="900">
                 <a:solidFill>
                   <a:srgbClr val="6E7278"/>
                 </a:solidFill>
@@ -6303,7 +6303,7 @@
         <p:spPr>
           <a:xfrm>
             <a:off x="7498079" y="1783080"/>
-            <a:ext cx="4160520" cy="2329705"/>
+            <a:ext cx="4160520" cy="2468880"/>
           </a:xfrm>
           <a:prstGeom prst="rect">
             <a:avLst/>
@@ -6333,7 +6333,7 @@
           <a:lstStyle/>
           <a:p>
             <a:r>
-              <a:rPr sz="900" b="1">
+              <a:rPr sz="1000" b="1">
                 <a:solidFill>
                   <a:srgbClr val="1C2333"/>
                 </a:solidFill>
@@ -6342,7 +6342,7 @@
               <a:t>Figure 8. </a:t>
             </a:r>
             <a:r>
-              <a:rPr sz="900">
+              <a:rPr sz="1000">
                 <a:solidFill>
                   <a:srgbClr val="1C2333"/>
                 </a:solidFill>
@@ -6353,7 +6353,7 @@
           </a:p>
           <a:p>
             <a:r>
-              <a:rPr sz="800">
+              <a:rPr sz="900">
                 <a:solidFill>
                   <a:srgbClr val="6E7278"/>
                 </a:solidFill>
@@ -7453,8 +7453,8 @@
         </p:blipFill>
         <p:spPr>
           <a:xfrm>
-            <a:off x="7892795" y="1783080"/>
-            <a:ext cx="3371088" cy="2206752"/>
+            <a:off x="7520939" y="1783080"/>
+            <a:ext cx="4114800" cy="2103120"/>
           </a:xfrm>
           <a:prstGeom prst="rect">
             <a:avLst/>
@@ -7484,7 +7484,7 @@
           <a:lstStyle/>
           <a:p>
             <a:r>
-              <a:rPr sz="900" b="1">
+              <a:rPr sz="1000" b="1">
                 <a:solidFill>
                   <a:srgbClr val="1C2333"/>
                 </a:solidFill>
@@ -7493,7 +7493,7 @@
               <a:t>Figure 1. </a:t>
             </a:r>
             <a:r>
-              <a:rPr sz="900">
+              <a:rPr sz="1000">
                 <a:solidFill>
                   <a:srgbClr val="1C2333"/>
                 </a:solidFill>
@@ -7504,7 +7504,7 @@
           </a:p>
           <a:p>
             <a:r>
-              <a:rPr sz="800">
+              <a:rPr sz="900">
                 <a:solidFill>
                   <a:srgbClr val="6E7278"/>
                 </a:solidFill>
@@ -7756,7 +7756,7 @@
         <p:spPr>
           <a:xfrm>
             <a:off x="685800" y="1783080"/>
-            <a:ext cx="11064240" cy="914400"/>
+            <a:ext cx="6720840" cy="914400"/>
           </a:xfrm>
           <a:prstGeom prst="rect">
             <a:avLst/>
@@ -7915,8 +7915,8 @@
         </p:blipFill>
         <p:spPr>
           <a:xfrm>
-            <a:off x="7676387" y="2834639"/>
-            <a:ext cx="3803904" cy="3112008"/>
+            <a:off x="7520939" y="1783080"/>
+            <a:ext cx="4114800" cy="3017520"/>
           </a:xfrm>
           <a:prstGeom prst="rect">
             <a:avLst/>
@@ -7946,7 +7946,7 @@
           <a:lstStyle/>
           <a:p>
             <a:r>
-              <a:rPr sz="900" b="1">
+              <a:rPr sz="1000" b="1">
                 <a:solidFill>
                   <a:srgbClr val="1C2333"/>
                 </a:solidFill>
@@ -7955,7 +7955,7 @@
               <a:t>Figure 2. </a:t>
             </a:r>
             <a:r>
-              <a:rPr sz="900">
+              <a:rPr sz="1000">
                 <a:solidFill>
                   <a:srgbClr val="1C2333"/>
                 </a:solidFill>
@@ -7966,7 +7966,7 @@
           </a:p>
           <a:p>
             <a:r>
-              <a:rPr sz="800">
+              <a:rPr sz="900">
                 <a:solidFill>
                   <a:srgbClr val="6E7278"/>
                 </a:solidFill>
@@ -8218,7 +8218,7 @@
         <p:spPr>
           <a:xfrm>
             <a:off x="685800" y="1783080"/>
-            <a:ext cx="11064240" cy="914400"/>
+            <a:ext cx="6720840" cy="914400"/>
           </a:xfrm>
           <a:prstGeom prst="rect">
             <a:avLst/>
@@ -8377,8 +8377,8 @@
         </p:blipFill>
         <p:spPr>
           <a:xfrm>
-            <a:off x="7808916" y="2834639"/>
-            <a:ext cx="3538845" cy="3154680"/>
+            <a:off x="7498079" y="1783080"/>
+            <a:ext cx="4160520" cy="4114800"/>
           </a:xfrm>
           <a:prstGeom prst="rect">
             <a:avLst/>
@@ -8408,7 +8408,7 @@
           <a:lstStyle/>
           <a:p>
             <a:r>
-              <a:rPr sz="900" b="1">
+              <a:rPr sz="1000" b="1">
                 <a:solidFill>
                   <a:srgbClr val="1C2333"/>
                 </a:solidFill>
@@ -8417,7 +8417,7 @@
               <a:t>Figure 3. </a:t>
             </a:r>
             <a:r>
-              <a:rPr sz="900">
+              <a:rPr sz="1000">
                 <a:solidFill>
                   <a:srgbClr val="1C2333"/>
                 </a:solidFill>
@@ -8428,7 +8428,7 @@
           </a:p>
           <a:p>
             <a:r>
-              <a:rPr sz="800">
+              <a:rPr sz="900">
                 <a:solidFill>
                   <a:srgbClr val="6E7278"/>
                 </a:solidFill>
@@ -8680,7 +8680,7 @@
         <p:spPr>
           <a:xfrm>
             <a:off x="685800" y="1783080"/>
-            <a:ext cx="11064240" cy="914400"/>
+            <a:ext cx="6720840" cy="914400"/>
           </a:xfrm>
           <a:prstGeom prst="rect">
             <a:avLst/>
@@ -8867,8 +8867,8 @@
         </p:blipFill>
         <p:spPr>
           <a:xfrm>
-            <a:off x="7498079" y="2834639"/>
-            <a:ext cx="4160520" cy="2017503"/>
+            <a:off x="7498079" y="1783080"/>
+            <a:ext cx="4160520" cy="2514600"/>
           </a:xfrm>
           <a:prstGeom prst="rect">
             <a:avLst/>
@@ -8898,7 +8898,7 @@
           <a:lstStyle/>
           <a:p>
             <a:r>
-              <a:rPr sz="900" b="1">
+              <a:rPr sz="1000" b="1">
                 <a:solidFill>
                   <a:srgbClr val="1C2333"/>
                 </a:solidFill>
@@ -8907,7 +8907,7 @@
               <a:t>Figure 4. </a:t>
             </a:r>
             <a:r>
-              <a:rPr sz="900">
+              <a:rPr sz="1000">
                 <a:solidFill>
                   <a:srgbClr val="1C2333"/>
                 </a:solidFill>
@@ -8918,7 +8918,7 @@
           </a:p>
           <a:p>
             <a:r>
-              <a:rPr sz="800">
+              <a:rPr sz="900">
                 <a:solidFill>
                   <a:srgbClr val="6E7278"/>
                 </a:solidFill>
@@ -9170,7 +9170,7 @@
         <p:spPr>
           <a:xfrm>
             <a:off x="685800" y="1783080"/>
-            <a:ext cx="11064240" cy="914400"/>
+            <a:ext cx="6720840" cy="914400"/>
           </a:xfrm>
           <a:prstGeom prst="rect">
             <a:avLst/>
@@ -9301,8 +9301,8 @@
         </p:blipFill>
         <p:spPr>
           <a:xfrm>
-            <a:off x="7498079" y="2834639"/>
-            <a:ext cx="4160519" cy="2696957"/>
+            <a:off x="7498079" y="1783080"/>
+            <a:ext cx="4160520" cy="2743200"/>
           </a:xfrm>
           <a:prstGeom prst="rect">
             <a:avLst/>
@@ -9332,7 +9332,7 @@
           <a:lstStyle/>
           <a:p>
             <a:r>
-              <a:rPr sz="900" b="1">
+              <a:rPr sz="1000" b="1">
                 <a:solidFill>
                   <a:srgbClr val="1C2333"/>
                 </a:solidFill>
@@ -9341,7 +9341,7 @@
               <a:t>Figure 5. </a:t>
             </a:r>
             <a:r>
-              <a:rPr sz="900">
+              <a:rPr sz="1000">
                 <a:solidFill>
                   <a:srgbClr val="1C2333"/>
                 </a:solidFill>
@@ -9352,7 +9352,7 @@
           </a:p>
           <a:p>
             <a:r>
-              <a:rPr sz="800">
+              <a:rPr sz="900">
                 <a:solidFill>
                   <a:srgbClr val="6E7278"/>
                 </a:solidFill>

</xml_diff>

<commit_message>
docs: figure Notes now lead with a verified takeaway hook
Each exhibit's Notes line opens with the one striking reading of the
figure (13x sector spread, -0.3pt 'recovery', t(1)=12.7 bar, ~7x
correlation gap, ten-structural-before-one-narrative SHAP) followed by
the provenance - all hooks derived from already-verified numbers.

Co-Authored-By: Claude Fable 5 <noreply@anthropic.com>
</commit_message>
<xml_diff>
--- a/docs/presentation/slides_draft.pptx
+++ b/docs/presentation/slides_draft.pptx
@@ -5525,7 +5525,7 @@
                 </a:solidFill>
                 <a:latin typeface="DM Sans"/>
               </a:rPr>
-              <a:t>Notes: Computed from the raw data replicating EDA §5 grouping; all counts match the executed notebook.</a:t>
+              <a:t>Notes: North America is Haiti alone (n = 7,559) - fastest region, and exactly why single-cluster inference is off the table. Computed from the raw data (counts verified vs executed notebook).</a:t>
             </a:r>
           </a:p>
         </p:txBody>
@@ -5942,7 +5942,7 @@
                 </a:solidFill>
                 <a:latin typeface="DM Sans"/>
               </a:rPr>
-              <a:t>Notes: 2,000-loan holdout sample; sentiment (11th) highlighted as the only narrative feature. Modeling notebook §8.</a:t>
+              <a:t>Notes: Ten structural features outrank the first narrative one. Rebuilt from modeling §8 printed values (2,000-loan holdout sample).</a:t>
             </a:r>
           </a:p>
         </p:txBody>
@@ -6359,7 +6359,7 @@
                 </a:solidFill>
                 <a:latin typeface="DM Sans"/>
               </a:rPr>
-              <a:t>Notes: Absolute Pearson correlations from the full valid sample. EDA notebook §9.</a:t>
+              <a:t>Notes: Loan amount correlates ~7x stronger with speed than the best narrative signal (0.429 vs 0.058). EDA §9 printed correlation table.</a:t>
             </a:r>
           </a:p>
         </p:txBody>
@@ -7510,7 +7510,7 @@
                 </a:solidFill>
                 <a:latin typeface="DM Sans"/>
               </a:rPr>
-              <a:t>Notes: Train 1,174,953 loans (2016-2023); test 278,887 (posted 2024-01-01 onward). Counts from the authoritative snapshot.</a:t>
+              <a:t>Notes: The 278,887 test loans stayed sealed during training - the models never see the future they are scored on. Counts: analysis_summary.json (boundary 2024-01-01).</a:t>
             </a:r>
           </a:p>
         </p:txBody>
@@ -7972,7 +7972,7 @@
                 </a:solidFill>
                 <a:latin typeface="DM Sans"/>
               </a:rPr>
-              <a:t>Notes: Exact shares 46.0% / 30.3% / 30.0%; period sizes 589,823 / 298,549 / 565,474 loans. EDA notebook §4.</a:t>
+              <a:t>Notes: The drop is 16 points; the 'recovery' is -0.3. Exact shares 46.0% / 30.3% / 30.0% (589,823 / 298,549 / 565,474 loans). EDA notebook §4.</a:t>
             </a:r>
           </a:p>
         </p:txBody>
@@ -8434,7 +8434,7 @@
                 </a:solidFill>
                 <a:latin typeface="DM Sans"/>
               </a:rPr>
-              <a:t>Notes: Computed from the raw data replicating EDA §5 grouping (sectors under 1,000 loans folded into Other); all counts match the executed notebook.</a:t>
+              <a:t>Notes: Sanitation loans fund ~13x faster than Clothing (0.9 vs 12.1 days). Computed from the raw data replicating EDA §5 grouping; every count matches the executed notebook.</a:t>
             </a:r>
           </a:p>
         </p:txBody>
@@ -8924,7 +8924,7 @@
                 </a:solidFill>
                 <a:latin typeface="DM Sans"/>
               </a:rPr>
-              <a:t>Notes: Slopes averaged over each region's own moderator mix; few-cluster screen is a conservative heuristic. Executed modeling notebook §7.2.</a:t>
+              <a:t>Notes: For a two-country region the significance bar is t(1) = 12.7, not 1.96 - nothing clears it. Typeset from executed §7.2 (v15); 4-dp values in analysis_summary.json.</a:t>
             </a:r>
           </a:p>
         </p:txBody>
@@ -9358,7 +9358,7 @@
                 </a:solidFill>
                 <a:latin typeface="DM Sans"/>
               </a:rPr>
-              <a:t>Notes: TF-IDF + NMF, 8 topics, 20K-description sample; themes named from each topic's top words. EDA notebook §8.</a:t>
+              <a:t>Notes: Water and sanitation stories fund in under 2 days; group farming waits ~2 weeks - themes track what the loan is FOR. EDA §8 printed means (TF-IDF + NMF, 8 topics, 20K sample).</a:t>
             </a:r>
           </a:p>
         </p:txBody>

</xml_diff>

<commit_message>
docs: two-presenter storyline scripts with stakeholder-mapped recommendations
Scripts rebuilt as a dialogue: Tuan carries the analyst arc (question,
method, scrutiny: S1-3, 6-7), Sophia the business arc (market,
recommendations, close: S4-5, 8-10), with spoken hand-offs and
marketing-audience framing (lender = customer, loan page = landing
page, test-before-you-ship). Slide 8 now names an owner per
recommendation - content team, growth team + field partners
(PS/YE/HN/NI), product team, data science - matching the panel's
practical-implications criterion; stakeholder map added to the S8
backup block. All verified numbers unchanged; per-slide alignment
asserted in the built deck (~9:30 total).

Co-Authored-By: Claude Fable 5 <noreply@anthropic.com>
</commit_message>
<xml_diff>
--- a/docs/presentation/slides_draft.pptx
+++ b/docs/presentation/slides_draft.pptx
@@ -516,7 +516,7 @@
           <a:lstStyle/>
           <a:p>
             <a:r>
-              <a:t>Good morning — we're Cultural Blend. Kiva is built on stories: every loan page leads with one. So we asked a simple question of 1.45 million real loans: does the story actually move the money?</a:t>
+              <a:t>(Tuan, ~20s) Good morning — we're Cultural Blend: I'm Tuan, and my teammate Sophia will take you through what this means for the business. Kiva is built on stories — every loan page leads with one, the way a landing page leads with copy. We asked 1.45 million real loans a single question: does the story actually move the money?</a:t>
             </a:r>
           </a:p>
           <a:p/>
@@ -592,7 +592,7 @@
           <a:lstStyle/>
           <a:p>
             <a:r>
-              <a:t>In this data, the story barely registers — the structure carries the signal. And testing hard enough to say, honestly, that there is no robust evidence for the story is worth more to a platform than a good-sounding tip. Thank you — we're happy to take questions.</a:t>
+              <a:t>(Both, ~20s) (Sophia) In this data, the story barely registers — the structure carries the signal. (Tuan) And testing hard enough to say, honestly, that there is no robust evidence for the story — that's worth more to a platform than a good-sounding tip. Thank you — we're happy to take your questions.</a:t>
             </a:r>
           </a:p>
           <a:p/>
@@ -1048,7 +1048,7 @@
           <a:lstStyle/>
           <a:p>
             <a:r>
-              <a:t>Specifically: when a borrower's story leans on family, on competence, on urgency — does the loan fund faster? And does the answer depend on who's asking, and when? We care because language is the one thing a platform can coach. You can't rewrite a loan's size, sector, or country after the fact — but you could suggest better words. IF words work. That's the claim we set out to test, not assume.</a:t>
+              <a:t>(Tuan, ~45s) Why should a marketing audience care? Because on Kiva, the lender is the customer and the loan page is the product page. Loan size, sector, geography — fixed at listing. The story is the one element a platform can coach, test, and optimise — classic conversion territory. So: when a story leans on family, competence, or urgency, does the loan fund faster? And does that depend on who's asking, and when? That's a testable claim — so we tested it, hard.</a:t>
             </a:r>
           </a:p>
           <a:p/>
@@ -1124,7 +1124,7 @@
           <a:lstStyle/>
           <a:p>
             <a:r>
-              <a:t>Two disciplines before any findings. For prediction, we train only on the past and test only on loans posted in 2024–25 — no peeking at the future. For the framing claims, every 'significant' result had to survive re-testing: first with standard errors clustered by country, so ten thousand loans from one country can't masquerade as ten thousand independent pieces of evidence — and where a result rested on just a couple of countries, a deliberately harsher few-cluster reference on top. Most headline-looking results did not survive. That's the point: we'd rather lose a finding than present a fluke.</a:t>
+              <a:t>(Tuan, ~60s) Two disciplines before any findings — because in a dataset this size it is dangerously easy to find things that aren't there. For prediction: train only on the past, score only on loans posted in 2024-25 — the models never see the future they're graded on. For the framing claims: every 'significant' result had to survive country-clustered standard errors — ten thousand loans from one country are not ten thousand independent customers — and where a result rested on just a couple of countries, an even harsher few-cluster screen on top. Most headline-looking results did not survive. Hold that thought while Sophia shows you what the market itself looks like.</a:t>
             </a:r>
           </a:p>
           <a:p/>
@@ -1200,7 +1200,7 @@
           <a:lstStyle/>
           <a:p>
             <a:r>
-              <a:t>Before the pandemic, almost half of Kiva loans — 46% — funded within 24 hours. Since 2020, it's been under a third — and through the end of our data in 2025 it has not recovered. That's more than half a million loans on each side of the divide, so this isn't noise. Every result we show next lives inside this slower, tighter marketplace — lenders are more selective now, which makes knowing what actually drives speed more valuable, not less.</a:t>
+              <a:t>(Sophia, ~60s) Thanks, Tuan. Start with the market, because every other number lives inside it. Before the pandemic, 46% of loans funded within 24 hours — nearly half converting same-day. Since 2020 it's been under a third — and through 2025, the 'recovery' is minus 0.3 points. With over half a million loans on each side of that divide, this isn't noise: it's a structurally slower, more selective marketplace. For a marketer that reframes the whole job — when customers get pickier, knowing what actually drives conversion matters more, not less.</a:t>
             </a:r>
           </a:p>
           <a:p/>
@@ -1276,7 +1276,7 @@
           <a:lstStyle/>
           <a:p>
             <a:r>
-              <a:t>So what does drive speed? Structure. Loan amount and repayment terms are associated with funding speed roughly ten times more strongly than any single narrative choice. Sector alone spans more than an order of magnitude. And the starkest gap in the data: loans posted by women fund in a median of 2.3 days; by men, 7.7 — more than three times longer. None of this is causal — but the pattern is enormous, it's stable, and it dwarfs anything the words do.</a:t>
+              <a:t>(Sophia, ~70s) And what drives it is structure. Loan amount and repayment terms correlate with funding speed roughly ten times more strongly than any narrative signal. Sector alone spans an order of magnitude — sanitation stories fund in under a day, clothing takes twelve. And the starkest gap in the data: loans posted by women fund in a median of 2.3 days, by men 7.7 — three times longer. None of this is causal, but it's enormous, it's stable, and it dwarfs anything the words do. Which brings us to the question we actually came here to answer. Tuan —</a:t>
             </a:r>
           </a:p>
           <a:p/>
@@ -1352,7 +1352,7 @@
           <a:lstStyle/>
           <a:p>
             <a:r>
-              <a:t>Now the question we came to answer — and the honest answer is that nothing about the narrative survives our own scrutiny. Urgency language looked like a clean, universal win: significant at p&lt;0.001. Cluster by country, and it collapses to p≈0.44. Gone. Family framing — here our own first version got it wrong: we tested whether regions differ from Africa, which is not the same as whether family framing helps WITHIN a region. Corrected, two pooled categories — Palestine+Yemen, and Honduras+Nicaragua — do show faster funding in every fit we ran. But each rests on exactly two countries, and against a deliberately harsh few-cluster screen — a t distribution with one degree of freedom, where the critical value is 12.7, not 1.96 — neither is significant: p between 0.06 and 0.21. So we report it as a hypothesis worth testing, not a finding. Sentiment tone: more positive language associates with SLOWER funding, but its significance flips between our two specifications — we call it open. We'd rather report no robust evidence than one exciting result we can't defend.</a:t>
+              <a:t>(Tuan, ~2min) So: does the story matter? Our honest answer is that nothing narrative survives our own scrutiny. Urgency language looked like a universal win — significant at p below 0.001. Cluster by country, and it collapses to 0.44. Gone. Family framing — and here our own first version got it wrong: we tested whether regions differ from Africa, which is not the same as whether family framing helps within a region. Corrected, two pooled categories — Palestine plus Yemen, and Honduras plus Nicaragua — do show faster funding in every fit we ran. But each rests on exactly two countries, and against a deliberately harsh few-cluster screen — a t distribution with one degree of freedom, where the critical value is 12.7, not 1.96 — neither is significant: p between 0.06 and 0.21. So we report a hypothesis worth testing, not a finding. Sentiment flips between our two specifications — genuinely open. We'd rather report no robust evidence than one exciting result we can't defend — because a recommendation you'd ship to real borrowers deserves that bar.</a:t>
             </a:r>
           </a:p>
           <a:p/>
@@ -1428,7 +1428,7 @@
           <a:lstStyle/>
           <a:p>
             <a:r>
-              <a:t>We also went beyond keyword counting. Topic modeling finds coherent themes in the stories — livestock, health and sanitation, clean water, farming, retail — and funding speed swings ninefold across them, from a day and a half to nearly two weeks. But notice what a topic mostly encodes: what the loan is FOR. Which is structure again — not persuasion.</a:t>
+              <a:t>(Tuan, ~45s) One more layer before the recommendations — we went past keyword counting. Topic modelling finds eight coherent story themes, and mean funding speed swings ninefold across them: sanitation and clean-water stories in under two days, group farming closer to two weeks. But notice what a theme mostly encodes: what the loan is FOR. Structure again — not persuasion. So what should Kiva actually do with all of this? Sophia —</a:t>
             </a:r>
           </a:p>
           <a:p/>
@@ -1504,7 +1504,7 @@
           <a:lstStyle/>
           <a:p>
             <a:r>
-              <a:t>So what should Kiva actually do? Three things. First — don't ship writing tips. A platform-wide 'add urgency' nudge would be built on a result that doesn't survive testing. The family-framing pattern deserves a country-stratified A/B test in exactly those four markets: that's how a hypothesis becomes a decision, and it's cheap to run. Second — the structural gaps are where the real levers are: review how the consistently slower sectors and regions are surfaced, bundled, and supported, because those gaps are ten times the size of any wording effect. Third — speed is predictable in retrospect: among loans that eventually funded, our classifier ranks same-day funding at AUC 0.90 on strictly future data, without any framing features. One honest boundary: expired or withdrawn listings never enter this data, so that is a ranking prototype among eventual funders — not yet an early-warning system. To build one, Kiva should pull all posted listings including expired and withdrawn outcomes, define the operational target, and retrain and validate on that population — before any pilot.</a:t>
+              <a:t>(Sophia, ~90s) Three moves — each with a clear owner. One: don't ship writing tips. For Kiva's content team that's a build spared; for borrowers, it's not being coached into copy that does nothing. Two: for the growth team and the field partners in exactly four markets — Palestine, Yemen, Honduras, Nicaragua — run the country-stratified A/B test: family-framing prompt versus standard at listing, outcome time-to-fund. That's how a hypothesis becomes a decision — and everyone in this room knows the discipline: test before you ship. Three: for the product team, the structural gaps are the real levers — how the consistently slower sectors and regions get surfaced, bundled, and supported — because those gaps are ten times any wording effect. And the classifier? A retrospective ranking prototype among funded loans — AUC 0.90 on strictly future data — for the data science team to develop toward an early-warning flag, after retraining on all listings including expired ones. The benefit flows to lenders through better discovery, and to borrowers through fewer stalled loans.</a:t>
             </a:r>
           </a:p>
           <a:p/>
@@ -1580,7 +1580,7 @@
           <a:lstStyle/>
           <a:p>
             <a:r>
-              <a:t>Three honest limits. This is association, never causation — no borrower was randomly assigned a writing style. We measure how fast funded loans fund — not whether a loan funds at all. And our framing measures are transparent, simple rules — they don't capture every nuance of persuasion. We'd rather you know exactly what this analysis can and cannot say — that's what makes the parts we do claim worth trusting.</a:t>
+              <a:t>(Sophia, ~40s) Three honest limits. Association, never causation — nobody randomly assigned writing styles. We measure how fast funded loans fund — not whether a loan funds at all. And our framing measures are transparent, simple rules — not every nuance of persuasion. We'd rather you know exactly what this can and cannot say — that's what makes the parts we do claim worth trusting.</a:t>
             </a:r>
           </a:p>
           <a:p/>

</xml_diff>

<commit_message>
docs: close Codex round 12 - evidence-safe scripts, honest timing, in-repo notes check
- S6 reopened evidence-safely (no narrative result robust enough across
  specifications; heuristic qualifier restored inline; sentiment as the
  cross-specification illustration); Fig-4 note drops 'significance bar'
- S8 stakeholder benefits made conditional (intended, to be tested)
- Timing relabelled honestly (~960 words, ~7.5 min at 130 wpm, labels
  with headroom ~9:10, finish-by-9:00 target); notes opener+[Sources]
  self-check now runs inside the generator on every build
- Page-9 header finding: does not reproduce against the committed PDF
  (rasterized + inspected); evidence in the log
- New scripts/export_deck_pdf.sh renders the deck to PDF via Keynote
  after each rebuild (PowerPoint signoff still stands)

Co-Authored-By: Claude Fable 5 <noreply@anthropic.com>
</commit_message>
<xml_diff>
--- a/docs/presentation/slides_draft.pptx
+++ b/docs/presentation/slides_draft.pptx
@@ -516,7 +516,7 @@
           <a:lstStyle/>
           <a:p>
             <a:r>
-              <a:t>(Tuan, ~20s) Good morning — we're Cultural Blend: I'm Tuan, and my teammate Sophia will take you through what this means for the business. Kiva is built on stories — every loan page leads with one, the way a landing page leads with copy. We asked 1.45 million real loans a single question: does the story actually move the money?</a:t>
+              <a:t>(Tuan, ~30s) Good morning — we're Cultural Blend: I'm Tuan, and my teammate Sophia will take you through what this means for the business. Kiva is built on stories — every loan page leads with one, the way a landing page leads with copy. We asked 1.45 million real loans a single question: does the story actually move the money?</a:t>
             </a:r>
           </a:p>
           <a:p/>
@@ -1048,7 +1048,7 @@
           <a:lstStyle/>
           <a:p>
             <a:r>
-              <a:t>(Tuan, ~45s) Why should a marketing audience care? Because on Kiva, the lender is the customer and the loan page is the product page. Loan size, sector, geography — fixed at listing. The story is the one element a platform can coach, test, and optimise — classic conversion territory. So: when a story leans on family, competence, or urgency, does the loan fund faster? And does that depend on who's asking, and when? That's a testable claim — so we tested it, hard.</a:t>
+              <a:t>(Tuan, ~50s) Why should a marketing audience care? Because on Kiva, the lender is the customer and the loan page is the product page. Loan size, sector, geography — fixed at listing. The story is the one element a platform can coach, test, and optimise — classic conversion territory. So: when a story leans on family, competence, or urgency, does the loan fund faster? And does that depend on who's asking, and when? That's a testable claim — so we tested it, hard.</a:t>
             </a:r>
           </a:p>
           <a:p/>
@@ -1124,7 +1124,7 @@
           <a:lstStyle/>
           <a:p>
             <a:r>
-              <a:t>(Tuan, ~60s) Two disciplines before any findings — because in a dataset this size it is dangerously easy to find things that aren't there. For prediction: train only on the past, score only on loans posted in 2024-25 — the models never see the future they're graded on. For the framing claims: every 'significant' result had to survive country-clustered standard errors — ten thousand loans from one country are not ten thousand independent customers — and where a result rested on just a couple of countries, an even harsher few-cluster screen on top. Most headline-looking results did not survive. Hold that thought while Sophia shows you what the market itself looks like.</a:t>
+              <a:t>(Tuan, ~65s) Two disciplines before any findings — because in a dataset this size it is dangerously easy to find things that aren't there. For prediction: train only on the past, score only on loans posted in 2024-25 — the models never see the future they're graded on. For the framing claims: every 'significant' result had to survive country-clustered standard errors — ten thousand loans from one country are not ten thousand independent customers — and where a result rested on just a couple of countries, an even harsher few-cluster screen on top. Most headline-looking results did not survive. Hold that thought while Sophia shows you what the market itself looks like.</a:t>
             </a:r>
           </a:p>
           <a:p/>
@@ -1276,7 +1276,7 @@
           <a:lstStyle/>
           <a:p>
             <a:r>
-              <a:t>(Sophia, ~70s) And what drives it is structure. Loan amount and repayment terms correlate with funding speed roughly ten times more strongly than any narrative signal. Sector alone spans an order of magnitude — sanitation stories fund in under a day, clothing takes twelve. And the starkest gap in the data: loans posted by women fund in a median of 2.3 days, by men 7.7 — three times longer. None of this is causal, but it's enormous, it's stable, and it dwarfs anything the words do. Which brings us to the question we actually came here to answer. Tuan —</a:t>
+              <a:t>(Sophia, ~65s) And what drives it is structure. Loan amount and repayment terms correlate with funding speed roughly ten times more strongly than any narrative signal. Sector alone spans an order of magnitude — sanitation stories fund in under a day, clothing takes twelve. And the starkest gap in the data: loans posted by women fund in a median of 2.3 days, by men 7.7 — three times longer. None of this is causal, but it's enormous, it's stable, and it dwarfs anything the words do. Which brings us to the question we actually came here to answer. Tuan —</a:t>
             </a:r>
           </a:p>
           <a:p/>
@@ -1352,7 +1352,7 @@
           <a:lstStyle/>
           <a:p>
             <a:r>
-              <a:t>(Tuan, ~2min) So: does the story matter? Our honest answer is that nothing narrative survives our own scrutiny. Urgency language looked like a universal win — significant at p below 0.001. Cluster by country, and it collapses to 0.44. Gone. Family framing — and here our own first version got it wrong: we tested whether regions differ from Africa, which is not the same as whether family framing helps within a region. Corrected, two pooled categories — Palestine plus Yemen, and Honduras plus Nicaragua — do show faster funding in every fit we ran. But each rests on exactly two countries, and against a deliberately harsh few-cluster screen — a t distribution with one degree of freedom, where the critical value is 12.7, not 1.96 — neither is significant: p between 0.06 and 0.21. So we report a hypothesis worth testing, not a finding. Sentiment flips between our two specifications — genuinely open. We'd rather report no robust evidence than one exciting result we can't defend — because a recommendation you'd ship to real borrowers deserves that bar.</a:t>
+              <a:t>(Tuan, ~1m50s) So: does the story matter? Our honest answer: no narrative result is robust enough across specifications to support a recommendation. Urgency language looked like a universal win — significant at p below 0.001. Cluster by country, and it collapses to 0.44. Gone. Family framing — and here our own first version got it wrong: we tested whether regions differ from Africa, which is not the same as whether family framing helps within a region. Corrected, two pooled categories — Palestine plus Yemen, and Honduras plus Nicaragua — do show faster funding in every fit we ran. But each rests on exactly two countries, and against a deliberately harsh few-cluster screen — a conservative heuristic, not calibrated inference: a t distribution with one degree of freedom, critical value 12.7, not 1.96 — neither is significant: p between 0.06 and 0.21. So we report a hypothesis worth testing, not a finding. Sentiment is the honest illustration: it survives country clustering in one of our two specifications and not the other — genuinely open, robust in neither direction. We'd rather report no robust evidence than one exciting result we can't defend — because a recommendation you'd ship to real borrowers deserves that bar.</a:t>
             </a:r>
           </a:p>
           <a:p/>
@@ -1428,7 +1428,7 @@
           <a:lstStyle/>
           <a:p>
             <a:r>
-              <a:t>(Tuan, ~45s) One more layer before the recommendations — we went past keyword counting. Topic modelling finds eight coherent story themes, and mean funding speed swings ninefold across them: sanitation and clean-water stories in under two days, group farming closer to two weeks. But notice what a theme mostly encodes: what the loan is FOR. Structure again — not persuasion. So what should Kiva actually do with all of this? Sophia —</a:t>
+              <a:t>(Tuan, ~40s) One more layer before the recommendations — we went past keyword counting. Topic modelling finds eight coherent story themes, and mean funding speed swings ninefold across them: sanitation and clean-water stories in under two days, group farming closer to two weeks. But notice what a theme mostly encodes: what the loan is FOR. Structure again — not persuasion. So what should Kiva actually do with all of this? Sophia —</a:t>
             </a:r>
           </a:p>
           <a:p/>
@@ -1504,7 +1504,7 @@
           <a:lstStyle/>
           <a:p>
             <a:r>
-              <a:t>(Sophia, ~90s) Three moves — each with a clear owner. One: don't ship writing tips. For Kiva's content team that's a build spared; for borrowers, it's not being coached into copy that does nothing. Two: for the growth team and the field partners in exactly four markets — Palestine, Yemen, Honduras, Nicaragua — run the country-stratified A/B test: family-framing prompt versus standard at listing, outcome time-to-fund. That's how a hypothesis becomes a decision — and everyone in this room knows the discipline: test before you ship. Three: for the product team, the structural gaps are the real levers — how the consistently slower sectors and regions get surfaced, bundled, and supported — because those gaps are ten times any wording effect. And the classifier? A retrospective ranking prototype among funded loans — AUC 0.90 on strictly future data — for the data science team to develop toward an early-warning flag, after retraining on all listings including expired ones. The benefit flows to lenders through better discovery, and to borrowers through fewer stalled loans.</a:t>
+              <a:t>(Sophia, ~85s) Three moves — each with a clear owner. One: don't ship writing tips. For Kiva's content team that's a build spared; for borrowers, it's not being coached into copy we found no robust evidence for. Two: for the growth team and the field partners in exactly four markets — Palestine, Yemen, Honduras, Nicaragua — run the country-stratified A/B test: family-framing prompt versus standard at listing, outcome time-to-fund. That's how a hypothesis becomes a decision — and everyone in this room knows the discipline: test before you ship. Three: for the product team, the structural gaps are the real levers — how the consistently slower sectors and regions get surfaced, bundled, and supported — because those gaps are ten times any wording effect. And the classifier? A retrospective ranking prototype among funded loans — AUC 0.90 on strictly future data — for the data science team to develop toward an early-warning flag, after retraining on all listings including expired ones. And the intended benefits — to be tested, not assumed: better discovery for lenders, fewer stalled loans for borrowers.</a:t>
             </a:r>
           </a:p>
           <a:p/>
@@ -1580,7 +1580,7 @@
           <a:lstStyle/>
           <a:p>
             <a:r>
-              <a:t>(Sophia, ~40s) Three honest limits. Association, never causation — nobody randomly assigned writing styles. We measure how fast funded loans fund — not whether a loan funds at all. And our framing measures are transparent, simple rules — not every nuance of persuasion. We'd rather you know exactly what this can and cannot say — that's what makes the parts we do claim worth trusting.</a:t>
+              <a:t>(Sophia, ~35s) Three honest limits. Association, never causation — nobody randomly assigned writing styles. We measure how fast funded loans fund — not whether a loan funds at all. And our framing measures are transparent, simple rules — not every nuance of persuasion. We'd rather you know exactly what this can and cannot say — that's what makes the parts we do claim worth trusting.</a:t>
             </a:r>
           </a:p>
           <a:p/>
@@ -8924,7 +8924,7 @@
                 </a:solidFill>
                 <a:latin typeface="DM Sans"/>
               </a:rPr>
-              <a:t>Notes: For a two-country region the significance bar is t(1) = 12.7, not 1.96 - nothing clears it. Typeset from executed §7.2 (v15); 4-dp values in analysis_summary.json.</a:t>
+              <a:t>Notes: Against the few-cluster screen - a conservative heuristic (t(1) critical value 12.7), able to downgrade a claim but never certify one - nothing clears it. Typeset from executed §7.2 (v15); 4-dp values in analysis_summary.json.</a:t>
             </a:r>
           </a:p>
         </p:txBody>

</xml_diff>

<commit_message>
docs: borrower-facing recommendation on Slide 8 + armed Q&A A4
The brief asks for strategies for borrowers AND platforms; S8 carried
only platform-owned moves. Adds a borrower/field-partner bullet and
script beat - plan for timing, not wording - with the explicit guardrail
that this is NOT advice to ask for less (our outcome is speed, not
whether the capital arrived). New Q&A A4 arms the matching hard question
(loan amount is the top SHAP feature: 0.446, r=0.429, deciles 2.14->18.56
days). Timing labels updated honestly (S8 ~1m50s, total ~9:45).

Co-Authored-By: Claude Fable 5 <noreply@anthropic.com>
</commit_message>
<xml_diff>
--- a/docs/presentation/slides_draft.pptx
+++ b/docs/presentation/slides_draft.pptx
@@ -1504,7 +1504,7 @@
           <a:lstStyle/>
           <a:p>
             <a:r>
-              <a:t>(Sophia, ~85s) Three moves — each with a clear owner. One: don't ship writing tips. For Kiva's content team that's a build spared; for borrowers, it's not being coached into copy we found no robust evidence for. Two: for the growth team and the field partners in exactly four markets — Palestine, Yemen, Honduras, Nicaragua — run the country-stratified A/B test: family-framing prompt versus standard at listing, outcome time-to-fund. That's how a hypothesis becomes a decision — and everyone in this room knows the discipline: test before you ship. Three: for the product team, the structural gaps are the real levers — how the consistently slower sectors and regions get surfaced, bundled, and supported — because those gaps are ten times any wording effect. And the classifier? A retrospective ranking prototype among funded loans — AUC 0.90 on strictly future data — for the data science team to develop toward an early-warning flag, after retraining on all listings including expired ones. And the intended benefits — to be tested, not assumed: better discovery for lenders, fewer stalled loans for borrowers.</a:t>
+              <a:t>(Sophia, ~1m50s) Three moves — each with a clear owner. One: don't ship writing tips. For Kiva's content team that's a build spared; for borrowers, it's not being coached into copy we found no robust evidence for. And for borrowers and field partners themselves, the honest advice is timing, not persuasion: a bigger ask fills more slowly — roughly two days for the smallest loans against nineteen for the largest — so post earlier when capital is needed by a date. That is not us telling anyone to ask for less: our outcome is speed, not whether they got the capital they needed. Two: for the growth team and the field partners in exactly four markets — Palestine, Yemen, Honduras, Nicaragua — run the country-stratified A/B test: family-framing prompt versus standard at listing, outcome time-to-fund. That's how a hypothesis becomes a decision — and everyone in this room knows the discipline: test before you ship. Three: for the product team, the structural gaps are the real levers — how the consistently slower sectors and regions get surfaced, bundled, and supported — because those gaps are ten times any wording effect. And the classifier? A retrospective ranking prototype among funded loans — AUC 0.90 on strictly future data — for the data science team to develop toward an early-warning flag, after retraining on all listings including expired ones. And the intended benefits — to be tested, not assumed: better discovery for lenders, fewer stalled loans for borrowers.</a:t>
             </a:r>
           </a:p>
           <a:p/>
@@ -9726,6 +9726,34 @@
                 <a:latin typeface="DM Sans"/>
               </a:rPr>
               <a:t>PROTOTYPE, then re-validate: the 24h classifier ranks well among eventually-funded loans (AUC ≈ 0.90, strictly future data) — but expired/withdrawn listings aren't in the data, so an early-warning flag first needs all posted listings, a defined target, and retraining on that population.</a:t>
+            </a:r>
+          </a:p>
+          <a:p>
+            <a:pPr>
+              <a:lnSpc>
+                <a:spcPct val="115000"/>
+              </a:lnSpc>
+              <a:spcAft>
+                <a:spcPts val="1200"/>
+              </a:spcAft>
+            </a:pPr>
+            <a:r>
+              <a:rPr sz="1600">
+                <a:solidFill>
+                  <a:srgbClr val="FFDD04"/>
+                </a:solidFill>
+                <a:latin typeface="DM Sans"/>
+              </a:rPr>
+              <a:t>▪  </a:t>
+            </a:r>
+            <a:r>
+              <a:rPr sz="1650">
+                <a:solidFill>
+                  <a:srgbClr val="1C2333"/>
+                </a:solidFill>
+                <a:latin typeface="DM Sans"/>
+              </a:rPr>
+              <a:t>FOR BORROWERS &amp; FIELD PARTNERS: don't optimise wording; plan for timing — a bigger ask fills more slowly (~2 days for the smallest decile vs ~19 for the largest). NOT a recommendation to ask for less: our outcome is speed, not whether the capital arrived.</a:t>
             </a:r>
           </a:p>
         </p:txBody>

</xml_diff>

<commit_message>
docs: presentation-day delivery upgrade - evidence grade sets the verb
The deck is submitted, so these are delivery/Q&A changes only:
- S8 script names each recommendation's evidence grade aloud (robust null
  -> firm don't; unconfirmed pattern -> experiment; association -> review
  not change; scope-limited model -> prototype not deployment), making
  the finding->recommendation chain audible without a slide change
- S7 labels its 9x topic swing descriptive, closing the tested-vs-
  untested inconsistency against S6
- Q&A C9 arms the expanded feature audit honestly (third-person voice
  survives FDR in the duration model, reverses in the 24h model, and
  plausibly tracks field-partner writing convention)
- Q&A gains a finding -> recommendation -> limitation traceability table
- Timing arithmetic corrected: ~1,120 words ~= 8:35 at 130 wpm

Co-Authored-By: Claude Fable 5 <noreply@anthropic.com>
</commit_message>
<xml_diff>
--- a/docs/presentation/slides_draft.pptx
+++ b/docs/presentation/slides_draft.pptx
@@ -1428,7 +1428,7 @@
           <a:lstStyle/>
           <a:p>
             <a:r>
-              <a:t>(Tuan, ~40s) One more layer before the recommendations — we went past keyword counting. Topic modelling finds eight coherent story themes, and mean funding speed swings ninefold across them: sanitation and clean-water stories in under two days, group farming closer to two weeks. But notice what a theme mostly encodes: what the loan is FOR. Structure again — not persuasion. So what should Kiva actually do with all of this? Sophia —</a:t>
+              <a:t>(Tuan, ~40s) One more layer before the recommendations — we went past keyword counting. Topic modelling finds eight coherent story themes, and mean funding speed swings ninefold across them — descriptively, not as a tested effect: sanitation and clean-water stories in under two days, group farming closer to two weeks. But notice what a theme mostly encodes: what the loan is FOR. Structure again — not persuasion. So what should Kiva actually do with all of this? Sophia —</a:t>
             </a:r>
           </a:p>
           <a:p/>
@@ -1504,7 +1504,7 @@
           <a:lstStyle/>
           <a:p>
             <a:r>
-              <a:t>(Sophia, ~1m50s) Three moves — each with a clear owner. One: don't ship writing tips. For Kiva's content team that's a build spared; for borrowers, it's not being coached into copy we found no robust evidence for. And for borrowers and field partners themselves, the honest advice is timing, not persuasion: a bigger ask fills more slowly — roughly two days for the smallest loans against nineteen for the largest — so post earlier when capital is needed by a date. That is not us telling anyone to ask for less: our outcome is speed, not whether they got the capital they needed. Two: for the growth team and the field partners in exactly four markets — Palestine, Yemen, Honduras, Nicaragua — run the country-stratified A/B test: family-framing prompt versus standard at listing, outcome time-to-fund. That's how a hypothesis becomes a decision — and everyone in this room knows the discipline: test before you ship. Three: for the product team, the structural gaps are the real levers — how the consistently slower sectors and regions get surfaced, bundled, and supported — because those gaps are ten times any wording effect. And the classifier? A retrospective ranking prototype among funded loans — AUC 0.90 on strictly future data — for the data science team to develop toward an early-warning flag, after retraining on all listings including expired ones. And the intended benefits — to be tested, not assumed: better discovery for lenders, fewer stalled loans for borrowers.</a:t>
+              <a:t>(Sophia, ~2m) Three moves for the platform, one for borrowers — and notice the verbs, because the evidence sets them. One: don't ship writing tips — a firm don't, because a robust null is the one thing we did find. For the content team that's a build spared; for borrowers, it's not being coached into copy we found no robust evidence for — and the honest advice to them is timing rather than persuasion: a bigger ask fills more slowly — two days for the smallest loans against nineteen for the largest — so post earlier when capital is needed by a date. That is not us telling anyone to ask for less: our outcome is speed, not whether they got the capital they needed. Two — an experiment, not an action, because there we have a pattern we could not confirm: for the growth team and the field partners in exactly four markets — Palestine, Yemen, Honduras, Nicaragua — run the country-stratified A/B test: family-framing prompt versus standard at listing. test before you ship. Three — review, not change, because these are associations and not causes: for the product team, the structural gaps are the real levers — how the consistently slower sectors and regions get surfaced and supported — because those gaps are ten times any wording effect. And the classifier stays a prototype, not a deployment — a retrospective ranking prototype among funded loans — AUC 0.90 on strictly future data — so data science retrains on all listings, including expired ones, first. And the intended benefits — to be tested, not assumed: better discovery for lenders, fewer stalled loans for borrowers.</a:t>
             </a:r>
           </a:p>
           <a:p/>

</xml_diff>

<commit_message>
docs: close the finding->recommendation chain in delivery (Scenario B)
Every finding now hands forward to an action in the spoken scripts:
- S4 (F1 market) -> 'why our recommendations start with acting rather
  than waiting for the market to fix itself'
- S7 (F4 topics) -> 'why the structural review should cover what loans
  are FOR, not just which sector they sit in' (rescues the orphan slide)
- S8 already states each recommendation's evidence grade inline
Benefits line moved off-script (it stays on the slide); labels and the
timing note corrected: ~1,150 words = 8:50 @130wpm / 8:12 @140wpm.

Co-Authored-By: Claude Fable 5 <noreply@anthropic.com>
</commit_message>
<xml_diff>
--- a/docs/presentation/slides_draft.pptx
+++ b/docs/presentation/slides_draft.pptx
@@ -1200,7 +1200,7 @@
           <a:lstStyle/>
           <a:p>
             <a:r>
-              <a:t>(Sophia, ~60s) Thanks, Tuan. Start with the market, because every other number lives inside it. Before the pandemic, 46% of loans funded within 24 hours — nearly half converting same-day. Since 2020 it's been under a third — and through 2025, the 'recovery' is minus 0.3 points. With over half a million loans on each side of that divide, this isn't noise: it's a structurally slower, more selective marketplace. For a marketer that reframes the whole job — when customers get pickier, knowing what actually drives conversion matters more, not less.</a:t>
+              <a:t>(Sophia, ~65s) Thanks, Tuan. Start with the market, because every other number lives inside it. Before the pandemic, 46% of loans funded within 24 hours — nearly half converting same-day. Since 2020 it's been under a third — and through 2025, the 'recovery' is minus 0.3 points. With over half a million loans on each side of that divide, this isn't noise: it's a structurally slower, more selective marketplace. For a marketer that reframes the whole job — when customers get pickier, knowing what actually drives conversion matters more, not less. Four years without a recovery is also why our recommendations start with acting rather than waiting for the market to fix itself.</a:t>
             </a:r>
           </a:p>
           <a:p/>
@@ -1428,7 +1428,7 @@
           <a:lstStyle/>
           <a:p>
             <a:r>
-              <a:t>(Tuan, ~40s) One more layer before the recommendations — we went past keyword counting. Topic modelling finds eight coherent story themes, and mean funding speed swings ninefold across them — descriptively, not as a tested effect: sanitation and clean-water stories in under two days, group farming closer to two weeks. But notice what a theme mostly encodes: what the loan is FOR. Structure again — not persuasion. So what should Kiva actually do with all of this? Sophia —</a:t>
+              <a:t>(Tuan, ~50s) One more layer before the recommendations — we went past keyword counting. Topic modelling finds eight coherent story themes, and mean funding speed swings ninefold across them — descriptively, not as a tested effect: sanitation and clean-water stories in under two days, group farming closer to two weeks. But notice what a theme mostly encodes: what the loan is FOR. Structure again — not persuasion — and it's why the structural review we're about to recommend should cover what loans are FOR, not just which sector they sit in. So what should Kiva actually do with all of this? Sophia —</a:t>
             </a:r>
           </a:p>
           <a:p/>
@@ -1504,7 +1504,7 @@
           <a:lstStyle/>
           <a:p>
             <a:r>
-              <a:t>(Sophia, ~2m) Three moves for the platform, one for borrowers — and notice the verbs, because the evidence sets them. One: don't ship writing tips — a firm don't, because a robust null is the one thing we did find. For the content team that's a build spared; for borrowers, it's not being coached into copy we found no robust evidence for — and the honest advice to them is timing rather than persuasion: a bigger ask fills more slowly — two days for the smallest loans against nineteen for the largest — so post earlier when capital is needed by a date. That is not us telling anyone to ask for less: our outcome is speed, not whether they got the capital they needed. Two — an experiment, not an action, because there we have a pattern we could not confirm: for the growth team and the field partners in exactly four markets — Palestine, Yemen, Honduras, Nicaragua — run the country-stratified A/B test: family-framing prompt versus standard at listing. test before you ship. Three — review, not change, because these are associations and not causes: for the product team, the structural gaps are the real levers — how the consistently slower sectors and regions get surfaced and supported — because those gaps are ten times any wording effect. And the classifier stays a prototype, not a deployment — a retrospective ranking prototype among funded loans — AUC 0.90 on strictly future data — so data science retrains on all listings, including expired ones, first. And the intended benefits — to be tested, not assumed: better discovery for lenders, fewer stalled loans for borrowers.</a:t>
+              <a:t>(Sophia, ~2m) Three moves for the platform, one for borrowers — and notice the verbs, because the evidence sets them. One: don't ship writing tips — a firm don't, because a robust null is the one thing we did find. For the content team that's a build spared; for borrowers, it's not being coached into copy we found no robust evidence for — and the honest advice to them is timing rather than persuasion: a bigger ask fills more slowly — two days for the smallest loans against nineteen for the largest — so post earlier when capital is needed by a date. That is not us telling anyone to ask for less: our outcome is speed, not whether they got the capital they needed. Two — an experiment, not an action, because there we have a pattern we could not confirm: for the growth team and the field partners in exactly four markets — Palestine, Yemen, Honduras, Nicaragua — run the country-stratified A/B test: family-framing prompt versus standard at listing. test before you ship. Three — review, not change, because these are associations and not causes: for the product team, the structural gaps are the real levers — how the consistently slower sectors and regions get surfaced and supported — because those gaps are ten times any wording effect. And the classifier stays a prototype, not a deployment — a retrospective ranking prototype among funded loans — AUC 0.90 on strictly future data — so data science retrains on all listings, including expired ones, first. </a:t>
             </a:r>
           </a:p>
           <a:p/>

</xml_diff>

<commit_message>
fix: funding speed is the partner's capital cycle, not the borrower's wait
Verified from the raw data: 96.4% of loans are disbursed to the borrower
BEFORE fundraising opens (median 24.2 days earlier, 1,453,840 valid rows).
The borrower timing advice added earlier today ('post earlier when capital
is needed by a date') was therefore wrong for 96% of loans - the borrower
already holds the capital when lenders see the page.

- S8 bullet + script reframed: timing is a FIELD-PARTNER capital-cycle
  matter; a slow loan ties up capital that would fund the next borrower
- Q&A A4 corrected to the same framing
- New Q&A D6 arms the pre-disbursal question directly
- Future work now names whySpecial as a programme/partner proxy (643
  distinct values, 92% inside a single country) - the finer cluster level
  we said we lacked; country-clustering remains the conservative choice
  because those groups nest within countries

Co-Authored-By: Claude Fable 5 <noreply@anthropic.com>
</commit_message>
<xml_diff>
--- a/docs/presentation/slides_draft.pptx
+++ b/docs/presentation/slides_draft.pptx
@@ -1504,7 +1504,7 @@
           <a:lstStyle/>
           <a:p>
             <a:r>
-              <a:t>(Sophia, ~2m) Three moves for the platform, one for borrowers — and notice the verbs, because the evidence sets them. One: don't ship writing tips — a firm don't, because a robust null is the one thing we did find. For the content team that's a build spared; for borrowers, it's not being coached into copy we found no robust evidence for — and the honest advice to them is timing rather than persuasion: a bigger ask fills more slowly — two days for the smallest loans against nineteen for the largest — so post earlier when capital is needed by a date. That is not us telling anyone to ask for less: our outcome is speed, not whether they got the capital they needed. Two — an experiment, not an action, because there we have a pattern we could not confirm: for the growth team and the field partners in exactly four markets — Palestine, Yemen, Honduras, Nicaragua — run the country-stratified A/B test: family-framing prompt versus standard at listing. test before you ship. Three — review, not change, because these are associations and not causes: for the product team, the structural gaps are the real levers — how the consistently slower sectors and regions get surfaced and supported — because those gaps are ten times any wording effect. And the classifier stays a prototype, not a deployment — a retrospective ranking prototype among funded loans — AUC 0.90 on strictly future data — so data science retrains on all listings, including expired ones, first. </a:t>
+              <a:t>(Sophia, ~2m) Three moves for the platform, one for borrowers — and notice the verbs, because the evidence sets them. One: don't ship writing tips — a firm don't, because a robust null is the one thing we did find. For the content team that's a build spared; for borrowers, it's not being coached into copy we found no robust evidence for — and the timing advice belongs to field partners, not borrowers: a bigger ask sits on the platform longer — two days for the smallest loans against nineteen for the largest — and since 96% of loans in this data are already disbursed before the page even goes live, that is a partner capital-cycle fact, not a borrower's waiting time. Which is also why we are not telling anyone to ask for less. Two — an experiment, not an action, because there we have a pattern we could not confirm: for the growth team and the field partners in exactly four markets — Palestine, Yemen, Honduras, Nicaragua — run the country-stratified A/B test: family-framing prompt versus standard at listing. test before you ship. Three — review, not change, because these are associations and not causes: for the product team, the structural gaps are the real levers — how the consistently slower sectors and regions get surfaced and supported — because those gaps are ten times any wording effect. And the classifier stays a prototype, not a deployment — a retrospective ranking prototype among funded loans — AUC 0.90 on strictly future data — so data science retrains on all listings, including expired ones, first. </a:t>
             </a:r>
           </a:p>
           <a:p/>
@@ -9753,7 +9753,7 @@
                 </a:solidFill>
                 <a:latin typeface="DM Sans"/>
               </a:rPr>
-              <a:t>FOR BORROWERS &amp; FIELD PARTNERS: don't optimise wording; plan for timing — a bigger ask fills more slowly (~2 days for the smallest decile vs ~19 for the largest). NOT a recommendation to ask for less: our outcome is speed, not whether the capital arrived.</a:t>
+              <a:t>FOR FIELD PARTNERS (and borrowers): don't optimise wording — no robust evidence it pays. Timing is a partner capital-cycle matter, not a borrower wait: 96% of loans are already disbursed before the page goes live (median 24 days), and a bigger ask sits on the platform longer (~2 vs ~19 days). Still NOT a recommendation to ask for less.</a:t>
             </a:r>
           </a:p>
         </p:txBody>

</xml_diff>